<commit_message>
Kontextdiagramm v2: Layout ohne Kreuzungen (waagerechte Verbindungen, Elbow unten)
Co-Authored-By: Claude Fable 5.1 <noreply@anthropic.com>
</commit_message>
<xml_diff>
--- a/Kontextdiagramm_ThesisFlow_v2.pptx
+++ b/Kontextdiagramm_ThesisFlow_v2.pptx
@@ -886,8 +886,8 @@
         </p:nvSpPr>
         <p:spPr>
           <a:xfrm>
-            <a:off x="457200" y="201168"/>
-            <a:ext cx="7315200" cy="457200"/>
+            <a:off x="457200" y="182880"/>
+            <a:ext cx="7315200" cy="438912"/>
           </a:xfrm>
           <a:prstGeom prst="rect">
             <a:avLst/>
@@ -925,7 +925,7 @@
         </p:nvSpPr>
         <p:spPr>
           <a:xfrm>
-            <a:off x="457200" y="640080"/>
+            <a:off x="457200" y="603504"/>
             <a:ext cx="8229600" cy="228600"/>
           </a:xfrm>
           <a:prstGeom prst="rect">
@@ -964,7 +964,7 @@
         </p:nvSpPr>
         <p:spPr>
           <a:xfrm>
-            <a:off x="8046720" y="274320"/>
+            <a:off x="8046720" y="256032"/>
             <a:ext cx="3703320" cy="274320"/>
           </a:xfrm>
           <a:prstGeom prst="rect">
@@ -1003,12 +1003,12 @@
         </p:nvSpPr>
         <p:spPr>
           <a:xfrm>
-            <a:off x="457200" y="960120"/>
-            <a:ext cx="9281160" cy="5166360"/>
+            <a:off x="457200" y="914400"/>
+            <a:ext cx="9692640" cy="5257800"/>
           </a:xfrm>
           <a:prstGeom prst="roundRect">
             <a:avLst>
-              <a:gd name="adj" fmla="val 3540"/>
+              <a:gd name="adj" fmla="val 3478"/>
             </a:avLst>
           </a:prstGeom>
           <a:solidFill>
@@ -1030,7 +1030,7 @@
         </p:nvSpPr>
         <p:spPr>
           <a:xfrm>
-            <a:off x="640080" y="1033272"/>
+            <a:off x="640080" y="978408"/>
             <a:ext cx="2743200" cy="201168"/>
           </a:xfrm>
           <a:prstGeom prst="rect">
@@ -1069,12 +1069,12 @@
         </p:nvSpPr>
         <p:spPr>
           <a:xfrm>
-            <a:off x="4206240" y="2788920"/>
-            <a:ext cx="1828800" cy="1188720"/>
+            <a:off x="4480560" y="1188720"/>
+            <a:ext cx="1828800" cy="3429000"/>
           </a:xfrm>
           <a:prstGeom prst="roundRect">
             <a:avLst>
-              <a:gd name="adj" fmla="val 9231"/>
+              <a:gd name="adj" fmla="val 6000"/>
             </a:avLst>
           </a:prstGeom>
           <a:solidFill>
@@ -1103,8 +1103,8 @@
         </p:nvSpPr>
         <p:spPr>
           <a:xfrm>
-            <a:off x="4206240" y="2788920"/>
-            <a:ext cx="1828800" cy="1188720"/>
+            <a:off x="4572000" y="1188720"/>
+            <a:ext cx="1645920" cy="3429000"/>
           </a:xfrm>
           <a:prstGeom prst="rect">
             <a:avLst/>
@@ -1113,14 +1113,14 @@
           <a:ln/>
         </p:spPr>
         <p:txBody>
-          <a:bodyPr wrap="square" lIns="635" tIns="635" rIns="635" bIns="635" rtlCol="0" anchor="ctr"/>
+          <a:bodyPr wrap="square" lIns="0" tIns="0" rIns="0" bIns="0" rtlCol="0" anchor="ctr"/>
           <a:lstStyle/>
           <a:p>
             <a:pPr algn="ctr" indent="0" marL="0">
               <a:buNone/>
             </a:pPr>
             <a:r>
-              <a:rPr lang="en-US" sz="1800" b="1" dirty="0">
+              <a:rPr lang="en-US" sz="2000" b="1" dirty="0">
                 <a:solidFill>
                   <a:srgbClr val="FFFFFF"/>
                 </a:solidFill>
@@ -1130,14 +1130,14 @@
               </a:rPr>
               <a:t>ThesisFlow</a:t>
             </a:r>
-            <a:endParaRPr lang="en-US" sz="1800" dirty="0"/>
+            <a:endParaRPr lang="en-US" sz="2000" dirty="0"/>
           </a:p>
           <a:p>
             <a:pPr algn="ctr" indent="0" marL="0">
               <a:buNone/>
             </a:pPr>
             <a:r>
-              <a:rPr lang="en-US" sz="850" dirty="0">
+              <a:rPr lang="en-US" sz="900" dirty="0">
                 <a:solidFill>
                   <a:srgbClr val="D9E6CF"/>
                 </a:solidFill>
@@ -1145,33 +1145,30 @@
                 <a:ea typeface="Calibri" pitchFamily="34" charset="-122"/>
                 <a:cs typeface="Calibri" pitchFamily="34" charset="-120"/>
               </a:rPr>
-              <a:t>Portal für Anmeldung, Freigabe,</a:t>
-            </a:r>
-            <a:endParaRPr lang="en-US" sz="1800" dirty="0"/>
+              <a:t>Portal für Anmeldung, Freigabe, Ausgabe und Verlängerung von Abschlussarbeiten</a:t>
+            </a:r>
+            <a:endParaRPr lang="en-US" sz="2000" dirty="0"/>
           </a:p>
           <a:p>
             <a:pPr algn="ctr" indent="0" marL="0">
               <a:buNone/>
             </a:pPr>
             <a:r>
-              <a:rPr lang="en-US" sz="850" dirty="0">
-                <a:solidFill>
-                  <a:srgbClr val="D9E6CF"/>
-                </a:solidFill>
-                <a:latin typeface="Calibri" pitchFamily="34" charset="0"/>
-                <a:ea typeface="Calibri" pitchFamily="34" charset="-122"/>
-                <a:cs typeface="Calibri" pitchFamily="34" charset="-120"/>
-              </a:rPr>
-              <a:t>Ausgabe und Verlängerung</a:t>
-            </a:r>
-            <a:endParaRPr lang="en-US" sz="1800" dirty="0"/>
+              <a:rPr lang="en-US" sz="600" dirty="0">
+                <a:solidFill>
+                  <a:srgbClr val="000000"/>
+                </a:solidFill>
+              </a:rPr>
+              <a:t> </a:t>
+            </a:r>
+            <a:endParaRPr lang="en-US" sz="2000" dirty="0"/>
           </a:p>
           <a:p>
             <a:pPr algn="ctr" indent="0" marL="0">
               <a:buNone/>
             </a:pPr>
             <a:r>
-              <a:rPr lang="en-US" sz="750" i="1" dirty="0">
+              <a:rPr lang="en-US" sz="800" i="1" dirty="0">
                 <a:solidFill>
                   <a:srgbClr val="97BC62"/>
                 </a:solidFill>
@@ -1181,7 +1178,7 @@
               </a:rPr>
               <a:t>Systemgrenze</a:t>
             </a:r>
-            <a:endParaRPr lang="en-US" sz="1800" dirty="0"/>
+            <a:endParaRPr lang="en-US" sz="2000" dirty="0"/>
           </a:p>
         </p:txBody>
       </p:sp>
@@ -1193,7 +1190,7 @@
         </p:nvSpPr>
         <p:spPr>
           <a:xfrm>
-            <a:off x="731520" y="1234440"/>
+            <a:off x="731520" y="1325880"/>
             <a:ext cx="1737360" cy="502920"/>
           </a:xfrm>
           <a:prstGeom prst="roundRect">
@@ -1220,7 +1217,7 @@
         </p:nvSpPr>
         <p:spPr>
           <a:xfrm>
-            <a:off x="731520" y="1234440"/>
+            <a:off x="731520" y="1325880"/>
             <a:ext cx="1737360" cy="502920"/>
           </a:xfrm>
           <a:prstGeom prst="rect">
@@ -1276,8 +1273,8 @@
         </p:nvSpPr>
         <p:spPr>
           <a:xfrm>
-            <a:off x="2468880" y="1431036"/>
-            <a:ext cx="1737360" cy="1449324"/>
+            <a:off x="2468880" y="1513332"/>
+            <a:ext cx="2011680" cy="914"/>
           </a:xfrm>
           <a:prstGeom prst="line">
             <a:avLst/>
@@ -1300,8 +1297,8 @@
         </p:nvSpPr>
         <p:spPr>
           <a:xfrm>
-            <a:off x="2468880" y="1540764"/>
-            <a:ext cx="1737360" cy="1431036"/>
+            <a:off x="2468880" y="1641348"/>
+            <a:ext cx="2011680" cy="914"/>
           </a:xfrm>
           <a:prstGeom prst="line">
             <a:avLst/>
@@ -1324,8 +1321,8 @@
         </p:nvSpPr>
         <p:spPr>
           <a:xfrm>
-            <a:off x="2606040" y="1995678"/>
-            <a:ext cx="1463040" cy="420624"/>
+            <a:off x="2606040" y="1348740"/>
+            <a:ext cx="1737360" cy="457200"/>
           </a:xfrm>
           <a:prstGeom prst="rect">
             <a:avLst/>
@@ -1340,7 +1337,7 @@
           </a:ln>
         </p:spPr>
         <p:txBody>
-          <a:bodyPr wrap="square" lIns="381" tIns="381" rIns="381" bIns="381" rtlCol="0" anchor="ctr"/>
+          <a:bodyPr wrap="square" lIns="508" tIns="508" rIns="508" bIns="508" rtlCol="0" anchor="ctr"/>
           <a:lstStyle/>
           <a:p>
             <a:pPr indent="0" marL="0">
@@ -1392,7 +1389,7 @@
         </p:nvSpPr>
         <p:spPr>
           <a:xfrm>
-            <a:off x="731520" y="2286000"/>
+            <a:off x="731520" y="2011680"/>
             <a:ext cx="1737360" cy="502920"/>
           </a:xfrm>
           <a:prstGeom prst="roundRect">
@@ -1419,7 +1416,7 @@
         </p:nvSpPr>
         <p:spPr>
           <a:xfrm>
-            <a:off x="731520" y="2286000"/>
+            <a:off x="731520" y="2011680"/>
             <a:ext cx="1737360" cy="502920"/>
           </a:xfrm>
           <a:prstGeom prst="rect">
@@ -1475,8 +1472,8 @@
         </p:nvSpPr>
         <p:spPr>
           <a:xfrm>
-            <a:off x="2468880" y="2482596"/>
-            <a:ext cx="1737360" cy="717804"/>
+            <a:off x="2468880" y="2199132"/>
+            <a:ext cx="2011680" cy="914"/>
           </a:xfrm>
           <a:prstGeom prst="line">
             <a:avLst/>
@@ -1499,8 +1496,8 @@
         </p:nvSpPr>
         <p:spPr>
           <a:xfrm>
-            <a:off x="2468880" y="2592324"/>
-            <a:ext cx="1737360" cy="699516"/>
+            <a:off x="2468880" y="2327148"/>
+            <a:ext cx="2011680" cy="914"/>
           </a:xfrm>
           <a:prstGeom prst="line">
             <a:avLst/>
@@ -1523,8 +1520,8 @@
         </p:nvSpPr>
         <p:spPr>
           <a:xfrm>
-            <a:off x="2606040" y="2681478"/>
-            <a:ext cx="1463040" cy="420624"/>
+            <a:off x="2606040" y="2034540"/>
+            <a:ext cx="1737360" cy="457200"/>
           </a:xfrm>
           <a:prstGeom prst="rect">
             <a:avLst/>
@@ -1539,7 +1536,7 @@
           </a:ln>
         </p:spPr>
         <p:txBody>
-          <a:bodyPr wrap="square" lIns="381" tIns="381" rIns="381" bIns="381" rtlCol="0" anchor="ctr"/>
+          <a:bodyPr wrap="square" lIns="508" tIns="508" rIns="508" bIns="508" rtlCol="0" anchor="ctr"/>
           <a:lstStyle/>
           <a:p>
             <a:pPr indent="0" marL="0">
@@ -1591,7 +1588,7 @@
         </p:nvSpPr>
         <p:spPr>
           <a:xfrm>
-            <a:off x="731520" y="3337560"/>
+            <a:off x="731520" y="2697480"/>
             <a:ext cx="1737360" cy="502920"/>
           </a:xfrm>
           <a:prstGeom prst="roundRect">
@@ -1618,7 +1615,7 @@
         </p:nvSpPr>
         <p:spPr>
           <a:xfrm>
-            <a:off x="731520" y="3337560"/>
+            <a:off x="731520" y="2697480"/>
             <a:ext cx="1737360" cy="502920"/>
           </a:xfrm>
           <a:prstGeom prst="rect">
@@ -1673,9 +1670,9 @@
           <p:nvPr/>
         </p:nvSpPr>
         <p:spPr>
-          <a:xfrm flipV="1">
-            <a:off x="2468880" y="3520440"/>
-            <a:ext cx="1737360" cy="13716"/>
+          <a:xfrm>
+            <a:off x="2468880" y="2884932"/>
+            <a:ext cx="2011680" cy="914"/>
           </a:xfrm>
           <a:prstGeom prst="line">
             <a:avLst/>
@@ -1697,9 +1694,9 @@
           <p:nvPr/>
         </p:nvSpPr>
         <p:spPr>
-          <a:xfrm flipV="1">
-            <a:off x="2468880" y="3611880"/>
-            <a:ext cx="1737360" cy="32004"/>
+          <a:xfrm>
+            <a:off x="2468880" y="3012948"/>
+            <a:ext cx="2011680" cy="914"/>
           </a:xfrm>
           <a:prstGeom prst="line">
             <a:avLst/>
@@ -1722,8 +1719,8 @@
         </p:nvSpPr>
         <p:spPr>
           <a:xfrm>
-            <a:off x="2606040" y="3367278"/>
-            <a:ext cx="1463040" cy="420624"/>
+            <a:off x="2606040" y="2720340"/>
+            <a:ext cx="1737360" cy="457200"/>
           </a:xfrm>
           <a:prstGeom prst="rect">
             <a:avLst/>
@@ -1738,7 +1735,7 @@
           </a:ln>
         </p:spPr>
         <p:txBody>
-          <a:bodyPr wrap="square" lIns="381" tIns="381" rIns="381" bIns="381" rtlCol="0" anchor="ctr"/>
+          <a:bodyPr wrap="square" lIns="508" tIns="508" rIns="508" bIns="508" rtlCol="0" anchor="ctr"/>
           <a:lstStyle/>
           <a:p>
             <a:pPr indent="0" marL="0">
@@ -1790,7 +1787,7 @@
         </p:nvSpPr>
         <p:spPr>
           <a:xfrm>
-            <a:off x="731520" y="4389120"/>
+            <a:off x="731520" y="3383280"/>
             <a:ext cx="1737360" cy="502920"/>
           </a:xfrm>
           <a:prstGeom prst="roundRect">
@@ -1817,7 +1814,7 @@
         </p:nvSpPr>
         <p:spPr>
           <a:xfrm>
-            <a:off x="731520" y="4389120"/>
+            <a:off x="731520" y="3383280"/>
             <a:ext cx="1737360" cy="502920"/>
           </a:xfrm>
           <a:prstGeom prst="rect">
@@ -1872,9 +1869,9 @@
           <p:nvPr/>
         </p:nvSpPr>
         <p:spPr>
-          <a:xfrm flipV="1">
-            <a:off x="2468880" y="3840480"/>
-            <a:ext cx="1737360" cy="745236"/>
+          <a:xfrm>
+            <a:off x="2468880" y="3570732"/>
+            <a:ext cx="2011680" cy="914"/>
           </a:xfrm>
           <a:prstGeom prst="line">
             <a:avLst/>
@@ -1896,9 +1893,9 @@
           <p:nvPr/>
         </p:nvSpPr>
         <p:spPr>
-          <a:xfrm flipV="1">
-            <a:off x="2468880" y="3931920"/>
-            <a:ext cx="1737360" cy="763524"/>
+          <a:xfrm>
+            <a:off x="2468880" y="3698748"/>
+            <a:ext cx="2011680" cy="914"/>
           </a:xfrm>
           <a:prstGeom prst="line">
             <a:avLst/>
@@ -1921,8 +1918,8 @@
         </p:nvSpPr>
         <p:spPr>
           <a:xfrm>
-            <a:off x="2606040" y="4053078"/>
-            <a:ext cx="1463040" cy="420624"/>
+            <a:off x="2606040" y="3406140"/>
+            <a:ext cx="1737360" cy="457200"/>
           </a:xfrm>
           <a:prstGeom prst="rect">
             <a:avLst/>
@@ -1937,7 +1934,7 @@
           </a:ln>
         </p:spPr>
         <p:txBody>
-          <a:bodyPr wrap="square" lIns="381" tIns="381" rIns="381" bIns="381" rtlCol="0" anchor="ctr"/>
+          <a:bodyPr wrap="square" lIns="508" tIns="508" rIns="508" bIns="508" rtlCol="0" anchor="ctr"/>
           <a:lstStyle/>
           <a:p>
             <a:pPr indent="0" marL="0">
@@ -1989,7 +1986,7 @@
         </p:nvSpPr>
         <p:spPr>
           <a:xfrm>
-            <a:off x="7726680" y="1234440"/>
+            <a:off x="731520" y="4069080"/>
             <a:ext cx="1737360" cy="502920"/>
           </a:xfrm>
           <a:prstGeom prst="roundRect">
@@ -2016,7 +2013,7 @@
         </p:nvSpPr>
         <p:spPr>
           <a:xfrm>
-            <a:off x="7726680" y="1234440"/>
+            <a:off x="731520" y="4069080"/>
             <a:ext cx="1737360" cy="502920"/>
           </a:xfrm>
           <a:prstGeom prst="rect">
@@ -2071,9 +2068,9 @@
           <p:nvPr/>
         </p:nvSpPr>
         <p:spPr>
-          <a:xfrm flipV="1">
-            <a:off x="6035040" y="1431036"/>
-            <a:ext cx="1691640" cy="1449324"/>
+          <a:xfrm>
+            <a:off x="2468880" y="4256532"/>
+            <a:ext cx="2011680" cy="914"/>
           </a:xfrm>
           <a:prstGeom prst="line">
             <a:avLst/>
@@ -2082,6 +2079,30 @@
           <a:ln w="15875">
             <a:solidFill>
               <a:srgbClr val="2C5F2D"/>
+            </a:solidFill>
+            <a:prstDash val="solid"/>
+            <a:tailEnd type="triangle"/>
+          </a:ln>
+        </p:spPr>
+      </p:sp>
+      <p:sp>
+        <p:nvSpPr>
+          <p:cNvPr id="32" name="Shape 30"/>
+          <p:cNvSpPr/>
+          <p:nvPr/>
+        </p:nvSpPr>
+        <p:spPr>
+          <a:xfrm>
+            <a:off x="2468880" y="4384548"/>
+            <a:ext cx="2011680" cy="914"/>
+          </a:xfrm>
+          <a:prstGeom prst="line">
+            <a:avLst/>
+          </a:prstGeom>
+          <a:noFill/>
+          <a:ln w="15875">
+            <a:solidFill>
+              <a:srgbClr val="4A7FB5"/>
             </a:solidFill>
             <a:prstDash val="solid"/>
             <a:headEnd type="triangle"/>
@@ -2090,38 +2111,14 @@
       </p:sp>
       <p:sp>
         <p:nvSpPr>
-          <p:cNvPr id="32" name="Shape 30"/>
-          <p:cNvSpPr/>
-          <p:nvPr/>
-        </p:nvSpPr>
-        <p:spPr>
-          <a:xfrm flipV="1">
-            <a:off x="6035040" y="1540764"/>
-            <a:ext cx="1691640" cy="1431036"/>
-          </a:xfrm>
-          <a:prstGeom prst="line">
-            <a:avLst/>
-          </a:prstGeom>
-          <a:noFill/>
-          <a:ln w="15875">
-            <a:solidFill>
-              <a:srgbClr val="4A7FB5"/>
-            </a:solidFill>
-            <a:prstDash val="solid"/>
-            <a:tailEnd type="triangle"/>
-          </a:ln>
-        </p:spPr>
-      </p:sp>
-      <p:sp>
-        <p:nvSpPr>
           <p:cNvPr id="33" name="Text 31"/>
           <p:cNvSpPr txBox="1"/>
           <p:nvPr/>
         </p:nvSpPr>
         <p:spPr>
           <a:xfrm>
-            <a:off x="6172200" y="1995678"/>
-            <a:ext cx="1463040" cy="420624"/>
+            <a:off x="2606040" y="4091940"/>
+            <a:ext cx="1737360" cy="457200"/>
           </a:xfrm>
           <a:prstGeom prst="rect">
             <a:avLst/>
@@ -2136,7 +2133,7 @@
           </a:ln>
         </p:spPr>
         <p:txBody>
-          <a:bodyPr wrap="square" lIns="381" tIns="381" rIns="381" bIns="381" rtlCol="0" anchor="ctr"/>
+          <a:bodyPr wrap="square" lIns="508" tIns="508" rIns="508" bIns="508" rtlCol="0" anchor="ctr"/>
           <a:lstStyle/>
           <a:p>
             <a:pPr indent="0" marL="0">
@@ -2188,7 +2185,7 @@
         </p:nvSpPr>
         <p:spPr>
           <a:xfrm>
-            <a:off x="7726680" y="2286000"/>
+            <a:off x="8321040" y="1645920"/>
             <a:ext cx="1737360" cy="502920"/>
           </a:xfrm>
           <a:prstGeom prst="roundRect">
@@ -2215,7 +2212,7 @@
         </p:nvSpPr>
         <p:spPr>
           <a:xfrm>
-            <a:off x="7726680" y="2286000"/>
+            <a:off x="8321040" y="1645920"/>
             <a:ext cx="1737360" cy="502920"/>
           </a:xfrm>
           <a:prstGeom prst="rect">
@@ -2270,9 +2267,9 @@
           <p:nvPr/>
         </p:nvSpPr>
         <p:spPr>
-          <a:xfrm flipV="1">
-            <a:off x="6035040" y="2482596"/>
-            <a:ext cx="1691640" cy="717804"/>
+          <a:xfrm>
+            <a:off x="6309360" y="1833372"/>
+            <a:ext cx="2011680" cy="914"/>
           </a:xfrm>
           <a:prstGeom prst="line">
             <a:avLst/>
@@ -2294,9 +2291,9 @@
           <p:nvPr/>
         </p:nvSpPr>
         <p:spPr>
-          <a:xfrm flipV="1">
-            <a:off x="6035040" y="2592324"/>
-            <a:ext cx="1691640" cy="699516"/>
+          <a:xfrm>
+            <a:off x="6309360" y="1961388"/>
+            <a:ext cx="2011680" cy="914"/>
           </a:xfrm>
           <a:prstGeom prst="line">
             <a:avLst/>
@@ -2319,8 +2316,8 @@
         </p:nvSpPr>
         <p:spPr>
           <a:xfrm>
-            <a:off x="6172200" y="2681478"/>
-            <a:ext cx="1463040" cy="420624"/>
+            <a:off x="6446520" y="1668780"/>
+            <a:ext cx="1737360" cy="457200"/>
           </a:xfrm>
           <a:prstGeom prst="rect">
             <a:avLst/>
@@ -2335,7 +2332,7 @@
           </a:ln>
         </p:spPr>
         <p:txBody>
-          <a:bodyPr wrap="square" lIns="381" tIns="381" rIns="381" bIns="381" rtlCol="0" anchor="ctr"/>
+          <a:bodyPr wrap="square" lIns="508" tIns="508" rIns="508" bIns="508" rtlCol="0" anchor="ctr"/>
           <a:lstStyle/>
           <a:p>
             <a:pPr indent="0" marL="0">
@@ -2387,7 +2384,7 @@
         </p:nvSpPr>
         <p:spPr>
           <a:xfrm>
-            <a:off x="7726680" y="3337560"/>
+            <a:off x="8321040" y="2423160"/>
             <a:ext cx="1737360" cy="502920"/>
           </a:xfrm>
           <a:prstGeom prst="roundRect">
@@ -2414,7 +2411,7 @@
         </p:nvSpPr>
         <p:spPr>
           <a:xfrm>
-            <a:off x="7726680" y="3337560"/>
+            <a:off x="8321040" y="2423160"/>
             <a:ext cx="1737360" cy="502920"/>
           </a:xfrm>
           <a:prstGeom prst="rect">
@@ -2470,8 +2467,8 @@
         </p:nvSpPr>
         <p:spPr>
           <a:xfrm>
-            <a:off x="6035040" y="3520440"/>
-            <a:ext cx="1691640" cy="13716"/>
+            <a:off x="6309360" y="2610612"/>
+            <a:ext cx="2011680" cy="914"/>
           </a:xfrm>
           <a:prstGeom prst="line">
             <a:avLst/>
@@ -2494,8 +2491,8 @@
         </p:nvSpPr>
         <p:spPr>
           <a:xfrm>
-            <a:off x="6035040" y="3611880"/>
-            <a:ext cx="1691640" cy="32004"/>
+            <a:off x="6309360" y="2738628"/>
+            <a:ext cx="2011680" cy="914"/>
           </a:xfrm>
           <a:prstGeom prst="line">
             <a:avLst/>
@@ -2518,8 +2515,8 @@
         </p:nvSpPr>
         <p:spPr>
           <a:xfrm>
-            <a:off x="6172200" y="3367278"/>
-            <a:ext cx="1463040" cy="420624"/>
+            <a:off x="6446520" y="2446020"/>
+            <a:ext cx="1737360" cy="457200"/>
           </a:xfrm>
           <a:prstGeom prst="rect">
             <a:avLst/>
@@ -2534,7 +2531,7 @@
           </a:ln>
         </p:spPr>
         <p:txBody>
-          <a:bodyPr wrap="square" lIns="381" tIns="381" rIns="381" bIns="381" rtlCol="0" anchor="ctr"/>
+          <a:bodyPr wrap="square" lIns="508" tIns="508" rIns="508" bIns="508" rtlCol="0" anchor="ctr"/>
           <a:lstStyle/>
           <a:p>
             <a:pPr indent="0" marL="0">
@@ -2586,7 +2583,7 @@
         </p:nvSpPr>
         <p:spPr>
           <a:xfrm>
-            <a:off x="7726680" y="4389120"/>
+            <a:off x="8321040" y="3200400"/>
             <a:ext cx="1737360" cy="502920"/>
           </a:xfrm>
           <a:prstGeom prst="roundRect">
@@ -2613,7 +2610,7 @@
         </p:nvSpPr>
         <p:spPr>
           <a:xfrm>
-            <a:off x="7726680" y="4389120"/>
+            <a:off x="8321040" y="3200400"/>
             <a:ext cx="1737360" cy="502920"/>
           </a:xfrm>
           <a:prstGeom prst="rect">
@@ -2638,7 +2635,7 @@
                 <a:ea typeface="Calibri" pitchFamily="34" charset="-122"/>
                 <a:cs typeface="Calibri" pitchFamily="34" charset="-120"/>
               </a:rPr>
-              <a:t>E-Mail-Dienst THM</a:t>
+              <a:t>THM-Login (SSO)</a:t>
             </a:r>
             <a:endParaRPr lang="en-US" sz="950" dirty="0"/>
           </a:p>
@@ -2669,8 +2666,8 @@
         </p:nvSpPr>
         <p:spPr>
           <a:xfrm>
-            <a:off x="6035040" y="3840480"/>
-            <a:ext cx="1691640" cy="745236"/>
+            <a:off x="6309360" y="3387852"/>
+            <a:ext cx="2011680" cy="914"/>
           </a:xfrm>
           <a:prstGeom prst="line">
             <a:avLst/>
@@ -2693,8 +2690,8 @@
         </p:nvSpPr>
         <p:spPr>
           <a:xfrm>
-            <a:off x="6035040" y="3931920"/>
-            <a:ext cx="1691640" cy="763524"/>
+            <a:off x="6309360" y="3515868"/>
+            <a:ext cx="2011680" cy="914"/>
           </a:xfrm>
           <a:prstGeom prst="line">
             <a:avLst/>
@@ -2717,8 +2714,8 @@
         </p:nvSpPr>
         <p:spPr>
           <a:xfrm>
-            <a:off x="6172200" y="4053078"/>
-            <a:ext cx="1463040" cy="420624"/>
+            <a:off x="6446520" y="3223260"/>
+            <a:ext cx="1737360" cy="457200"/>
           </a:xfrm>
           <a:prstGeom prst="rect">
             <a:avLst/>
@@ -2733,7 +2730,7 @@
           </a:ln>
         </p:spPr>
         <p:txBody>
-          <a:bodyPr wrap="square" lIns="381" tIns="381" rIns="381" bIns="381" rtlCol="0" anchor="ctr"/>
+          <a:bodyPr wrap="square" lIns="508" tIns="508" rIns="508" bIns="508" rtlCol="0" anchor="ctr"/>
           <a:lstStyle/>
           <a:p>
             <a:pPr indent="0" marL="0">
@@ -2751,7 +2748,7 @@
                 <a:ea typeface="Calibri" pitchFamily="34" charset="-122"/>
                 <a:cs typeface="Calibri" pitchFamily="34" charset="-120"/>
               </a:rPr>
-              <a:t>▶ Zustellstatus</a:t>
+              <a:t>▶ Identität, Rolle, Matrikelnummer</a:t>
             </a:r>
             <a:endParaRPr lang="en-US" sz="700" dirty="0"/>
           </a:p>
@@ -2771,7 +2768,7 @@
                 <a:ea typeface="Calibri" pitchFamily="34" charset="-122"/>
                 <a:cs typeface="Calibri" pitchFamily="34" charset="-120"/>
               </a:rPr>
-              <a:t>◀ Benachrichtigungen, Einladungen, Bescheide</a:t>
+              <a:t>◀ Authentifizierungsanfrage</a:t>
             </a:r>
             <a:endParaRPr lang="en-US" sz="700" dirty="0"/>
           </a:p>
@@ -2785,7 +2782,7 @@
         </p:nvSpPr>
         <p:spPr>
           <a:xfrm>
-            <a:off x="4251960" y="1188720"/>
+            <a:off x="8321040" y="3977640"/>
             <a:ext cx="1737360" cy="502920"/>
           </a:xfrm>
           <a:prstGeom prst="roundRect">
@@ -2812,7 +2809,7 @@
         </p:nvSpPr>
         <p:spPr>
           <a:xfrm>
-            <a:off x="4251960" y="1188720"/>
+            <a:off x="8321040" y="3977640"/>
             <a:ext cx="1737360" cy="502920"/>
           </a:xfrm>
           <a:prstGeom prst="rect">
@@ -2837,7 +2834,7 @@
                 <a:ea typeface="Calibri" pitchFamily="34" charset="-122"/>
                 <a:cs typeface="Calibri" pitchFamily="34" charset="-120"/>
               </a:rPr>
-              <a:t>THM-Login (SSO)</a:t>
+              <a:t>E-Mail-Dienst THM</a:t>
             </a:r>
             <a:endParaRPr lang="en-US" sz="950" dirty="0"/>
           </a:p>
@@ -2868,8 +2865,8 @@
         </p:nvSpPr>
         <p:spPr>
           <a:xfrm>
-            <a:off x="5029200" y="1691640"/>
-            <a:ext cx="914" cy="1097280"/>
+            <a:off x="6309360" y="4165092"/>
+            <a:ext cx="2011680" cy="914"/>
           </a:xfrm>
           <a:prstGeom prst="line">
             <a:avLst/>
@@ -2878,6 +2875,30 @@
           <a:ln w="15875">
             <a:solidFill>
               <a:srgbClr val="2C5F2D"/>
+            </a:solidFill>
+            <a:prstDash val="solid"/>
+            <a:headEnd type="triangle"/>
+          </a:ln>
+        </p:spPr>
+      </p:sp>
+      <p:sp>
+        <p:nvSpPr>
+          <p:cNvPr id="52" name="Shape 50"/>
+          <p:cNvSpPr/>
+          <p:nvPr/>
+        </p:nvSpPr>
+        <p:spPr>
+          <a:xfrm>
+            <a:off x="6309360" y="4293108"/>
+            <a:ext cx="2011680" cy="914"/>
+          </a:xfrm>
+          <a:prstGeom prst="line">
+            <a:avLst/>
+          </a:prstGeom>
+          <a:noFill/>
+          <a:ln w="15875">
+            <a:solidFill>
+              <a:srgbClr val="4A7FB5"/>
             </a:solidFill>
             <a:prstDash val="solid"/>
             <a:tailEnd type="triangle"/>
@@ -2886,38 +2907,14 @@
       </p:sp>
       <p:sp>
         <p:nvSpPr>
-          <p:cNvPr id="52" name="Shape 50"/>
-          <p:cNvSpPr/>
-          <p:nvPr/>
-        </p:nvSpPr>
-        <p:spPr>
-          <a:xfrm flipV="1">
-            <a:off x="5212080" y="1691640"/>
-            <a:ext cx="914" cy="1097280"/>
-          </a:xfrm>
-          <a:prstGeom prst="line">
-            <a:avLst/>
-          </a:prstGeom>
-          <a:noFill/>
-          <a:ln w="15875">
-            <a:solidFill>
-              <a:srgbClr val="4A7FB5"/>
-            </a:solidFill>
-            <a:prstDash val="solid"/>
-            <a:tailEnd type="triangle"/>
-          </a:ln>
-        </p:spPr>
-      </p:sp>
-      <p:sp>
-        <p:nvSpPr>
           <p:cNvPr id="53" name="Text 51"/>
           <p:cNvSpPr txBox="1"/>
           <p:nvPr/>
         </p:nvSpPr>
         <p:spPr>
           <a:xfrm>
-            <a:off x="5303520" y="2011680"/>
-            <a:ext cx="1371600" cy="420624"/>
+            <a:off x="6446520" y="4000500"/>
+            <a:ext cx="1737360" cy="457200"/>
           </a:xfrm>
           <a:prstGeom prst="rect">
             <a:avLst/>
@@ -2932,7 +2929,7 @@
           </a:ln>
         </p:spPr>
         <p:txBody>
-          <a:bodyPr wrap="square" lIns="381" tIns="381" rIns="381" bIns="381" rtlCol="0" anchor="ctr"/>
+          <a:bodyPr wrap="square" lIns="508" tIns="508" rIns="508" bIns="508" rtlCol="0" anchor="ctr"/>
           <a:lstStyle/>
           <a:p>
             <a:pPr indent="0" marL="0">
@@ -2950,7 +2947,7 @@
                 <a:ea typeface="Calibri" pitchFamily="34" charset="-122"/>
                 <a:cs typeface="Calibri" pitchFamily="34" charset="-120"/>
               </a:rPr>
-              <a:t>▶ Identität, Rolle, Matrikelnummer</a:t>
+              <a:t>▶ Zustellstatus</a:t>
             </a:r>
             <a:endParaRPr lang="en-US" sz="700" dirty="0"/>
           </a:p>
@@ -2970,7 +2967,7 @@
                 <a:ea typeface="Calibri" pitchFamily="34" charset="-122"/>
                 <a:cs typeface="Calibri" pitchFamily="34" charset="-120"/>
               </a:rPr>
-              <a:t>◀ Authentifizierungsanfrage</a:t>
+              <a:t>◀ Benachrichtigungen, Einladungen, Bescheide</a:t>
             </a:r>
             <a:endParaRPr lang="en-US" sz="700" dirty="0"/>
           </a:p>
@@ -2984,7 +2981,7 @@
         </p:nvSpPr>
         <p:spPr>
           <a:xfrm>
-            <a:off x="2148840" y="5349240"/>
+            <a:off x="2377440" y="5440680"/>
             <a:ext cx="1737360" cy="502920"/>
           </a:xfrm>
           <a:prstGeom prst="roundRect">
@@ -3011,7 +3008,7 @@
         </p:nvSpPr>
         <p:spPr>
           <a:xfrm>
-            <a:off x="2148840" y="5349240"/>
+            <a:off x="2377440" y="5440680"/>
             <a:ext cx="1737360" cy="502920"/>
           </a:xfrm>
           <a:prstGeom prst="rect">
@@ -3066,9 +3063,9 @@
           <p:nvPr/>
         </p:nvSpPr>
         <p:spPr>
-          <a:xfrm flipV="1">
-            <a:off x="3017520" y="3977640"/>
-            <a:ext cx="1508760" cy="1371600"/>
+          <a:xfrm>
+            <a:off x="3246120" y="4892040"/>
+            <a:ext cx="914" cy="548640"/>
           </a:xfrm>
           <a:prstGeom prst="line">
             <a:avLst/>
@@ -3079,7 +3076,6 @@
               <a:srgbClr val="2C5F2D"/>
             </a:solidFill>
             <a:prstDash val="solid"/>
-            <a:tailEnd type="triangle"/>
           </a:ln>
         </p:spPr>
       </p:sp>
@@ -3091,7 +3087,102 @@
         </p:nvSpPr>
         <p:spPr>
           <a:xfrm>
-            <a:off x="4251960" y="5349240"/>
+            <a:off x="3246120" y="4892040"/>
+            <a:ext cx="1645920" cy="914"/>
+          </a:xfrm>
+          <a:prstGeom prst="line">
+            <a:avLst/>
+          </a:prstGeom>
+          <a:noFill/>
+          <a:ln w="15875">
+            <a:solidFill>
+              <a:srgbClr val="2C5F2D"/>
+            </a:solidFill>
+            <a:prstDash val="solid"/>
+          </a:ln>
+        </p:spPr>
+      </p:sp>
+      <p:sp>
+        <p:nvSpPr>
+          <p:cNvPr id="58" name="Shape 56"/>
+          <p:cNvSpPr/>
+          <p:nvPr/>
+        </p:nvSpPr>
+        <p:spPr>
+          <a:xfrm>
+            <a:off x="4892040" y="4617720"/>
+            <a:ext cx="914" cy="274320"/>
+          </a:xfrm>
+          <a:prstGeom prst="line">
+            <a:avLst/>
+          </a:prstGeom>
+          <a:noFill/>
+          <a:ln w="15875">
+            <a:solidFill>
+              <a:srgbClr val="2C5F2D"/>
+            </a:solidFill>
+            <a:prstDash val="solid"/>
+            <a:headEnd type="triangle"/>
+          </a:ln>
+        </p:spPr>
+      </p:sp>
+      <p:sp>
+        <p:nvSpPr>
+          <p:cNvPr id="59" name="Text 57"/>
+          <p:cNvSpPr txBox="1"/>
+          <p:nvPr/>
+        </p:nvSpPr>
+        <p:spPr>
+          <a:xfrm>
+            <a:off x="2468880" y="4956048"/>
+            <a:ext cx="1554480" cy="457200"/>
+          </a:xfrm>
+          <a:prstGeom prst="rect">
+            <a:avLst/>
+          </a:prstGeom>
+          <a:solidFill>
+            <a:srgbClr val="FFFFFF"/>
+          </a:solidFill>
+          <a:ln w="6350">
+            <a:solidFill>
+              <a:srgbClr val="C9D1C9"/>
+            </a:solidFill>
+          </a:ln>
+        </p:spPr>
+        <p:txBody>
+          <a:bodyPr wrap="square" lIns="508" tIns="508" rIns="508" bIns="508" rtlCol="0" anchor="ctr"/>
+          <a:lstStyle/>
+          <a:p>
+            <a:pPr indent="0" marL="0">
+              <a:lnSpc>
+                <a:spcPct val="105000"/>
+              </a:lnSpc>
+              <a:buNone/>
+            </a:pPr>
+            <a:r>
+              <a:rPr lang="en-US" sz="700" dirty="0">
+                <a:solidFill>
+                  <a:srgbClr val="2C5F2D"/>
+                </a:solidFill>
+                <a:latin typeface="Calibri" pitchFamily="34" charset="0"/>
+                <a:ea typeface="Calibri" pitchFamily="34" charset="-122"/>
+                <a:cs typeface="Calibri" pitchFamily="34" charset="-120"/>
+              </a:rPr>
+              <a:t>▶ Zulassungsregeln, Fristen (Konfiguration)</a:t>
+            </a:r>
+            <a:endParaRPr lang="en-US" sz="700" dirty="0"/>
+          </a:p>
+        </p:txBody>
+      </p:sp>
+      <p:sp>
+        <p:nvSpPr>
+          <p:cNvPr id="60" name="Shape 58"/>
+          <p:cNvSpPr/>
+          <p:nvPr/>
+        </p:nvSpPr>
+        <p:spPr>
+          <a:xfrm>
+            <a:off x="4526280" y="5440680"/>
             <a:ext cx="1737360" cy="502920"/>
           </a:xfrm>
           <a:prstGeom prst="roundRect">
@@ -3112,13 +3203,13 @@
       </p:sp>
       <p:sp>
         <p:nvSpPr>
-          <p:cNvPr id="58" name="Text 56"/>
+          <p:cNvPr id="61" name="Text 59"/>
           <p:cNvSpPr txBox="1"/>
           <p:nvPr/>
         </p:nvSpPr>
         <p:spPr>
           <a:xfrm>
-            <a:off x="4251960" y="5349240"/>
+            <a:off x="4526280" y="5440680"/>
             <a:ext cx="1737360" cy="502920"/>
           </a:xfrm>
           <a:prstGeom prst="rect">
@@ -3168,14 +3259,14 @@
       </p:sp>
       <p:sp>
         <p:nvSpPr>
-          <p:cNvPr id="59" name="Shape 57"/>
-          <p:cNvSpPr/>
-          <p:nvPr/>
-        </p:nvSpPr>
-        <p:spPr>
-          <a:xfrm>
-            <a:off x="5120640" y="3977640"/>
-            <a:ext cx="0" cy="1371600"/>
+          <p:cNvPr id="62" name="Shape 60"/>
+          <p:cNvSpPr/>
+          <p:nvPr/>
+        </p:nvSpPr>
+        <p:spPr>
+          <a:xfrm>
+            <a:off x="5394960" y="4617720"/>
+            <a:ext cx="914" cy="822960"/>
           </a:xfrm>
           <a:prstGeom prst="line">
             <a:avLst/>
@@ -3192,13 +3283,61 @@
       </p:sp>
       <p:sp>
         <p:nvSpPr>
-          <p:cNvPr id="60" name="Shape 58"/>
-          <p:cNvSpPr/>
-          <p:nvPr/>
-        </p:nvSpPr>
-        <p:spPr>
-          <a:xfrm>
-            <a:off x="6355080" y="5349240"/>
+          <p:cNvPr id="63" name="Text 61"/>
+          <p:cNvSpPr txBox="1"/>
+          <p:nvPr/>
+        </p:nvSpPr>
+        <p:spPr>
+          <a:xfrm>
+            <a:off x="4617720" y="4956048"/>
+            <a:ext cx="1554480" cy="457200"/>
+          </a:xfrm>
+          <a:prstGeom prst="rect">
+            <a:avLst/>
+          </a:prstGeom>
+          <a:solidFill>
+            <a:srgbClr val="FFFFFF"/>
+          </a:solidFill>
+          <a:ln w="6350">
+            <a:solidFill>
+              <a:srgbClr val="C9D1C9"/>
+            </a:solidFill>
+          </a:ln>
+        </p:spPr>
+        <p:txBody>
+          <a:bodyPr wrap="square" lIns="508" tIns="508" rIns="508" bIns="508" rtlCol="0" anchor="ctr"/>
+          <a:lstStyle/>
+          <a:p>
+            <a:pPr indent="0" marL="0">
+              <a:lnSpc>
+                <a:spcPct val="105000"/>
+              </a:lnSpc>
+              <a:buNone/>
+            </a:pPr>
+            <a:r>
+              <a:rPr lang="en-US" sz="700" dirty="0">
+                <a:solidFill>
+                  <a:srgbClr val="4A7FB5"/>
+                </a:solidFill>
+                <a:latin typeface="Calibri" pitchFamily="34" charset="0"/>
+                <a:ea typeface="Calibri" pitchFamily="34" charset="-122"/>
+                <a:cs typeface="Calibri" pitchFamily="34" charset="-120"/>
+              </a:rPr>
+              <a:t>◀ abgeschlossener Vorgang als Akten-PDF</a:t>
+            </a:r>
+            <a:endParaRPr lang="en-US" sz="700" dirty="0"/>
+          </a:p>
+        </p:txBody>
+      </p:sp>
+      <p:sp>
+        <p:nvSpPr>
+          <p:cNvPr id="64" name="Shape 62"/>
+          <p:cNvSpPr/>
+          <p:nvPr/>
+        </p:nvSpPr>
+        <p:spPr>
+          <a:xfrm>
+            <a:off x="6675120" y="5440680"/>
             <a:ext cx="1737360" cy="502920"/>
           </a:xfrm>
           <a:prstGeom prst="roundRect">
@@ -3219,13 +3358,13 @@
       </p:sp>
       <p:sp>
         <p:nvSpPr>
-          <p:cNvPr id="61" name="Text 59"/>
+          <p:cNvPr id="65" name="Text 63"/>
           <p:cNvSpPr txBox="1"/>
           <p:nvPr/>
         </p:nvSpPr>
         <p:spPr>
           <a:xfrm>
-            <a:off x="6355080" y="5349240"/>
+            <a:off x="6675120" y="5440680"/>
             <a:ext cx="1737360" cy="502920"/>
           </a:xfrm>
           <a:prstGeom prst="rect">
@@ -3275,14 +3414,60 @@
       </p:sp>
       <p:sp>
         <p:nvSpPr>
-          <p:cNvPr id="62" name="Shape 60"/>
-          <p:cNvSpPr/>
-          <p:nvPr/>
-        </p:nvSpPr>
-        <p:spPr>
-          <a:xfrm>
-            <a:off x="5715000" y="3977640"/>
-            <a:ext cx="1508760" cy="1371600"/>
+          <p:cNvPr id="66" name="Shape 64"/>
+          <p:cNvSpPr/>
+          <p:nvPr/>
+        </p:nvSpPr>
+        <p:spPr>
+          <a:xfrm>
+            <a:off x="7543800" y="4892040"/>
+            <a:ext cx="914" cy="548640"/>
+          </a:xfrm>
+          <a:prstGeom prst="line">
+            <a:avLst/>
+          </a:prstGeom>
+          <a:noFill/>
+          <a:ln w="15875">
+            <a:solidFill>
+              <a:srgbClr val="2C5F2D"/>
+            </a:solidFill>
+            <a:prstDash val="solid"/>
+          </a:ln>
+        </p:spPr>
+      </p:sp>
+      <p:sp>
+        <p:nvSpPr>
+          <p:cNvPr id="67" name="Shape 65"/>
+          <p:cNvSpPr/>
+          <p:nvPr/>
+        </p:nvSpPr>
+        <p:spPr>
+          <a:xfrm>
+            <a:off x="5897880" y="4892040"/>
+            <a:ext cx="1645920" cy="914"/>
+          </a:xfrm>
+          <a:prstGeom prst="line">
+            <a:avLst/>
+          </a:prstGeom>
+          <a:noFill/>
+          <a:ln w="15875">
+            <a:solidFill>
+              <a:srgbClr val="2C5F2D"/>
+            </a:solidFill>
+            <a:prstDash val="solid"/>
+          </a:ln>
+        </p:spPr>
+      </p:sp>
+      <p:sp>
+        <p:nvSpPr>
+          <p:cNvPr id="68" name="Shape 66"/>
+          <p:cNvSpPr/>
+          <p:nvPr/>
+        </p:nvSpPr>
+        <p:spPr>
+          <a:xfrm>
+            <a:off x="5897880" y="4617720"/>
+            <a:ext cx="914" cy="274320"/>
           </a:xfrm>
           <a:prstGeom prst="line">
             <a:avLst/>
@@ -3299,14 +3484,14 @@
       </p:sp>
       <p:sp>
         <p:nvSpPr>
-          <p:cNvPr id="63" name="Text 61"/>
+          <p:cNvPr id="69" name="Text 67"/>
           <p:cNvSpPr txBox="1"/>
           <p:nvPr/>
         </p:nvSpPr>
         <p:spPr>
           <a:xfrm>
-            <a:off x="2743200" y="4572000"/>
-            <a:ext cx="1417320" cy="420624"/>
+            <a:off x="6766560" y="4956048"/>
+            <a:ext cx="1554480" cy="457200"/>
           </a:xfrm>
           <a:prstGeom prst="rect">
             <a:avLst/>
@@ -3321,7 +3506,7 @@
           </a:ln>
         </p:spPr>
         <p:txBody>
-          <a:bodyPr wrap="square" lIns="381" tIns="381" rIns="381" bIns="381" rtlCol="0" anchor="ctr"/>
+          <a:bodyPr wrap="square" lIns="508" tIns="508" rIns="508" bIns="508" rtlCol="0" anchor="ctr"/>
           <a:lstStyle/>
           <a:p>
             <a:pPr indent="0" marL="0">
@@ -3339,7 +3524,7 @@
                 <a:ea typeface="Calibri" pitchFamily="34" charset="-122"/>
                 <a:cs typeface="Calibri" pitchFamily="34" charset="-120"/>
               </a:rPr>
-              <a:t>▶ Zulassungsregeln, Fristen (Konfiguration)</a:t>
+              <a:t>▶ Abgabetermin erreicht, 4-Wochen-Frist Themenrückgabe</a:t>
             </a:r>
             <a:endParaRPr lang="en-US" sz="700" dirty="0"/>
           </a:p>
@@ -3347,29 +3532,133 @@
       </p:sp>
       <p:sp>
         <p:nvSpPr>
-          <p:cNvPr id="64" name="Text 62"/>
+          <p:cNvPr id="70" name="Shape 68"/>
+          <p:cNvSpPr/>
+          <p:nvPr/>
+        </p:nvSpPr>
+        <p:spPr>
+          <a:xfrm>
+            <a:off x="10332720" y="914400"/>
+            <a:ext cx="1417320" cy="5257800"/>
+          </a:xfrm>
+          <a:prstGeom prst="roundRect">
+            <a:avLst>
+              <a:gd name="adj" fmla="val 12903"/>
+            </a:avLst>
+          </a:prstGeom>
+          <a:solidFill>
+            <a:srgbClr val="FFFFFF"/>
+          </a:solidFill>
+          <a:ln w="12700">
+            <a:solidFill>
+              <a:srgbClr val="C9D1C9"/>
+            </a:solidFill>
+            <a:prstDash val="sysDot"/>
+          </a:ln>
+        </p:spPr>
+      </p:sp>
+      <p:sp>
+        <p:nvSpPr>
+          <p:cNvPr id="71" name="Text 69"/>
           <p:cNvSpPr txBox="1"/>
           <p:nvPr/>
         </p:nvSpPr>
         <p:spPr>
           <a:xfrm>
-            <a:off x="5074920" y="4709160"/>
-            <a:ext cx="1371600" cy="420624"/>
+            <a:off x="10424160" y="1005840"/>
+            <a:ext cx="1234440" cy="548640"/>
           </a:xfrm>
           <a:prstGeom prst="rect">
             <a:avLst/>
           </a:prstGeom>
-          <a:solidFill>
-            <a:srgbClr val="FFFFFF"/>
-          </a:solidFill>
-          <a:ln w="6350">
+          <a:noFill/>
+          <a:ln/>
+        </p:spPr>
+        <p:txBody>
+          <a:bodyPr wrap="square" lIns="0" tIns="0" rIns="0" bIns="0" rtlCol="0" anchor="t"/>
+          <a:lstStyle/>
+          <a:p>
+            <a:pPr indent="0" marL="0">
+              <a:buNone/>
+            </a:pPr>
+            <a:r>
+              <a:rPr lang="en-US" sz="950" b="1" dirty="0">
+                <a:solidFill>
+                  <a:srgbClr val="5C6B5C"/>
+                </a:solidFill>
+                <a:latin typeface="Calibri" pitchFamily="34" charset="0"/>
+                <a:ea typeface="Calibri" pitchFamily="34" charset="-122"/>
+                <a:cs typeface="Calibri" pitchFamily="34" charset="-120"/>
+              </a:rPr>
+              <a:t>Grauzone</a:t>
+            </a:r>
+            <a:endParaRPr lang="en-US" sz="950" dirty="0"/>
+          </a:p>
+          <a:p>
+            <a:pPr indent="0" marL="0">
+              <a:buNone/>
+            </a:pPr>
+            <a:r>
+              <a:rPr lang="en-US" sz="700" dirty="0">
+                <a:solidFill>
+                  <a:srgbClr val="8A968A"/>
+                </a:solidFill>
+                <a:latin typeface="Calibri" pitchFamily="34" charset="0"/>
+                <a:ea typeface="Calibri" pitchFamily="34" charset="-122"/>
+                <a:cs typeface="Calibri" pitchFamily="34" charset="-120"/>
+              </a:rPr>
+              <a:t>Beziehung zum System noch offen (Kontextabgrenzung)</a:t>
+            </a:r>
+            <a:endParaRPr lang="en-US" sz="950" dirty="0"/>
+          </a:p>
+        </p:txBody>
+      </p:sp>
+      <p:sp>
+        <p:nvSpPr>
+          <p:cNvPr id="72" name="Shape 70"/>
+          <p:cNvSpPr/>
+          <p:nvPr/>
+        </p:nvSpPr>
+        <p:spPr>
+          <a:xfrm>
+            <a:off x="10424160" y="1645920"/>
+            <a:ext cx="1234440" cy="987552"/>
+          </a:xfrm>
+          <a:prstGeom prst="roundRect">
+            <a:avLst>
+              <a:gd name="adj" fmla="val 5556"/>
+            </a:avLst>
+          </a:prstGeom>
+          <a:solidFill>
+            <a:srgbClr val="F5F7F4"/>
+          </a:solidFill>
+          <a:ln w="9525">
             <a:solidFill>
               <a:srgbClr val="C9D1C9"/>
             </a:solidFill>
-          </a:ln>
-        </p:spPr>
-        <p:txBody>
-          <a:bodyPr wrap="square" lIns="381" tIns="381" rIns="381" bIns="381" rtlCol="0" anchor="ctr"/>
+            <a:prstDash val="dash"/>
+          </a:ln>
+        </p:spPr>
+      </p:sp>
+      <p:sp>
+        <p:nvSpPr>
+          <p:cNvPr id="73" name="Text 71"/>
+          <p:cNvSpPr txBox="1"/>
+          <p:nvPr/>
+        </p:nvSpPr>
+        <p:spPr>
+          <a:xfrm>
+            <a:off x="10479024" y="1691640"/>
+            <a:ext cx="1124712" cy="914400"/>
+          </a:xfrm>
+          <a:prstGeom prst="rect">
+            <a:avLst/>
+          </a:prstGeom>
+          <a:noFill/>
+          <a:ln/>
+        </p:spPr>
+        <p:txBody>
+          <a:bodyPr wrap="square" lIns="0" tIns="0" rIns="0" bIns="0" rtlCol="0" anchor="t"/>
           <a:lstStyle/>
           <a:p>
             <a:pPr indent="0" marL="0">
@@ -3379,46 +3668,18 @@
               <a:buNone/>
             </a:pPr>
             <a:r>
-              <a:rPr lang="en-US" sz="700" dirty="0">
-                <a:solidFill>
-                  <a:srgbClr val="4A7FB5"/>
-                </a:solidFill>
-                <a:latin typeface="Calibri" pitchFamily="34" charset="0"/>
-                <a:ea typeface="Calibri" pitchFamily="34" charset="-122"/>
-                <a:cs typeface="Calibri" pitchFamily="34" charset="-120"/>
-              </a:rPr>
-              <a:t>◀ abgeschlossener Vorgang als Akten-PDF</a:t>
-            </a:r>
-            <a:endParaRPr lang="en-US" sz="700" dirty="0"/>
-          </a:p>
-        </p:txBody>
-      </p:sp>
-      <p:sp>
-        <p:nvSpPr>
-          <p:cNvPr id="65" name="Text 63"/>
-          <p:cNvSpPr txBox="1"/>
-          <p:nvPr/>
-        </p:nvSpPr>
-        <p:spPr>
-          <a:xfrm>
-            <a:off x="6629400" y="4572000"/>
-            <a:ext cx="1417320" cy="420624"/>
-          </a:xfrm>
-          <a:prstGeom prst="rect">
-            <a:avLst/>
-          </a:prstGeom>
-          <a:solidFill>
-            <a:srgbClr val="FFFFFF"/>
-          </a:solidFill>
-          <a:ln w="6350">
-            <a:solidFill>
-              <a:srgbClr val="C9D1C9"/>
-            </a:solidFill>
-          </a:ln>
-        </p:spPr>
-        <p:txBody>
-          <a:bodyPr wrap="square" lIns="381" tIns="381" rIns="381" bIns="381" rtlCol="0" anchor="ctr"/>
-          <a:lstStyle/>
+              <a:rPr lang="en-US" sz="800" b="1" dirty="0">
+                <a:solidFill>
+                  <a:srgbClr val="5C6B5C"/>
+                </a:solidFill>
+                <a:latin typeface="Calibri" pitchFamily="34" charset="0"/>
+                <a:ea typeface="Calibri" pitchFamily="34" charset="-122"/>
+                <a:cs typeface="Calibri" pitchFamily="34" charset="-120"/>
+              </a:rPr>
+              <a:t>Prüfungsverwaltung THM</a:t>
+            </a:r>
+            <a:endParaRPr lang="en-US" sz="800" dirty="0"/>
+          </a:p>
           <a:p>
             <a:pPr indent="0" marL="0">
               <a:lnSpc>
@@ -3429,138 +3690,55 @@
             <a:r>
               <a:rPr lang="en-US" sz="700" dirty="0">
                 <a:solidFill>
-                  <a:srgbClr val="2C5F2D"/>
-                </a:solidFill>
-                <a:latin typeface="Calibri" pitchFamily="34" charset="0"/>
-                <a:ea typeface="Calibri" pitchFamily="34" charset="-122"/>
-                <a:cs typeface="Calibri" pitchFamily="34" charset="-120"/>
-              </a:rPr>
-              <a:t>▶ Abgabetermin erreicht, 4-Wochen-Frist Themenrückgabe</a:t>
-            </a:r>
-            <a:endParaRPr lang="en-US" sz="700" dirty="0"/>
-          </a:p>
-        </p:txBody>
-      </p:sp>
-      <p:sp>
-        <p:nvSpPr>
-          <p:cNvPr id="66" name="Shape 64"/>
-          <p:cNvSpPr/>
-          <p:nvPr/>
-        </p:nvSpPr>
-        <p:spPr>
-          <a:xfrm>
-            <a:off x="10012680" y="960120"/>
-            <a:ext cx="1737360" cy="5166360"/>
+                  <a:srgbClr val="8A968A"/>
+                </a:solidFill>
+                <a:latin typeface="Calibri" pitchFamily="34" charset="0"/>
+                <a:ea typeface="Calibri" pitchFamily="34" charset="-122"/>
+                <a:cs typeface="Calibri" pitchFamily="34" charset="-120"/>
+              </a:rPr>
+              <a:t>Modulstand für die Zulassungsprüfung: manuell oder Schnittstelle?</a:t>
+            </a:r>
+            <a:endParaRPr lang="en-US" sz="800" dirty="0"/>
+          </a:p>
+        </p:txBody>
+      </p:sp>
+      <p:sp>
+        <p:nvSpPr>
+          <p:cNvPr id="74" name="Shape 72"/>
+          <p:cNvSpPr/>
+          <p:nvPr/>
+        </p:nvSpPr>
+        <p:spPr>
+          <a:xfrm>
+            <a:off x="10424160" y="2743200"/>
+            <a:ext cx="1234440" cy="987552"/>
           </a:xfrm>
           <a:prstGeom prst="roundRect">
             <a:avLst>
-              <a:gd name="adj" fmla="val 10526"/>
+              <a:gd name="adj" fmla="val 5556"/>
             </a:avLst>
           </a:prstGeom>
           <a:solidFill>
-            <a:srgbClr val="FFFFFF"/>
-          </a:solidFill>
-          <a:ln w="12700">
+            <a:srgbClr val="F5F7F4"/>
+          </a:solidFill>
+          <a:ln w="9525">
             <a:solidFill>
               <a:srgbClr val="C9D1C9"/>
             </a:solidFill>
-            <a:prstDash val="sysDot"/>
-          </a:ln>
-        </p:spPr>
-      </p:sp>
-      <p:sp>
-        <p:nvSpPr>
-          <p:cNvPr id="67" name="Text 65"/>
+            <a:prstDash val="dash"/>
+          </a:ln>
+        </p:spPr>
+      </p:sp>
+      <p:sp>
+        <p:nvSpPr>
+          <p:cNvPr id="75" name="Text 73"/>
           <p:cNvSpPr txBox="1"/>
           <p:nvPr/>
         </p:nvSpPr>
         <p:spPr>
           <a:xfrm>
-            <a:off x="10104120" y="1069848"/>
-            <a:ext cx="1554480" cy="548640"/>
-          </a:xfrm>
-          <a:prstGeom prst="rect">
-            <a:avLst/>
-          </a:prstGeom>
-          <a:noFill/>
-          <a:ln/>
-        </p:spPr>
-        <p:txBody>
-          <a:bodyPr wrap="square" lIns="0" tIns="0" rIns="0" bIns="0" rtlCol="0" anchor="t"/>
-          <a:lstStyle/>
-          <a:p>
-            <a:pPr indent="0" marL="0">
-              <a:buNone/>
-            </a:pPr>
-            <a:r>
-              <a:rPr lang="en-US" sz="950" b="1" dirty="0">
-                <a:solidFill>
-                  <a:srgbClr val="5C6B5C"/>
-                </a:solidFill>
-                <a:latin typeface="Calibri" pitchFamily="34" charset="0"/>
-                <a:ea typeface="Calibri" pitchFamily="34" charset="-122"/>
-                <a:cs typeface="Calibri" pitchFamily="34" charset="-120"/>
-              </a:rPr>
-              <a:t>Grauzone</a:t>
-            </a:r>
-            <a:endParaRPr lang="en-US" sz="950" dirty="0"/>
-          </a:p>
-          <a:p>
-            <a:pPr indent="0" marL="0">
-              <a:buNone/>
-            </a:pPr>
-            <a:r>
-              <a:rPr lang="en-US" sz="750" dirty="0">
-                <a:solidFill>
-                  <a:srgbClr val="8A968A"/>
-                </a:solidFill>
-                <a:latin typeface="Calibri" pitchFamily="34" charset="0"/>
-                <a:ea typeface="Calibri" pitchFamily="34" charset="-122"/>
-                <a:cs typeface="Calibri" pitchFamily="34" charset="-120"/>
-              </a:rPr>
-              <a:t>Beziehung zum System noch offen (Kontextabgrenzung)</a:t>
-            </a:r>
-            <a:endParaRPr lang="en-US" sz="950" dirty="0"/>
-          </a:p>
-        </p:txBody>
-      </p:sp>
-      <p:sp>
-        <p:nvSpPr>
-          <p:cNvPr id="68" name="Shape 66"/>
-          <p:cNvSpPr/>
-          <p:nvPr/>
-        </p:nvSpPr>
-        <p:spPr>
-          <a:xfrm>
-            <a:off x="10122408" y="1737360"/>
-            <a:ext cx="1517904" cy="960120"/>
-          </a:xfrm>
-          <a:prstGeom prst="roundRect">
-            <a:avLst>
-              <a:gd name="adj" fmla="val 5714"/>
-            </a:avLst>
-          </a:prstGeom>
-          <a:solidFill>
-            <a:srgbClr val="F5F7F4"/>
-          </a:solidFill>
-          <a:ln w="9525">
-            <a:solidFill>
-              <a:srgbClr val="C9D1C9"/>
-            </a:solidFill>
-            <a:prstDash val="dash"/>
-          </a:ln>
-        </p:spPr>
-      </p:sp>
-      <p:sp>
-        <p:nvSpPr>
-          <p:cNvPr id="69" name="Text 67"/>
-          <p:cNvSpPr txBox="1"/>
-          <p:nvPr/>
-        </p:nvSpPr>
-        <p:spPr>
-          <a:xfrm>
-            <a:off x="10177272" y="1773936"/>
-            <a:ext cx="1408176" cy="886968"/>
+            <a:off x="10479024" y="2788920"/>
+            <a:ext cx="1124712" cy="914400"/>
           </a:xfrm>
           <a:prstGeom prst="rect">
             <a:avLst/>
@@ -3579,7 +3757,7 @@
               <a:buNone/>
             </a:pPr>
             <a:r>
-              <a:rPr lang="en-US" sz="850" b="1" dirty="0">
+              <a:rPr lang="en-US" sz="800" b="1" dirty="0">
                 <a:solidFill>
                   <a:srgbClr val="5C6B5C"/>
                 </a:solidFill>
@@ -3587,9 +3765,9 @@
                 <a:ea typeface="Calibri" pitchFamily="34" charset="-122"/>
                 <a:cs typeface="Calibri" pitchFamily="34" charset="-120"/>
               </a:rPr>
-              <a:t>Prüfungsverwaltung THM</a:t>
-            </a:r>
-            <a:endParaRPr lang="en-US" sz="850" dirty="0"/>
+              <a:t>Unternehmen der Studierenden</a:t>
+            </a:r>
+            <a:endParaRPr lang="en-US" sz="800" dirty="0"/>
           </a:p>
           <a:p>
             <a:pPr indent="0" marL="0">
@@ -3607,26 +3785,26 @@
                 <a:ea typeface="Calibri" pitchFamily="34" charset="-122"/>
                 <a:cs typeface="Calibri" pitchFamily="34" charset="-120"/>
               </a:rPr>
-              <a:t>Modulstand für die Zulassungsprüfung: manuell oder Schnittstelle?</a:t>
-            </a:r>
-            <a:endParaRPr lang="en-US" sz="850" dirty="0"/>
-          </a:p>
-        </p:txBody>
-      </p:sp>
-      <p:sp>
-        <p:nvSpPr>
-          <p:cNvPr id="70" name="Shape 68"/>
-          <p:cNvSpPr/>
-          <p:nvPr/>
-        </p:nvSpPr>
-        <p:spPr>
-          <a:xfrm>
-            <a:off x="10122408" y="2816352"/>
-            <a:ext cx="1517904" cy="960120"/>
+              <a:t>Bei externer Thesis und Verlängerung: nur Datenfeld oder Beteiligter?</a:t>
+            </a:r>
+            <a:endParaRPr lang="en-US" sz="800" dirty="0"/>
+          </a:p>
+        </p:txBody>
+      </p:sp>
+      <p:sp>
+        <p:nvSpPr>
+          <p:cNvPr id="76" name="Shape 74"/>
+          <p:cNvSpPr/>
+          <p:nvPr/>
+        </p:nvSpPr>
+        <p:spPr>
+          <a:xfrm>
+            <a:off x="10424160" y="3840480"/>
+            <a:ext cx="1234440" cy="987552"/>
           </a:xfrm>
           <a:prstGeom prst="roundRect">
             <a:avLst>
-              <a:gd name="adj" fmla="val 5714"/>
+              <a:gd name="adj" fmla="val 5556"/>
             </a:avLst>
           </a:prstGeom>
           <a:solidFill>
@@ -3642,14 +3820,14 @@
       </p:sp>
       <p:sp>
         <p:nvSpPr>
-          <p:cNvPr id="71" name="Text 69"/>
+          <p:cNvPr id="77" name="Text 75"/>
           <p:cNvSpPr txBox="1"/>
           <p:nvPr/>
         </p:nvSpPr>
         <p:spPr>
           <a:xfrm>
-            <a:off x="10177272" y="2852928"/>
-            <a:ext cx="1408176" cy="886968"/>
+            <a:off x="10479024" y="3886200"/>
+            <a:ext cx="1124712" cy="914400"/>
           </a:xfrm>
           <a:prstGeom prst="rect">
             <a:avLst/>
@@ -3668,7 +3846,7 @@
               <a:buNone/>
             </a:pPr>
             <a:r>
-              <a:rPr lang="en-US" sz="850" b="1" dirty="0">
+              <a:rPr lang="en-US" sz="800" b="1" dirty="0">
                 <a:solidFill>
                   <a:srgbClr val="5C6B5C"/>
                 </a:solidFill>
@@ -3676,9 +3854,9 @@
                 <a:ea typeface="Calibri" pitchFamily="34" charset="-122"/>
                 <a:cs typeface="Calibri" pitchFamily="34" charset="-120"/>
               </a:rPr>
-              <a:t>Unternehmen der Studierenden</a:t>
-            </a:r>
-            <a:endParaRPr lang="en-US" sz="850" dirty="0"/>
+              <a:t>Moodle / Lernplattform</a:t>
+            </a:r>
+            <a:endParaRPr lang="en-US" sz="800" dirty="0"/>
           </a:p>
           <a:p>
             <a:pPr indent="0" marL="0">
@@ -3696,26 +3874,26 @@
                 <a:ea typeface="Calibri" pitchFamily="34" charset="-122"/>
                 <a:cs typeface="Calibri" pitchFamily="34" charset="-120"/>
               </a:rPr>
-              <a:t>Firma bei externer Thesis und Verlängerung: nur Datenfeld oder Beteiligter?</a:t>
-            </a:r>
-            <a:endParaRPr lang="en-US" sz="850" dirty="0"/>
-          </a:p>
-        </p:txBody>
-      </p:sp>
-      <p:sp>
-        <p:nvSpPr>
-          <p:cNvPr id="72" name="Shape 70"/>
-          <p:cNvSpPr/>
-          <p:nvPr/>
-        </p:nvSpPr>
-        <p:spPr>
-          <a:xfrm>
-            <a:off x="10122408" y="3895344"/>
-            <a:ext cx="1517904" cy="960120"/>
+              <a:t>Kolloquium und Betreuung laufen dort, nicht im Portal?</a:t>
+            </a:r>
+            <a:endParaRPr lang="en-US" sz="800" dirty="0"/>
+          </a:p>
+        </p:txBody>
+      </p:sp>
+      <p:sp>
+        <p:nvSpPr>
+          <p:cNvPr id="78" name="Shape 76"/>
+          <p:cNvSpPr/>
+          <p:nvPr/>
+        </p:nvSpPr>
+        <p:spPr>
+          <a:xfrm>
+            <a:off x="10424160" y="4937760"/>
+            <a:ext cx="1234440" cy="987552"/>
           </a:xfrm>
           <a:prstGeom prst="roundRect">
             <a:avLst>
-              <a:gd name="adj" fmla="val 5714"/>
+              <a:gd name="adj" fmla="val 5556"/>
             </a:avLst>
           </a:prstGeom>
           <a:solidFill>
@@ -3731,14 +3909,14 @@
       </p:sp>
       <p:sp>
         <p:nvSpPr>
-          <p:cNvPr id="73" name="Text 71"/>
+          <p:cNvPr id="79" name="Text 77"/>
           <p:cNvSpPr txBox="1"/>
           <p:nvPr/>
         </p:nvSpPr>
         <p:spPr>
           <a:xfrm>
-            <a:off x="10177272" y="3931920"/>
-            <a:ext cx="1408176" cy="886968"/>
+            <a:off x="10479024" y="4983480"/>
+            <a:ext cx="1124712" cy="914400"/>
           </a:xfrm>
           <a:prstGeom prst="rect">
             <a:avLst/>
@@ -3757,7 +3935,7 @@
               <a:buNone/>
             </a:pPr>
             <a:r>
-              <a:rPr lang="en-US" sz="850" b="1" dirty="0">
+              <a:rPr lang="en-US" sz="800" b="1" dirty="0">
                 <a:solidFill>
                   <a:srgbClr val="5C6B5C"/>
                 </a:solidFill>
@@ -3765,9 +3943,9 @@
                 <a:ea typeface="Calibri" pitchFamily="34" charset="-122"/>
                 <a:cs typeface="Calibri" pitchFamily="34" charset="-120"/>
               </a:rPr>
-              <a:t>Moodle / Lernplattform</a:t>
-            </a:r>
-            <a:endParaRPr lang="en-US" sz="850" dirty="0"/>
+              <a:t>Papierakte / Postadresse</a:t>
+            </a:r>
+            <a:endParaRPr lang="en-US" sz="800" dirty="0"/>
           </a:p>
           <a:p>
             <a:pPr indent="0" marL="0">
@@ -3785,110 +3963,21 @@
                 <a:ea typeface="Calibri" pitchFamily="34" charset="-122"/>
                 <a:cs typeface="Calibri" pitchFamily="34" charset="-120"/>
               </a:rPr>
-              <a:t>Kolloquium und Betreuung laufen dort, nicht im Portal?</a:t>
-            </a:r>
-            <a:endParaRPr lang="en-US" sz="850" dirty="0"/>
-          </a:p>
-        </p:txBody>
-      </p:sp>
-      <p:sp>
-        <p:nvSpPr>
-          <p:cNvPr id="74" name="Shape 72"/>
-          <p:cNvSpPr/>
-          <p:nvPr/>
-        </p:nvSpPr>
-        <p:spPr>
-          <a:xfrm>
-            <a:off x="10122408" y="4974336"/>
-            <a:ext cx="1517904" cy="960120"/>
-          </a:xfrm>
-          <a:prstGeom prst="roundRect">
-            <a:avLst>
-              <a:gd name="adj" fmla="val 5714"/>
-            </a:avLst>
-          </a:prstGeom>
-          <a:solidFill>
-            <a:srgbClr val="F5F7F4"/>
-          </a:solidFill>
-          <a:ln w="9525">
-            <a:solidFill>
-              <a:srgbClr val="C9D1C9"/>
-            </a:solidFill>
-            <a:prstDash val="dash"/>
-          </a:ln>
-        </p:spPr>
-      </p:sp>
-      <p:sp>
-        <p:nvSpPr>
-          <p:cNvPr id="75" name="Text 73"/>
-          <p:cNvSpPr txBox="1"/>
-          <p:nvPr/>
-        </p:nvSpPr>
-        <p:spPr>
-          <a:xfrm>
-            <a:off x="10177272" y="5010912"/>
-            <a:ext cx="1408176" cy="886968"/>
-          </a:xfrm>
-          <a:prstGeom prst="rect">
-            <a:avLst/>
-          </a:prstGeom>
-          <a:noFill/>
-          <a:ln/>
-        </p:spPr>
-        <p:txBody>
-          <a:bodyPr wrap="square" lIns="0" tIns="0" rIns="0" bIns="0" rtlCol="0" anchor="t"/>
-          <a:lstStyle/>
-          <a:p>
-            <a:pPr indent="0" marL="0">
-              <a:lnSpc>
-                <a:spcPct val="105000"/>
-              </a:lnSpc>
-              <a:buNone/>
-            </a:pPr>
-            <a:r>
-              <a:rPr lang="en-US" sz="850" b="1" dirty="0">
-                <a:solidFill>
-                  <a:srgbClr val="5C6B5C"/>
-                </a:solidFill>
-                <a:latin typeface="Calibri" pitchFamily="34" charset="0"/>
-                <a:ea typeface="Calibri" pitchFamily="34" charset="-122"/>
-                <a:cs typeface="Calibri" pitchFamily="34" charset="-120"/>
-              </a:rPr>
-              <a:t>Postadresse / Papierakte</a:t>
-            </a:r>
-            <a:endParaRPr lang="en-US" sz="850" dirty="0"/>
-          </a:p>
-          <a:p>
-            <a:pPr indent="0" marL="0">
-              <a:lnSpc>
-                <a:spcPct val="105000"/>
-              </a:lnSpc>
-              <a:buNone/>
-            </a:pPr>
-            <a:r>
-              <a:rPr lang="en-US" sz="700" dirty="0">
-                <a:solidFill>
-                  <a:srgbClr val="8A968A"/>
-                </a:solidFill>
-                <a:latin typeface="Calibri" pitchFamily="34" charset="0"/>
-                <a:ea typeface="Calibri" pitchFamily="34" charset="-122"/>
-                <a:cs typeface="Calibri" pitchFamily="34" charset="-120"/>
-              </a:rPr>
-              <a:t>Entfällt in der Soll-Perspektive, falls Akte digital geführt wird.</a:t>
-            </a:r>
-            <a:endParaRPr lang="en-US" sz="850" dirty="0"/>
-          </a:p>
-        </p:txBody>
-      </p:sp>
-      <p:sp>
-        <p:nvSpPr>
-          <p:cNvPr id="76" name="Shape 74"/>
-          <p:cNvSpPr/>
-          <p:nvPr/>
-        </p:nvSpPr>
-        <p:spPr>
-          <a:xfrm>
-            <a:off x="457200" y="6309360"/>
+              <a:t>Entfällt, falls die Akte digital geführt wird.</a:t>
+            </a:r>
+            <a:endParaRPr lang="en-US" sz="800" dirty="0"/>
+          </a:p>
+        </p:txBody>
+      </p:sp>
+      <p:sp>
+        <p:nvSpPr>
+          <p:cNvPr id="80" name="Shape 78"/>
+          <p:cNvSpPr/>
+          <p:nvPr/>
+        </p:nvSpPr>
+        <p:spPr>
+          <a:xfrm>
+            <a:off x="457200" y="6355080"/>
             <a:ext cx="292608" cy="182880"/>
           </a:xfrm>
           <a:prstGeom prst="roundRect">
@@ -3909,14 +3998,14 @@
       </p:sp>
       <p:sp>
         <p:nvSpPr>
-          <p:cNvPr id="77" name="Text 75"/>
+          <p:cNvPr id="81" name="Text 79"/>
           <p:cNvSpPr txBox="1"/>
           <p:nvPr/>
         </p:nvSpPr>
         <p:spPr>
           <a:xfrm>
-            <a:off x="804672" y="6263640"/>
-            <a:ext cx="1371600" cy="274320"/>
+            <a:off x="804672" y="6309360"/>
+            <a:ext cx="1280160" cy="274320"/>
           </a:xfrm>
           <a:prstGeom prst="rect">
             <a:avLst/>
@@ -3948,13 +4037,13 @@
       </p:sp>
       <p:sp>
         <p:nvSpPr>
-          <p:cNvPr id="78" name="Shape 76"/>
-          <p:cNvSpPr/>
-          <p:nvPr/>
-        </p:nvSpPr>
-        <p:spPr>
-          <a:xfrm>
-            <a:off x="1828800" y="6309360"/>
+          <p:cNvPr id="82" name="Shape 80"/>
+          <p:cNvSpPr/>
+          <p:nvPr/>
+        </p:nvSpPr>
+        <p:spPr>
+          <a:xfrm>
+            <a:off x="1737360" y="6355080"/>
             <a:ext cx="292608" cy="182880"/>
           </a:xfrm>
           <a:prstGeom prst="roundRect">
@@ -3975,14 +4064,14 @@
       </p:sp>
       <p:sp>
         <p:nvSpPr>
-          <p:cNvPr id="79" name="Text 77"/>
+          <p:cNvPr id="83" name="Text 81"/>
           <p:cNvSpPr txBox="1"/>
           <p:nvPr/>
         </p:nvSpPr>
         <p:spPr>
           <a:xfrm>
-            <a:off x="2176272" y="6263640"/>
-            <a:ext cx="1371600" cy="274320"/>
+            <a:off x="2084832" y="6309360"/>
+            <a:ext cx="1280160" cy="274320"/>
           </a:xfrm>
           <a:prstGeom prst="rect">
             <a:avLst/>
@@ -4014,13 +4103,13 @@
       </p:sp>
       <p:sp>
         <p:nvSpPr>
-          <p:cNvPr id="80" name="Shape 78"/>
-          <p:cNvSpPr/>
-          <p:nvPr/>
-        </p:nvSpPr>
-        <p:spPr>
-          <a:xfrm>
-            <a:off x="3291840" y="6309360"/>
+          <p:cNvPr id="84" name="Shape 82"/>
+          <p:cNvSpPr/>
+          <p:nvPr/>
+        </p:nvSpPr>
+        <p:spPr>
+          <a:xfrm>
+            <a:off x="3108960" y="6355080"/>
             <a:ext cx="292608" cy="182880"/>
           </a:xfrm>
           <a:prstGeom prst="roundRect">
@@ -4041,14 +4130,14 @@
       </p:sp>
       <p:sp>
         <p:nvSpPr>
-          <p:cNvPr id="81" name="Text 79"/>
+          <p:cNvPr id="85" name="Text 83"/>
           <p:cNvSpPr txBox="1"/>
           <p:nvPr/>
         </p:nvSpPr>
         <p:spPr>
           <a:xfrm>
-            <a:off x="3639312" y="6263640"/>
-            <a:ext cx="1371600" cy="274320"/>
+            <a:off x="3456432" y="6309360"/>
+            <a:ext cx="1280160" cy="274320"/>
           </a:xfrm>
           <a:prstGeom prst="rect">
             <a:avLst/>
@@ -4080,13 +4169,13 @@
       </p:sp>
       <p:sp>
         <p:nvSpPr>
-          <p:cNvPr id="82" name="Shape 80"/>
-          <p:cNvSpPr/>
-          <p:nvPr/>
-        </p:nvSpPr>
-        <p:spPr>
-          <a:xfrm>
-            <a:off x="4389120" y="6309360"/>
+          <p:cNvPr id="86" name="Shape 84"/>
+          <p:cNvSpPr/>
+          <p:nvPr/>
+        </p:nvSpPr>
+        <p:spPr>
+          <a:xfrm>
+            <a:off x="4114800" y="6355080"/>
             <a:ext cx="292608" cy="182880"/>
           </a:xfrm>
           <a:prstGeom prst="roundRect">
@@ -4107,14 +4196,14 @@
       </p:sp>
       <p:sp>
         <p:nvSpPr>
-          <p:cNvPr id="83" name="Text 81"/>
+          <p:cNvPr id="87" name="Text 85"/>
           <p:cNvSpPr txBox="1"/>
           <p:nvPr/>
         </p:nvSpPr>
         <p:spPr>
           <a:xfrm>
-            <a:off x="4736592" y="6263640"/>
-            <a:ext cx="1371600" cy="274320"/>
+            <a:off x="4462272" y="6309360"/>
+            <a:ext cx="1280160" cy="274320"/>
           </a:xfrm>
           <a:prstGeom prst="rect">
             <a:avLst/>
@@ -4146,13 +4235,13 @@
       </p:sp>
       <p:sp>
         <p:nvSpPr>
-          <p:cNvPr id="84" name="Shape 82"/>
-          <p:cNvSpPr/>
-          <p:nvPr/>
-        </p:nvSpPr>
-        <p:spPr>
-          <a:xfrm>
-            <a:off x="5486400" y="6400800"/>
+          <p:cNvPr id="88" name="Shape 86"/>
+          <p:cNvSpPr/>
+          <p:nvPr/>
+        </p:nvSpPr>
+        <p:spPr>
+          <a:xfrm>
+            <a:off x="5120640" y="6446520"/>
             <a:ext cx="365760" cy="914"/>
           </a:xfrm>
           <a:prstGeom prst="line">
@@ -4170,13 +4259,13 @@
       </p:sp>
       <p:sp>
         <p:nvSpPr>
-          <p:cNvPr id="85" name="Text 83"/>
+          <p:cNvPr id="89" name="Text 87"/>
           <p:cNvSpPr txBox="1"/>
           <p:nvPr/>
         </p:nvSpPr>
         <p:spPr>
           <a:xfrm>
-            <a:off x="5897880" y="6263640"/>
+            <a:off x="5532120" y="6309360"/>
             <a:ext cx="1554480" cy="274320"/>
           </a:xfrm>
           <a:prstGeom prst="rect">
@@ -4209,13 +4298,13 @@
       </p:sp>
       <p:sp>
         <p:nvSpPr>
-          <p:cNvPr id="86" name="Shape 84"/>
-          <p:cNvSpPr/>
-          <p:nvPr/>
-        </p:nvSpPr>
-        <p:spPr>
-          <a:xfrm>
-            <a:off x="7498080" y="6400800"/>
+          <p:cNvPr id="90" name="Shape 88"/>
+          <p:cNvSpPr/>
+          <p:nvPr/>
+        </p:nvSpPr>
+        <p:spPr>
+          <a:xfrm>
+            <a:off x="7132320" y="6446520"/>
             <a:ext cx="365760" cy="914"/>
           </a:xfrm>
           <a:prstGeom prst="line">
@@ -4233,13 +4322,13 @@
       </p:sp>
       <p:sp>
         <p:nvSpPr>
-          <p:cNvPr id="87" name="Text 85"/>
+          <p:cNvPr id="91" name="Text 89"/>
           <p:cNvSpPr txBox="1"/>
           <p:nvPr/>
         </p:nvSpPr>
         <p:spPr>
           <a:xfrm>
-            <a:off x="7909560" y="6263640"/>
+            <a:off x="7543800" y="6309360"/>
             <a:ext cx="1737360" cy="274320"/>
           </a:xfrm>
           <a:prstGeom prst="rect">
@@ -4272,14 +4361,14 @@
       </p:sp>
       <p:sp>
         <p:nvSpPr>
-          <p:cNvPr id="88" name="Text 86"/>
+          <p:cNvPr id="92" name="Text 90"/>
           <p:cNvSpPr txBox="1"/>
           <p:nvPr/>
         </p:nvSpPr>
         <p:spPr>
           <a:xfrm>
-            <a:off x="9601200" y="6263640"/>
-            <a:ext cx="2148840" cy="274320"/>
+            <a:off x="9326880" y="6309360"/>
+            <a:ext cx="2423160" cy="274320"/>
           </a:xfrm>
           <a:prstGeom prst="rect">
             <a:avLst/>

</xml_diff>

<commit_message>
Ist-Kontextdiagramm als Folie 2: Laufweg des Formulars statt Systemkasten
Co-Authored-By: Claude Fable 5.1 <noreply@anthropic.com>
</commit_message>
<xml_diff>
--- a/Kontextdiagramm_ThesisFlow_v2.pptx
+++ b/Kontextdiagramm_ThesisFlow_v2.pptx
@@ -6,9 +6,10 @@
   </p:sldMasterIdLst>
   <p:sldIdLst>
     <p:sldId id="256" r:id="rId2"/>
+    <p:sldId id="257" r:id="rId3"/>
   </p:sldIdLst>
   <p:notesMasterIdLst>
-    <p:notesMasterId r:id="rId3"/>
+    <p:notesMasterId r:id="rId4"/>
   </p:notesMasterIdLst>
   <p:sldSz cx="12192000" cy="6858000"/>
   <p:notesSz cx="6858000" cy="12192000"/>
@@ -547,6 +548,94 @@
 </p:notes>
 </file>
 
+<file path=ppt/notesSlides/notesSlide2.xml><?xml version="1.0" encoding="utf-8"?>
+<p:notes xmlns:a="http://schemas.openxmlformats.org/drawingml/2006/main" xmlns:r="http://schemas.openxmlformats.org/officeDocument/2006/relationships" xmlns:p="http://schemas.openxmlformats.org/presentationml/2006/main">
+  <p:cSld>
+    <p:spTree>
+      <p:nvGrpSpPr>
+        <p:cNvPr id="1" name=""/>
+        <p:cNvGrpSpPr/>
+        <p:nvPr/>
+      </p:nvGrpSpPr>
+      <p:grpSpPr>
+        <a:xfrm>
+          <a:off x="0" y="0"/>
+          <a:ext cx="0" cy="0"/>
+          <a:chOff x="0" y="0"/>
+          <a:chExt cx="0" cy="0"/>
+        </a:xfrm>
+      </p:grpSpPr>
+      <p:sp>
+        <p:nvSpPr>
+          <p:cNvPr id="2" name="Slide Image Placeholder 1"/>
+          <p:cNvSpPr>
+            <a:spLocks noGrp="1" noRot="1" noChangeAspect="1"/>
+          </p:cNvSpPr>
+          <p:nvPr>
+            <p:ph type="sldImg"/>
+          </p:nvPr>
+        </p:nvSpPr>
+        <p:spPr/>
+      </p:sp>
+      <p:sp>
+        <p:nvSpPr>
+          <p:cNvPr id="3" name="Notes Placeholder 2"/>
+          <p:cNvSpPr>
+            <a:spLocks noGrp="1"/>
+          </p:cNvSpPr>
+          <p:nvPr>
+            <p:ph type="body" idx="1"/>
+          </p:nvPr>
+        </p:nvSpPr>
+        <p:spPr/>
+        <p:txBody>
+          <a:bodyPr/>
+          <a:lstStyle/>
+          <a:p>
+            <a:r>
+              <a:rPr lang="en-US" dirty="0"/>
+              <a:t>Ist-Zustand: kein System, sondern der Laufweg des PDF-Antragsformulars. Die Schritte 1 bis 7 entsprechen den Hinweisen zur Bearbeitung im Zulassungsantrag: 1 Erstprüfer mailt das Formular, 2 Studierende füllen aus und unterschreiben (externe Korreferenten zusätzlich mit Formular Externe Prüfende und Urkunde), 3 Zweitprüfer unterschreibt und mailt ans Dekanat, 4 Sekretariat prüft Zulassung und Qualifikation, PA-Vorsitz entscheidet, 5 Erstprüfer trägt die Ausgabe ein, 6 Formular zurück ans Sekretariat, Fristprüfung und Ablage, 7 Sekretariat informiert Studierende. Verlängerung läuft als eigener Papierantrag an den Studienausschuss WI. Die Abgrenzung des Systems erfolgt laut Vorlesung in der Soll-Perspektive (Folie 1); diese Folie belegt die Schwachstellen.</a:t>
+            </a:r>
+            <a:endParaRPr lang="en-US" dirty="0"/>
+          </a:p>
+        </p:txBody>
+      </p:sp>
+      <p:sp>
+        <p:nvSpPr>
+          <p:cNvPr id="4" name="Slide Number Placeholder 3"/>
+          <p:cNvSpPr>
+            <a:spLocks noGrp="1"/>
+          </p:cNvSpPr>
+          <p:nvPr>
+            <p:ph type="sldNum" sz="quarter" idx="10"/>
+          </p:nvPr>
+        </p:nvSpPr>
+        <p:spPr/>
+        <p:txBody>
+          <a:bodyPr/>
+          <a:lstStyle/>
+          <a:p>
+            <a:fld id="{F7021451-1387-4CA6-816F-3879F97B5CBC}" type="slidenum">
+              <a:rPr lang="en-US"/>
+              <a:t>2</a:t>
+            </a:fld>
+            <a:endParaRPr lang="en-US"/>
+          </a:p>
+        </p:txBody>
+      </p:sp>
+    </p:spTree>
+    <p:extLst>
+      <p:ext uri="{BB962C8B-B14F-4D97-AF65-F5344CB8AC3E}">
+        <p14:creationId xmlns:p14="http://schemas.microsoft.com/office/powerpoint/2010/main" val="1024086991"/>
+      </p:ext>
+    </p:extLst>
+  </p:cSld>
+  <p:clrMapOvr>
+    <a:masterClrMapping/>
+  </p:clrMapOvr>
+</p:notes>
+</file>
+
 <file path=ppt/slideLayouts/slideLayout1.xml><?xml version="1.0" encoding="utf-8"?>
 <p:sldLayout xmlns:a="http://schemas.openxmlformats.org/drawingml/2006/main" xmlns:r="http://schemas.openxmlformats.org/officeDocument/2006/relationships" xmlns:p="http://schemas.openxmlformats.org/presentationml/2006/main" preserve="1">
   <p:cSld name="DEFAULT">
@@ -4393,6 +4482,3409 @@
                 <a:cs typeface="Calibri" pitchFamily="34" charset="-120"/>
               </a:rPr>
               <a:t>Quellen: Zulassungsantrag WS23/24, Anlage ext. Prüfer, PO B.Sc./M.Sc. WI 2024, Vorlesung Kap. 2</a:t>
+            </a:r>
+            <a:endParaRPr lang="en-US" sz="650" dirty="0"/>
+          </a:p>
+        </p:txBody>
+      </p:sp>
+    </p:spTree>
+  </p:cSld>
+  <p:clrMapOvr>
+    <a:masterClrMapping/>
+  </p:clrMapOvr>
+</p:sld>
+</file>
+
+<file path=ppt/slides/slide2.xml><?xml version="1.0" encoding="utf-8"?>
+<p:sld xmlns:a="http://schemas.openxmlformats.org/drawingml/2006/main" xmlns:r="http://schemas.openxmlformats.org/officeDocument/2006/relationships" xmlns:p="http://schemas.openxmlformats.org/presentationml/2006/main">
+  <p:cSld name="Slide 2">
+    <p:bg>
+      <p:bgPr>
+        <a:solidFill>
+          <a:srgbClr val="FFFFFF"/>
+        </a:solidFill>
+      </p:bgPr>
+    </p:bg>
+    <p:spTree>
+      <p:nvGrpSpPr>
+        <p:cNvPr id="1" name=""/>
+        <p:cNvGrpSpPr/>
+        <p:nvPr/>
+      </p:nvGrpSpPr>
+      <p:grpSpPr>
+        <a:xfrm>
+          <a:off x="0" y="0"/>
+          <a:ext cx="0" cy="0"/>
+          <a:chOff x="0" y="0"/>
+          <a:chExt cx="0" cy="0"/>
+        </a:xfrm>
+      </p:grpSpPr>
+      <p:sp>
+        <p:nvSpPr>
+          <p:cNvPr id="2" name="Text 0"/>
+          <p:cNvSpPr txBox="1"/>
+          <p:nvPr/>
+        </p:nvSpPr>
+        <p:spPr>
+          <a:xfrm>
+            <a:off x="457200" y="182880"/>
+            <a:ext cx="7315200" cy="438912"/>
+          </a:xfrm>
+          <a:prstGeom prst="rect">
+            <a:avLst/>
+          </a:prstGeom>
+          <a:noFill/>
+          <a:ln/>
+        </p:spPr>
+        <p:txBody>
+          <a:bodyPr wrap="square" lIns="0" tIns="0" rIns="0" bIns="0" rtlCol="0" anchor="ctr"/>
+          <a:lstStyle/>
+          <a:p>
+            <a:pPr indent="0" marL="0">
+              <a:buNone/>
+            </a:pPr>
+            <a:r>
+              <a:rPr lang="en-US" sz="2400" b="1" dirty="0">
+                <a:solidFill>
+                  <a:srgbClr val="1F2A1F"/>
+                </a:solidFill>
+                <a:latin typeface="Cambria" pitchFamily="34" charset="0"/>
+                <a:ea typeface="Cambria" pitchFamily="34" charset="-122"/>
+                <a:cs typeface="Cambria" pitchFamily="34" charset="-120"/>
+              </a:rPr>
+              <a:t>Kontextdiagramm Ist-Zustand</a:t>
+            </a:r>
+            <a:endParaRPr lang="en-US" sz="2400" dirty="0"/>
+          </a:p>
+        </p:txBody>
+      </p:sp>
+      <p:sp>
+        <p:nvSpPr>
+          <p:cNvPr id="3" name="Text 1"/>
+          <p:cNvSpPr txBox="1"/>
+          <p:nvPr/>
+        </p:nvSpPr>
+        <p:spPr>
+          <a:xfrm>
+            <a:off x="457200" y="603504"/>
+            <a:ext cx="9144000" cy="228600"/>
+          </a:xfrm>
+          <a:prstGeom prst="rect">
+            <a:avLst/>
+          </a:prstGeom>
+          <a:noFill/>
+          <a:ln/>
+        </p:spPr>
+        <p:txBody>
+          <a:bodyPr wrap="square" lIns="0" tIns="0" rIns="0" bIns="0" rtlCol="0" anchor="ctr"/>
+          <a:lstStyle/>
+          <a:p>
+            <a:pPr indent="0" marL="0">
+              <a:buNone/>
+            </a:pPr>
+            <a:r>
+              <a:rPr lang="en-US" sz="1050" dirty="0">
+                <a:solidFill>
+                  <a:srgbClr val="5C6B5C"/>
+                </a:solidFill>
+                <a:latin typeface="Calibri" pitchFamily="34" charset="0"/>
+                <a:ea typeface="Calibri" pitchFamily="34" charset="-122"/>
+                <a:cs typeface="Calibri" pitchFamily="34" charset="-120"/>
+              </a:rPr>
+              <a:t>Heute gibt es kein System: das PDF-Formular wandert in sieben Übergaben per E-Mail, Papier und Scan zwischen den Beteiligten</a:t>
+            </a:r>
+            <a:endParaRPr lang="en-US" sz="1050" dirty="0"/>
+          </a:p>
+        </p:txBody>
+      </p:sp>
+      <p:sp>
+        <p:nvSpPr>
+          <p:cNvPr id="4" name="Text 2"/>
+          <p:cNvSpPr txBox="1"/>
+          <p:nvPr/>
+        </p:nvSpPr>
+        <p:spPr>
+          <a:xfrm>
+            <a:off x="8046720" y="256032"/>
+            <a:ext cx="3703320" cy="274320"/>
+          </a:xfrm>
+          <a:prstGeom prst="rect">
+            <a:avLst/>
+          </a:prstGeom>
+          <a:noFill/>
+          <a:ln/>
+        </p:spPr>
+        <p:txBody>
+          <a:bodyPr wrap="square" lIns="0" tIns="0" rIns="0" bIns="0" rtlCol="0" anchor="ctr"/>
+          <a:lstStyle/>
+          <a:p>
+            <a:pPr algn="r" indent="0" marL="0">
+              <a:buNone/>
+            </a:pPr>
+            <a:r>
+              <a:rPr lang="en-US" sz="800" b="1" spc="150" kern="0" dirty="0">
+                <a:solidFill>
+                  <a:srgbClr val="97BC62"/>
+                </a:solidFill>
+                <a:latin typeface="Calibri" pitchFamily="34" charset="0"/>
+                <a:ea typeface="Calibri" pitchFamily="34" charset="-122"/>
+                <a:cs typeface="Calibri" pitchFamily="34" charset="-120"/>
+              </a:rPr>
+              <a:t>REQUIREMENTS ENGINEERING  ·  GRUPPE GRÜN  ·  STAND 30.09.2026</a:t>
+            </a:r>
+            <a:endParaRPr lang="en-US" sz="800" dirty="0"/>
+          </a:p>
+        </p:txBody>
+      </p:sp>
+      <p:sp>
+        <p:nvSpPr>
+          <p:cNvPr id="5" name="Shape 3"/>
+          <p:cNvSpPr/>
+          <p:nvPr/>
+        </p:nvSpPr>
+        <p:spPr>
+          <a:xfrm>
+            <a:off x="457200" y="896112"/>
+            <a:ext cx="9509760" cy="4526280"/>
+          </a:xfrm>
+          <a:prstGeom prst="roundRect">
+            <a:avLst>
+              <a:gd name="adj" fmla="val 4040"/>
+            </a:avLst>
+          </a:prstGeom>
+          <a:solidFill>
+            <a:srgbClr val="F5F7F4"/>
+          </a:solidFill>
+          <a:ln w="15875">
+            <a:solidFill>
+              <a:srgbClr val="97BC62"/>
+            </a:solidFill>
+            <a:prstDash val="dash"/>
+          </a:ln>
+        </p:spPr>
+      </p:sp>
+      <p:sp>
+        <p:nvSpPr>
+          <p:cNvPr id="6" name="Text 4"/>
+          <p:cNvSpPr txBox="1"/>
+          <p:nvPr/>
+        </p:nvSpPr>
+        <p:spPr>
+          <a:xfrm>
+            <a:off x="640080" y="932688"/>
+            <a:ext cx="4572000" cy="201168"/>
+          </a:xfrm>
+          <a:prstGeom prst="rect">
+            <a:avLst/>
+          </a:prstGeom>
+          <a:noFill/>
+          <a:ln/>
+        </p:spPr>
+        <p:txBody>
+          <a:bodyPr wrap="square" lIns="0" tIns="0" rIns="0" bIns="0" rtlCol="0" anchor="ctr"/>
+          <a:lstStyle/>
+          <a:p>
+            <a:pPr indent="0" marL="0">
+              <a:buNone/>
+            </a:pPr>
+            <a:r>
+              <a:rPr lang="en-US" sz="800" b="1" i="1" dirty="0">
+                <a:solidFill>
+                  <a:srgbClr val="97BC62"/>
+                </a:solidFill>
+                <a:latin typeface="Calibri" pitchFamily="34" charset="0"/>
+                <a:ea typeface="Calibri" pitchFamily="34" charset="-122"/>
+                <a:cs typeface="Calibri" pitchFamily="34" charset="-120"/>
+              </a:rPr>
+              <a:t>Kontextgrenze  ·  Ist-Prozess (Laufweg des Antragsformulars)</a:t>
+            </a:r>
+            <a:endParaRPr lang="en-US" sz="800" dirty="0"/>
+          </a:p>
+        </p:txBody>
+      </p:sp>
+      <p:sp>
+        <p:nvSpPr>
+          <p:cNvPr id="7" name="Shape 5"/>
+          <p:cNvSpPr/>
+          <p:nvPr/>
+        </p:nvSpPr>
+        <p:spPr>
+          <a:xfrm>
+            <a:off x="914400" y="1371600"/>
+            <a:ext cx="1737360" cy="502920"/>
+          </a:xfrm>
+          <a:prstGeom prst="roundRect">
+            <a:avLst>
+              <a:gd name="adj" fmla="val 14545"/>
+            </a:avLst>
+          </a:prstGeom>
+          <a:solidFill>
+            <a:srgbClr val="EEF4E8"/>
+          </a:solidFill>
+          <a:ln w="15875">
+            <a:solidFill>
+              <a:srgbClr val="2C5F2D"/>
+            </a:solidFill>
+            <a:prstDash val="solid"/>
+          </a:ln>
+        </p:spPr>
+      </p:sp>
+      <p:sp>
+        <p:nvSpPr>
+          <p:cNvPr id="8" name="Text 6"/>
+          <p:cNvSpPr txBox="1"/>
+          <p:nvPr/>
+        </p:nvSpPr>
+        <p:spPr>
+          <a:xfrm>
+            <a:off x="914400" y="1371600"/>
+            <a:ext cx="1737360" cy="502920"/>
+          </a:xfrm>
+          <a:prstGeom prst="rect">
+            <a:avLst/>
+          </a:prstGeom>
+          <a:noFill/>
+          <a:ln/>
+        </p:spPr>
+        <p:txBody>
+          <a:bodyPr wrap="square" lIns="508" tIns="508" rIns="508" bIns="508" rtlCol="0" anchor="ctr"/>
+          <a:lstStyle/>
+          <a:p>
+            <a:pPr algn="ctr" indent="0" marL="0">
+              <a:buNone/>
+            </a:pPr>
+            <a:r>
+              <a:rPr lang="en-US" sz="950" b="1" dirty="0">
+                <a:solidFill>
+                  <a:srgbClr val="2C5F2D"/>
+                </a:solidFill>
+                <a:latin typeface="Calibri" pitchFamily="34" charset="0"/>
+                <a:ea typeface="Calibri" pitchFamily="34" charset="-122"/>
+                <a:cs typeface="Calibri" pitchFamily="34" charset="-120"/>
+              </a:rPr>
+              <a:t>Erstprüfende</a:t>
+            </a:r>
+            <a:endParaRPr lang="en-US" sz="950" dirty="0"/>
+          </a:p>
+          <a:p>
+            <a:pPr algn="ctr" indent="0" marL="0">
+              <a:buNone/>
+            </a:pPr>
+            <a:r>
+              <a:rPr lang="en-US" sz="700" dirty="0">
+                <a:solidFill>
+                  <a:srgbClr val="5C6B5C"/>
+                </a:solidFill>
+                <a:latin typeface="Calibri" pitchFamily="34" charset="0"/>
+                <a:ea typeface="Calibri" pitchFamily="34" charset="-122"/>
+                <a:cs typeface="Calibri" pitchFamily="34" charset="-120"/>
+              </a:rPr>
+              <a:t>Person / Rolle</a:t>
+            </a:r>
+            <a:endParaRPr lang="en-US" sz="950" dirty="0"/>
+          </a:p>
+        </p:txBody>
+      </p:sp>
+      <p:sp>
+        <p:nvSpPr>
+          <p:cNvPr id="9" name="Shape 7"/>
+          <p:cNvSpPr/>
+          <p:nvPr/>
+        </p:nvSpPr>
+        <p:spPr>
+          <a:xfrm>
+            <a:off x="914400" y="2926080"/>
+            <a:ext cx="1737360" cy="502920"/>
+          </a:xfrm>
+          <a:prstGeom prst="roundRect">
+            <a:avLst>
+              <a:gd name="adj" fmla="val 14545"/>
+            </a:avLst>
+          </a:prstGeom>
+          <a:solidFill>
+            <a:srgbClr val="EEF4E8"/>
+          </a:solidFill>
+          <a:ln w="15875">
+            <a:solidFill>
+              <a:srgbClr val="2C5F2D"/>
+            </a:solidFill>
+            <a:prstDash val="solid"/>
+          </a:ln>
+        </p:spPr>
+      </p:sp>
+      <p:sp>
+        <p:nvSpPr>
+          <p:cNvPr id="10" name="Text 8"/>
+          <p:cNvSpPr txBox="1"/>
+          <p:nvPr/>
+        </p:nvSpPr>
+        <p:spPr>
+          <a:xfrm>
+            <a:off x="914400" y="2926080"/>
+            <a:ext cx="1737360" cy="502920"/>
+          </a:xfrm>
+          <a:prstGeom prst="rect">
+            <a:avLst/>
+          </a:prstGeom>
+          <a:noFill/>
+          <a:ln/>
+        </p:spPr>
+        <p:txBody>
+          <a:bodyPr wrap="square" lIns="508" tIns="508" rIns="508" bIns="508" rtlCol="0" anchor="ctr"/>
+          <a:lstStyle/>
+          <a:p>
+            <a:pPr algn="ctr" indent="0" marL="0">
+              <a:buNone/>
+            </a:pPr>
+            <a:r>
+              <a:rPr lang="en-US" sz="950" b="1" dirty="0">
+                <a:solidFill>
+                  <a:srgbClr val="2C5F2D"/>
+                </a:solidFill>
+                <a:latin typeface="Calibri" pitchFamily="34" charset="0"/>
+                <a:ea typeface="Calibri" pitchFamily="34" charset="-122"/>
+                <a:cs typeface="Calibri" pitchFamily="34" charset="-120"/>
+              </a:rPr>
+              <a:t>Studierende</a:t>
+            </a:r>
+            <a:endParaRPr lang="en-US" sz="950" dirty="0"/>
+          </a:p>
+          <a:p>
+            <a:pPr algn="ctr" indent="0" marL="0">
+              <a:buNone/>
+            </a:pPr>
+            <a:r>
+              <a:rPr lang="en-US" sz="700" dirty="0">
+                <a:solidFill>
+                  <a:srgbClr val="5C6B5C"/>
+                </a:solidFill>
+                <a:latin typeface="Calibri" pitchFamily="34" charset="0"/>
+                <a:ea typeface="Calibri" pitchFamily="34" charset="-122"/>
+                <a:cs typeface="Calibri" pitchFamily="34" charset="-120"/>
+              </a:rPr>
+              <a:t>Person / Rolle</a:t>
+            </a:r>
+            <a:endParaRPr lang="en-US" sz="950" dirty="0"/>
+          </a:p>
+        </p:txBody>
+      </p:sp>
+      <p:sp>
+        <p:nvSpPr>
+          <p:cNvPr id="11" name="Shape 9"/>
+          <p:cNvSpPr/>
+          <p:nvPr/>
+        </p:nvSpPr>
+        <p:spPr>
+          <a:xfrm>
+            <a:off x="914400" y="4480560"/>
+            <a:ext cx="1737360" cy="502920"/>
+          </a:xfrm>
+          <a:prstGeom prst="roundRect">
+            <a:avLst>
+              <a:gd name="adj" fmla="val 14545"/>
+            </a:avLst>
+          </a:prstGeom>
+          <a:solidFill>
+            <a:srgbClr val="EEF4E8"/>
+          </a:solidFill>
+          <a:ln w="15875">
+            <a:solidFill>
+              <a:srgbClr val="2C5F2D"/>
+            </a:solidFill>
+            <a:prstDash val="solid"/>
+          </a:ln>
+        </p:spPr>
+      </p:sp>
+      <p:sp>
+        <p:nvSpPr>
+          <p:cNvPr id="12" name="Text 10"/>
+          <p:cNvSpPr txBox="1"/>
+          <p:nvPr/>
+        </p:nvSpPr>
+        <p:spPr>
+          <a:xfrm>
+            <a:off x="914400" y="4480560"/>
+            <a:ext cx="1737360" cy="502920"/>
+          </a:xfrm>
+          <a:prstGeom prst="rect">
+            <a:avLst/>
+          </a:prstGeom>
+          <a:noFill/>
+          <a:ln/>
+        </p:spPr>
+        <p:txBody>
+          <a:bodyPr wrap="square" lIns="508" tIns="508" rIns="508" bIns="508" rtlCol="0" anchor="ctr"/>
+          <a:lstStyle/>
+          <a:p>
+            <a:pPr algn="ctr" indent="0" marL="0">
+              <a:buNone/>
+            </a:pPr>
+            <a:r>
+              <a:rPr lang="en-US" sz="950" b="1" dirty="0">
+                <a:solidFill>
+                  <a:srgbClr val="2C5F2D"/>
+                </a:solidFill>
+                <a:latin typeface="Calibri" pitchFamily="34" charset="0"/>
+                <a:ea typeface="Calibri" pitchFamily="34" charset="-122"/>
+                <a:cs typeface="Calibri" pitchFamily="34" charset="-120"/>
+              </a:rPr>
+              <a:t>Interne Zweitprüfende</a:t>
+            </a:r>
+            <a:endParaRPr lang="en-US" sz="950" dirty="0"/>
+          </a:p>
+          <a:p>
+            <a:pPr algn="ctr" indent="0" marL="0">
+              <a:buNone/>
+            </a:pPr>
+            <a:r>
+              <a:rPr lang="en-US" sz="700" dirty="0">
+                <a:solidFill>
+                  <a:srgbClr val="5C6B5C"/>
+                </a:solidFill>
+                <a:latin typeface="Calibri" pitchFamily="34" charset="0"/>
+                <a:ea typeface="Calibri" pitchFamily="34" charset="-122"/>
+                <a:cs typeface="Calibri" pitchFamily="34" charset="-120"/>
+              </a:rPr>
+              <a:t>Person / Rolle</a:t>
+            </a:r>
+            <a:endParaRPr lang="en-US" sz="950" dirty="0"/>
+          </a:p>
+        </p:txBody>
+      </p:sp>
+      <p:sp>
+        <p:nvSpPr>
+          <p:cNvPr id="13" name="Shape 11"/>
+          <p:cNvSpPr/>
+          <p:nvPr/>
+        </p:nvSpPr>
+        <p:spPr>
+          <a:xfrm>
+            <a:off x="3108960" y="4480560"/>
+            <a:ext cx="1737360" cy="502920"/>
+          </a:xfrm>
+          <a:prstGeom prst="roundRect">
+            <a:avLst>
+              <a:gd name="adj" fmla="val 14545"/>
+            </a:avLst>
+          </a:prstGeom>
+          <a:solidFill>
+            <a:srgbClr val="EEF4E8"/>
+          </a:solidFill>
+          <a:ln w="15875">
+            <a:solidFill>
+              <a:srgbClr val="2C5F2D"/>
+            </a:solidFill>
+            <a:prstDash val="solid"/>
+          </a:ln>
+        </p:spPr>
+      </p:sp>
+      <p:sp>
+        <p:nvSpPr>
+          <p:cNvPr id="14" name="Text 12"/>
+          <p:cNvSpPr txBox="1"/>
+          <p:nvPr/>
+        </p:nvSpPr>
+        <p:spPr>
+          <a:xfrm>
+            <a:off x="3108960" y="4480560"/>
+            <a:ext cx="1737360" cy="502920"/>
+          </a:xfrm>
+          <a:prstGeom prst="rect">
+            <a:avLst/>
+          </a:prstGeom>
+          <a:noFill/>
+          <a:ln/>
+        </p:spPr>
+        <p:txBody>
+          <a:bodyPr wrap="square" lIns="508" tIns="508" rIns="508" bIns="508" rtlCol="0" anchor="ctr"/>
+          <a:lstStyle/>
+          <a:p>
+            <a:pPr algn="ctr" indent="0" marL="0">
+              <a:buNone/>
+            </a:pPr>
+            <a:r>
+              <a:rPr lang="en-US" sz="950" b="1" dirty="0">
+                <a:solidFill>
+                  <a:srgbClr val="2C5F2D"/>
+                </a:solidFill>
+                <a:latin typeface="Calibri" pitchFamily="34" charset="0"/>
+                <a:ea typeface="Calibri" pitchFamily="34" charset="-122"/>
+                <a:cs typeface="Calibri" pitchFamily="34" charset="-120"/>
+              </a:rPr>
+              <a:t>Externe Korreferenten</a:t>
+            </a:r>
+            <a:endParaRPr lang="en-US" sz="950" dirty="0"/>
+          </a:p>
+          <a:p>
+            <a:pPr algn="ctr" indent="0" marL="0">
+              <a:buNone/>
+            </a:pPr>
+            <a:r>
+              <a:rPr lang="en-US" sz="700" dirty="0">
+                <a:solidFill>
+                  <a:srgbClr val="5C6B5C"/>
+                </a:solidFill>
+                <a:latin typeface="Calibri" pitchFamily="34" charset="0"/>
+                <a:ea typeface="Calibri" pitchFamily="34" charset="-122"/>
+                <a:cs typeface="Calibri" pitchFamily="34" charset="-120"/>
+              </a:rPr>
+              <a:t>Person / Rolle</a:t>
+            </a:r>
+            <a:endParaRPr lang="en-US" sz="950" dirty="0"/>
+          </a:p>
+        </p:txBody>
+      </p:sp>
+      <p:sp>
+        <p:nvSpPr>
+          <p:cNvPr id="15" name="Shape 13"/>
+          <p:cNvSpPr/>
+          <p:nvPr/>
+        </p:nvSpPr>
+        <p:spPr>
+          <a:xfrm>
+            <a:off x="5120640" y="2926080"/>
+            <a:ext cx="1737360" cy="502920"/>
+          </a:xfrm>
+          <a:prstGeom prst="roundRect">
+            <a:avLst>
+              <a:gd name="adj" fmla="val 14545"/>
+            </a:avLst>
+          </a:prstGeom>
+          <a:solidFill>
+            <a:srgbClr val="EEF4E8"/>
+          </a:solidFill>
+          <a:ln w="15875">
+            <a:solidFill>
+              <a:srgbClr val="2C5F2D"/>
+            </a:solidFill>
+            <a:prstDash val="solid"/>
+          </a:ln>
+        </p:spPr>
+      </p:sp>
+      <p:sp>
+        <p:nvSpPr>
+          <p:cNvPr id="16" name="Text 14"/>
+          <p:cNvSpPr txBox="1"/>
+          <p:nvPr/>
+        </p:nvSpPr>
+        <p:spPr>
+          <a:xfrm>
+            <a:off x="5120640" y="2926080"/>
+            <a:ext cx="1737360" cy="502920"/>
+          </a:xfrm>
+          <a:prstGeom prst="rect">
+            <a:avLst/>
+          </a:prstGeom>
+          <a:noFill/>
+          <a:ln/>
+        </p:spPr>
+        <p:txBody>
+          <a:bodyPr wrap="square" lIns="508" tIns="508" rIns="508" bIns="508" rtlCol="0" anchor="ctr"/>
+          <a:lstStyle/>
+          <a:p>
+            <a:pPr algn="ctr" indent="0" marL="0">
+              <a:buNone/>
+            </a:pPr>
+            <a:r>
+              <a:rPr lang="en-US" sz="950" b="1" dirty="0">
+                <a:solidFill>
+                  <a:srgbClr val="2C5F2D"/>
+                </a:solidFill>
+                <a:latin typeface="Calibri" pitchFamily="34" charset="0"/>
+                <a:ea typeface="Calibri" pitchFamily="34" charset="-122"/>
+                <a:cs typeface="Calibri" pitchFamily="34" charset="-120"/>
+              </a:rPr>
+              <a:t>Sekretariat / Dekanat MND</a:t>
+            </a:r>
+            <a:endParaRPr lang="en-US" sz="950" dirty="0"/>
+          </a:p>
+          <a:p>
+            <a:pPr algn="ctr" indent="0" marL="0">
+              <a:buNone/>
+            </a:pPr>
+            <a:r>
+              <a:rPr lang="en-US" sz="700" dirty="0">
+                <a:solidFill>
+                  <a:srgbClr val="5C6B5C"/>
+                </a:solidFill>
+                <a:latin typeface="Calibri" pitchFamily="34" charset="0"/>
+                <a:ea typeface="Calibri" pitchFamily="34" charset="-122"/>
+                <a:cs typeface="Calibri" pitchFamily="34" charset="-120"/>
+              </a:rPr>
+              <a:t>Drehscheibe, prüft und legt ab</a:t>
+            </a:r>
+            <a:endParaRPr lang="en-US" sz="950" dirty="0"/>
+          </a:p>
+        </p:txBody>
+      </p:sp>
+      <p:sp>
+        <p:nvSpPr>
+          <p:cNvPr id="17" name="Shape 15"/>
+          <p:cNvSpPr/>
+          <p:nvPr/>
+        </p:nvSpPr>
+        <p:spPr>
+          <a:xfrm>
+            <a:off x="7955280" y="1371600"/>
+            <a:ext cx="1737360" cy="502920"/>
+          </a:xfrm>
+          <a:prstGeom prst="roundRect">
+            <a:avLst>
+              <a:gd name="adj" fmla="val 14545"/>
+            </a:avLst>
+          </a:prstGeom>
+          <a:solidFill>
+            <a:srgbClr val="EEF4E8"/>
+          </a:solidFill>
+          <a:ln w="15875">
+            <a:solidFill>
+              <a:srgbClr val="2C5F2D"/>
+            </a:solidFill>
+            <a:prstDash val="solid"/>
+          </a:ln>
+        </p:spPr>
+      </p:sp>
+      <p:sp>
+        <p:nvSpPr>
+          <p:cNvPr id="18" name="Text 16"/>
+          <p:cNvSpPr txBox="1"/>
+          <p:nvPr/>
+        </p:nvSpPr>
+        <p:spPr>
+          <a:xfrm>
+            <a:off x="7955280" y="1371600"/>
+            <a:ext cx="1737360" cy="502920"/>
+          </a:xfrm>
+          <a:prstGeom prst="rect">
+            <a:avLst/>
+          </a:prstGeom>
+          <a:noFill/>
+          <a:ln/>
+        </p:spPr>
+        <p:txBody>
+          <a:bodyPr wrap="square" lIns="508" tIns="508" rIns="508" bIns="508" rtlCol="0" anchor="ctr"/>
+          <a:lstStyle/>
+          <a:p>
+            <a:pPr algn="ctr" indent="0" marL="0">
+              <a:buNone/>
+            </a:pPr>
+            <a:r>
+              <a:rPr lang="en-US" sz="950" b="1" dirty="0">
+                <a:solidFill>
+                  <a:srgbClr val="2C5F2D"/>
+                </a:solidFill>
+                <a:latin typeface="Calibri" pitchFamily="34" charset="0"/>
+                <a:ea typeface="Calibri" pitchFamily="34" charset="-122"/>
+                <a:cs typeface="Calibri" pitchFamily="34" charset="-120"/>
+              </a:rPr>
+              <a:t>Prüfungsausschuss-Vorsitz</a:t>
+            </a:r>
+            <a:endParaRPr lang="en-US" sz="950" dirty="0"/>
+          </a:p>
+          <a:p>
+            <a:pPr algn="ctr" indent="0" marL="0">
+              <a:buNone/>
+            </a:pPr>
+            <a:r>
+              <a:rPr lang="en-US" sz="700" dirty="0">
+                <a:solidFill>
+                  <a:srgbClr val="5C6B5C"/>
+                </a:solidFill>
+                <a:latin typeface="Calibri" pitchFamily="34" charset="0"/>
+                <a:ea typeface="Calibri" pitchFamily="34" charset="-122"/>
+                <a:cs typeface="Calibri" pitchFamily="34" charset="-120"/>
+              </a:rPr>
+              <a:t>Person / Rolle</a:t>
+            </a:r>
+            <a:endParaRPr lang="en-US" sz="950" dirty="0"/>
+          </a:p>
+        </p:txBody>
+      </p:sp>
+      <p:sp>
+        <p:nvSpPr>
+          <p:cNvPr id="19" name="Shape 17"/>
+          <p:cNvSpPr/>
+          <p:nvPr/>
+        </p:nvSpPr>
+        <p:spPr>
+          <a:xfrm>
+            <a:off x="7955280" y="2926080"/>
+            <a:ext cx="1737360" cy="502920"/>
+          </a:xfrm>
+          <a:prstGeom prst="roundRect">
+            <a:avLst>
+              <a:gd name="adj" fmla="val 14545"/>
+            </a:avLst>
+          </a:prstGeom>
+          <a:solidFill>
+            <a:srgbClr val="EEF4E8"/>
+          </a:solidFill>
+          <a:ln w="15875">
+            <a:solidFill>
+              <a:srgbClr val="2C5F2D"/>
+            </a:solidFill>
+            <a:prstDash val="solid"/>
+          </a:ln>
+        </p:spPr>
+      </p:sp>
+      <p:sp>
+        <p:nvSpPr>
+          <p:cNvPr id="20" name="Text 18"/>
+          <p:cNvSpPr txBox="1"/>
+          <p:nvPr/>
+        </p:nvSpPr>
+        <p:spPr>
+          <a:xfrm>
+            <a:off x="7955280" y="2926080"/>
+            <a:ext cx="1737360" cy="502920"/>
+          </a:xfrm>
+          <a:prstGeom prst="rect">
+            <a:avLst/>
+          </a:prstGeom>
+          <a:noFill/>
+          <a:ln/>
+        </p:spPr>
+        <p:txBody>
+          <a:bodyPr wrap="square" lIns="508" tIns="508" rIns="508" bIns="508" rtlCol="0" anchor="ctr"/>
+          <a:lstStyle/>
+          <a:p>
+            <a:pPr algn="ctr" indent="0" marL="0">
+              <a:buNone/>
+            </a:pPr>
+            <a:r>
+              <a:rPr lang="en-US" sz="950" b="1" dirty="0">
+                <a:solidFill>
+                  <a:srgbClr val="2C5F2D"/>
+                </a:solidFill>
+                <a:latin typeface="Calibri" pitchFamily="34" charset="0"/>
+                <a:ea typeface="Calibri" pitchFamily="34" charset="-122"/>
+                <a:cs typeface="Calibri" pitchFamily="34" charset="-120"/>
+              </a:rPr>
+              <a:t>Studienausschuss WI</a:t>
+            </a:r>
+            <a:endParaRPr lang="en-US" sz="950" dirty="0"/>
+          </a:p>
+          <a:p>
+            <a:pPr algn="ctr" indent="0" marL="0">
+              <a:buNone/>
+            </a:pPr>
+            <a:r>
+              <a:rPr lang="en-US" sz="700" dirty="0">
+                <a:solidFill>
+                  <a:srgbClr val="5C6B5C"/>
+                </a:solidFill>
+                <a:latin typeface="Calibri" pitchFamily="34" charset="0"/>
+                <a:ea typeface="Calibri" pitchFamily="34" charset="-122"/>
+                <a:cs typeface="Calibri" pitchFamily="34" charset="-120"/>
+              </a:rPr>
+              <a:t>nur bei Verlängerung</a:t>
+            </a:r>
+            <a:endParaRPr lang="en-US" sz="950" dirty="0"/>
+          </a:p>
+        </p:txBody>
+      </p:sp>
+      <p:sp>
+        <p:nvSpPr>
+          <p:cNvPr id="21" name="Shape 19"/>
+          <p:cNvSpPr/>
+          <p:nvPr/>
+        </p:nvSpPr>
+        <p:spPr>
+          <a:xfrm>
+            <a:off x="1783080" y="1874520"/>
+            <a:ext cx="914" cy="1051560"/>
+          </a:xfrm>
+          <a:prstGeom prst="line">
+            <a:avLst/>
+          </a:prstGeom>
+          <a:noFill/>
+          <a:ln w="19050">
+            <a:solidFill>
+              <a:srgbClr val="2C5F2D"/>
+            </a:solidFill>
+            <a:prstDash val="solid"/>
+            <a:tailEnd type="triangle"/>
+          </a:ln>
+        </p:spPr>
+      </p:sp>
+      <p:sp>
+        <p:nvSpPr>
+          <p:cNvPr id="22" name="Shape 20"/>
+          <p:cNvSpPr/>
+          <p:nvPr/>
+        </p:nvSpPr>
+        <p:spPr>
+          <a:xfrm>
+            <a:off x="1874520" y="2267712"/>
+            <a:ext cx="201168" cy="201168"/>
+          </a:xfrm>
+          <a:prstGeom prst="ellipse">
+            <a:avLst/>
+          </a:prstGeom>
+          <a:solidFill>
+            <a:srgbClr val="2C5F2D"/>
+          </a:solidFill>
+          <a:ln w="12700">
+            <a:solidFill>
+              <a:srgbClr val="2C5F2D"/>
+            </a:solidFill>
+            <a:prstDash val="solid"/>
+          </a:ln>
+        </p:spPr>
+      </p:sp>
+      <p:sp>
+        <p:nvSpPr>
+          <p:cNvPr id="23" name="Text 21"/>
+          <p:cNvSpPr txBox="1"/>
+          <p:nvPr/>
+        </p:nvSpPr>
+        <p:spPr>
+          <a:xfrm>
+            <a:off x="1874520" y="2267712"/>
+            <a:ext cx="201168" cy="201168"/>
+          </a:xfrm>
+          <a:prstGeom prst="rect">
+            <a:avLst/>
+          </a:prstGeom>
+          <a:noFill/>
+          <a:ln/>
+        </p:spPr>
+        <p:txBody>
+          <a:bodyPr wrap="square" lIns="0" tIns="0" rIns="0" bIns="0" rtlCol="0" anchor="ctr"/>
+          <a:lstStyle/>
+          <a:p>
+            <a:pPr algn="ctr" indent="0" marL="0">
+              <a:buNone/>
+            </a:pPr>
+            <a:r>
+              <a:rPr lang="en-US" sz="800" b="1" dirty="0">
+                <a:solidFill>
+                  <a:srgbClr val="FFFFFF"/>
+                </a:solidFill>
+                <a:latin typeface="Calibri" pitchFamily="34" charset="0"/>
+                <a:ea typeface="Calibri" pitchFamily="34" charset="-122"/>
+                <a:cs typeface="Calibri" pitchFamily="34" charset="-120"/>
+              </a:rPr>
+              <a:t>1</a:t>
+            </a:r>
+            <a:endParaRPr lang="en-US" sz="800" dirty="0"/>
+          </a:p>
+        </p:txBody>
+      </p:sp>
+      <p:sp>
+        <p:nvSpPr>
+          <p:cNvPr id="24" name="Text 22"/>
+          <p:cNvSpPr txBox="1"/>
+          <p:nvPr/>
+        </p:nvSpPr>
+        <p:spPr>
+          <a:xfrm>
+            <a:off x="2121408" y="2240280"/>
+            <a:ext cx="1307592" cy="256032"/>
+          </a:xfrm>
+          <a:prstGeom prst="rect">
+            <a:avLst/>
+          </a:prstGeom>
+          <a:solidFill>
+            <a:srgbClr val="FFFFFF"/>
+          </a:solidFill>
+          <a:ln/>
+        </p:spPr>
+        <p:txBody>
+          <a:bodyPr wrap="square" lIns="254" tIns="254" rIns="254" bIns="254" rtlCol="0" anchor="ctr"/>
+          <a:lstStyle/>
+          <a:p>
+            <a:pPr indent="0" marL="0">
+              <a:buNone/>
+            </a:pPr>
+            <a:r>
+              <a:rPr lang="en-US" sz="750" dirty="0">
+                <a:solidFill>
+                  <a:srgbClr val="1F2A1F"/>
+                </a:solidFill>
+                <a:latin typeface="Calibri" pitchFamily="34" charset="0"/>
+                <a:ea typeface="Calibri" pitchFamily="34" charset="-122"/>
+                <a:cs typeface="Calibri" pitchFamily="34" charset="-120"/>
+              </a:rPr>
+              <a:t>Formular per E-Mail</a:t>
+            </a:r>
+            <a:endParaRPr lang="en-US" sz="750" dirty="0"/>
+          </a:p>
+        </p:txBody>
+      </p:sp>
+      <p:sp>
+        <p:nvSpPr>
+          <p:cNvPr id="25" name="Shape 23"/>
+          <p:cNvSpPr/>
+          <p:nvPr/>
+        </p:nvSpPr>
+        <p:spPr>
+          <a:xfrm>
+            <a:off x="1783080" y="3429000"/>
+            <a:ext cx="914" cy="1051560"/>
+          </a:xfrm>
+          <a:prstGeom prst="line">
+            <a:avLst/>
+          </a:prstGeom>
+          <a:noFill/>
+          <a:ln w="19050">
+            <a:solidFill>
+              <a:srgbClr val="2C5F2D"/>
+            </a:solidFill>
+            <a:prstDash val="solid"/>
+            <a:tailEnd type="triangle"/>
+          </a:ln>
+        </p:spPr>
+      </p:sp>
+      <p:sp>
+        <p:nvSpPr>
+          <p:cNvPr id="26" name="Shape 24"/>
+          <p:cNvSpPr/>
+          <p:nvPr/>
+        </p:nvSpPr>
+        <p:spPr>
+          <a:xfrm>
+            <a:off x="1874520" y="3822192"/>
+            <a:ext cx="201168" cy="201168"/>
+          </a:xfrm>
+          <a:prstGeom prst="ellipse">
+            <a:avLst/>
+          </a:prstGeom>
+          <a:solidFill>
+            <a:srgbClr val="2C5F2D"/>
+          </a:solidFill>
+          <a:ln w="12700">
+            <a:solidFill>
+              <a:srgbClr val="2C5F2D"/>
+            </a:solidFill>
+            <a:prstDash val="solid"/>
+          </a:ln>
+        </p:spPr>
+      </p:sp>
+      <p:sp>
+        <p:nvSpPr>
+          <p:cNvPr id="27" name="Text 25"/>
+          <p:cNvSpPr txBox="1"/>
+          <p:nvPr/>
+        </p:nvSpPr>
+        <p:spPr>
+          <a:xfrm>
+            <a:off x="1874520" y="3822192"/>
+            <a:ext cx="201168" cy="201168"/>
+          </a:xfrm>
+          <a:prstGeom prst="rect">
+            <a:avLst/>
+          </a:prstGeom>
+          <a:noFill/>
+          <a:ln/>
+        </p:spPr>
+        <p:txBody>
+          <a:bodyPr wrap="square" lIns="0" tIns="0" rIns="0" bIns="0" rtlCol="0" anchor="ctr"/>
+          <a:lstStyle/>
+          <a:p>
+            <a:pPr algn="ctr" indent="0" marL="0">
+              <a:buNone/>
+            </a:pPr>
+            <a:r>
+              <a:rPr lang="en-US" sz="800" b="1" dirty="0">
+                <a:solidFill>
+                  <a:srgbClr val="FFFFFF"/>
+                </a:solidFill>
+                <a:latin typeface="Calibri" pitchFamily="34" charset="0"/>
+                <a:ea typeface="Calibri" pitchFamily="34" charset="-122"/>
+                <a:cs typeface="Calibri" pitchFamily="34" charset="-120"/>
+              </a:rPr>
+              <a:t>2</a:t>
+            </a:r>
+            <a:endParaRPr lang="en-US" sz="800" dirty="0"/>
+          </a:p>
+        </p:txBody>
+      </p:sp>
+      <p:sp>
+        <p:nvSpPr>
+          <p:cNvPr id="28" name="Text 26"/>
+          <p:cNvSpPr txBox="1"/>
+          <p:nvPr/>
+        </p:nvSpPr>
+        <p:spPr>
+          <a:xfrm>
+            <a:off x="2121408" y="3794760"/>
+            <a:ext cx="1764792" cy="256032"/>
+          </a:xfrm>
+          <a:prstGeom prst="rect">
+            <a:avLst/>
+          </a:prstGeom>
+          <a:solidFill>
+            <a:srgbClr val="FFFFFF"/>
+          </a:solidFill>
+          <a:ln/>
+        </p:spPr>
+        <p:txBody>
+          <a:bodyPr wrap="square" lIns="254" tIns="254" rIns="254" bIns="254" rtlCol="0" anchor="ctr"/>
+          <a:lstStyle/>
+          <a:p>
+            <a:pPr indent="0" marL="0">
+              <a:buNone/>
+            </a:pPr>
+            <a:r>
+              <a:rPr lang="en-US" sz="750" dirty="0">
+                <a:solidFill>
+                  <a:srgbClr val="1F2A1F"/>
+                </a:solidFill>
+                <a:latin typeface="Calibri" pitchFamily="34" charset="0"/>
+                <a:ea typeface="Calibri" pitchFamily="34" charset="-122"/>
+                <a:cs typeface="Calibri" pitchFamily="34" charset="-120"/>
+              </a:rPr>
+              <a:t>Antrag ausgefüllt, unterschrieben</a:t>
+            </a:r>
+            <a:endParaRPr lang="en-US" sz="750" dirty="0"/>
+          </a:p>
+        </p:txBody>
+      </p:sp>
+      <p:sp>
+        <p:nvSpPr>
+          <p:cNvPr id="29" name="Shape 27"/>
+          <p:cNvSpPr/>
+          <p:nvPr/>
+        </p:nvSpPr>
+        <p:spPr>
+          <a:xfrm>
+            <a:off x="2651760" y="3337560"/>
+            <a:ext cx="1325880" cy="914"/>
+          </a:xfrm>
+          <a:prstGeom prst="line">
+            <a:avLst/>
+          </a:prstGeom>
+          <a:noFill/>
+          <a:ln w="19050">
+            <a:solidFill>
+              <a:srgbClr val="2C5F2D"/>
+            </a:solidFill>
+            <a:prstDash val="solid"/>
+          </a:ln>
+        </p:spPr>
+      </p:sp>
+      <p:sp>
+        <p:nvSpPr>
+          <p:cNvPr id="30" name="Shape 28"/>
+          <p:cNvSpPr/>
+          <p:nvPr/>
+        </p:nvSpPr>
+        <p:spPr>
+          <a:xfrm>
+            <a:off x="3977640" y="3337560"/>
+            <a:ext cx="914" cy="1143000"/>
+          </a:xfrm>
+          <a:prstGeom prst="line">
+            <a:avLst/>
+          </a:prstGeom>
+          <a:noFill/>
+          <a:ln w="19050">
+            <a:solidFill>
+              <a:srgbClr val="2C5F2D"/>
+            </a:solidFill>
+            <a:prstDash val="solid"/>
+            <a:tailEnd type="triangle"/>
+          </a:ln>
+        </p:spPr>
+      </p:sp>
+      <p:sp>
+        <p:nvSpPr>
+          <p:cNvPr id="31" name="Shape 29"/>
+          <p:cNvSpPr/>
+          <p:nvPr/>
+        </p:nvSpPr>
+        <p:spPr>
+          <a:xfrm>
+            <a:off x="2743200" y="3456432"/>
+            <a:ext cx="201168" cy="201168"/>
+          </a:xfrm>
+          <a:prstGeom prst="ellipse">
+            <a:avLst/>
+          </a:prstGeom>
+          <a:solidFill>
+            <a:srgbClr val="2C5F2D"/>
+          </a:solidFill>
+          <a:ln w="12700">
+            <a:solidFill>
+              <a:srgbClr val="2C5F2D"/>
+            </a:solidFill>
+            <a:prstDash val="solid"/>
+          </a:ln>
+        </p:spPr>
+      </p:sp>
+      <p:sp>
+        <p:nvSpPr>
+          <p:cNvPr id="32" name="Text 30"/>
+          <p:cNvSpPr txBox="1"/>
+          <p:nvPr/>
+        </p:nvSpPr>
+        <p:spPr>
+          <a:xfrm>
+            <a:off x="2743200" y="3456432"/>
+            <a:ext cx="201168" cy="201168"/>
+          </a:xfrm>
+          <a:prstGeom prst="rect">
+            <a:avLst/>
+          </a:prstGeom>
+          <a:noFill/>
+          <a:ln/>
+        </p:spPr>
+        <p:txBody>
+          <a:bodyPr wrap="square" lIns="0" tIns="0" rIns="0" bIns="0" rtlCol="0" anchor="ctr"/>
+          <a:lstStyle/>
+          <a:p>
+            <a:pPr algn="ctr" indent="0" marL="0">
+              <a:buNone/>
+            </a:pPr>
+            <a:r>
+              <a:rPr lang="en-US" sz="800" b="1" dirty="0">
+                <a:solidFill>
+                  <a:srgbClr val="FFFFFF"/>
+                </a:solidFill>
+                <a:latin typeface="Calibri" pitchFamily="34" charset="0"/>
+                <a:ea typeface="Calibri" pitchFamily="34" charset="-122"/>
+                <a:cs typeface="Calibri" pitchFamily="34" charset="-120"/>
+              </a:rPr>
+              <a:t>2</a:t>
+            </a:r>
+            <a:endParaRPr lang="en-US" sz="800" dirty="0"/>
+          </a:p>
+        </p:txBody>
+      </p:sp>
+      <p:sp>
+        <p:nvSpPr>
+          <p:cNvPr id="33" name="Text 31"/>
+          <p:cNvSpPr txBox="1"/>
+          <p:nvPr/>
+        </p:nvSpPr>
+        <p:spPr>
+          <a:xfrm>
+            <a:off x="2990088" y="3429000"/>
+            <a:ext cx="1581912" cy="256032"/>
+          </a:xfrm>
+          <a:prstGeom prst="rect">
+            <a:avLst/>
+          </a:prstGeom>
+          <a:solidFill>
+            <a:srgbClr val="FFFFFF"/>
+          </a:solidFill>
+          <a:ln/>
+        </p:spPr>
+        <p:txBody>
+          <a:bodyPr wrap="square" lIns="254" tIns="254" rIns="254" bIns="254" rtlCol="0" anchor="ctr"/>
+          <a:lstStyle/>
+          <a:p>
+            <a:pPr indent="0" marL="0">
+              <a:buNone/>
+            </a:pPr>
+            <a:r>
+              <a:rPr lang="en-US" sz="750" dirty="0">
+                <a:solidFill>
+                  <a:srgbClr val="1F2A1F"/>
+                </a:solidFill>
+                <a:latin typeface="Calibri" pitchFamily="34" charset="0"/>
+                <a:ea typeface="Calibri" pitchFamily="34" charset="-122"/>
+                <a:cs typeface="Calibri" pitchFamily="34" charset="-120"/>
+              </a:rPr>
+              <a:t>Formular Ext. Prüfende + Urkunde</a:t>
+            </a:r>
+            <a:endParaRPr lang="en-US" sz="750" dirty="0"/>
+          </a:p>
+        </p:txBody>
+      </p:sp>
+      <p:sp>
+        <p:nvSpPr>
+          <p:cNvPr id="34" name="Shape 32"/>
+          <p:cNvSpPr/>
+          <p:nvPr/>
+        </p:nvSpPr>
+        <p:spPr>
+          <a:xfrm>
+            <a:off x="1783080" y="4983480"/>
+            <a:ext cx="914" cy="155448"/>
+          </a:xfrm>
+          <a:prstGeom prst="line">
+            <a:avLst/>
+          </a:prstGeom>
+          <a:noFill/>
+          <a:ln w="19050">
+            <a:solidFill>
+              <a:srgbClr val="2C5F2D"/>
+            </a:solidFill>
+            <a:prstDash val="solid"/>
+          </a:ln>
+        </p:spPr>
+      </p:sp>
+      <p:sp>
+        <p:nvSpPr>
+          <p:cNvPr id="35" name="Shape 33"/>
+          <p:cNvSpPr/>
+          <p:nvPr/>
+        </p:nvSpPr>
+        <p:spPr>
+          <a:xfrm>
+            <a:off x="3977640" y="4983480"/>
+            <a:ext cx="914" cy="155448"/>
+          </a:xfrm>
+          <a:prstGeom prst="line">
+            <a:avLst/>
+          </a:prstGeom>
+          <a:noFill/>
+          <a:ln w="19050">
+            <a:solidFill>
+              <a:srgbClr val="2C5F2D"/>
+            </a:solidFill>
+            <a:prstDash val="solid"/>
+          </a:ln>
+        </p:spPr>
+      </p:sp>
+      <p:sp>
+        <p:nvSpPr>
+          <p:cNvPr id="36" name="Shape 34"/>
+          <p:cNvSpPr/>
+          <p:nvPr/>
+        </p:nvSpPr>
+        <p:spPr>
+          <a:xfrm>
+            <a:off x="1783080" y="5138928"/>
+            <a:ext cx="3886200" cy="914"/>
+          </a:xfrm>
+          <a:prstGeom prst="line">
+            <a:avLst/>
+          </a:prstGeom>
+          <a:noFill/>
+          <a:ln w="19050">
+            <a:solidFill>
+              <a:srgbClr val="2C5F2D"/>
+            </a:solidFill>
+            <a:prstDash val="solid"/>
+          </a:ln>
+        </p:spPr>
+      </p:sp>
+      <p:sp>
+        <p:nvSpPr>
+          <p:cNvPr id="37" name="Shape 35"/>
+          <p:cNvSpPr/>
+          <p:nvPr/>
+        </p:nvSpPr>
+        <p:spPr>
+          <a:xfrm>
+            <a:off x="5669280" y="3429000"/>
+            <a:ext cx="914" cy="1709928"/>
+          </a:xfrm>
+          <a:prstGeom prst="line">
+            <a:avLst/>
+          </a:prstGeom>
+          <a:noFill/>
+          <a:ln w="19050">
+            <a:solidFill>
+              <a:srgbClr val="2C5F2D"/>
+            </a:solidFill>
+            <a:prstDash val="solid"/>
+            <a:headEnd type="triangle"/>
+          </a:ln>
+        </p:spPr>
+      </p:sp>
+      <p:sp>
+        <p:nvSpPr>
+          <p:cNvPr id="38" name="Shape 36"/>
+          <p:cNvSpPr/>
+          <p:nvPr/>
+        </p:nvSpPr>
+        <p:spPr>
+          <a:xfrm>
+            <a:off x="5760720" y="4005072"/>
+            <a:ext cx="201168" cy="201168"/>
+          </a:xfrm>
+          <a:prstGeom prst="ellipse">
+            <a:avLst/>
+          </a:prstGeom>
+          <a:solidFill>
+            <a:srgbClr val="2C5F2D"/>
+          </a:solidFill>
+          <a:ln w="12700">
+            <a:solidFill>
+              <a:srgbClr val="2C5F2D"/>
+            </a:solidFill>
+            <a:prstDash val="solid"/>
+          </a:ln>
+        </p:spPr>
+      </p:sp>
+      <p:sp>
+        <p:nvSpPr>
+          <p:cNvPr id="39" name="Text 37"/>
+          <p:cNvSpPr txBox="1"/>
+          <p:nvPr/>
+        </p:nvSpPr>
+        <p:spPr>
+          <a:xfrm>
+            <a:off x="5760720" y="4005072"/>
+            <a:ext cx="201168" cy="201168"/>
+          </a:xfrm>
+          <a:prstGeom prst="rect">
+            <a:avLst/>
+          </a:prstGeom>
+          <a:noFill/>
+          <a:ln/>
+        </p:spPr>
+        <p:txBody>
+          <a:bodyPr wrap="square" lIns="0" tIns="0" rIns="0" bIns="0" rtlCol="0" anchor="ctr"/>
+          <a:lstStyle/>
+          <a:p>
+            <a:pPr algn="ctr" indent="0" marL="0">
+              <a:buNone/>
+            </a:pPr>
+            <a:r>
+              <a:rPr lang="en-US" sz="800" b="1" dirty="0">
+                <a:solidFill>
+                  <a:srgbClr val="FFFFFF"/>
+                </a:solidFill>
+                <a:latin typeface="Calibri" pitchFamily="34" charset="0"/>
+                <a:ea typeface="Calibri" pitchFamily="34" charset="-122"/>
+                <a:cs typeface="Calibri" pitchFamily="34" charset="-120"/>
+              </a:rPr>
+              <a:t>3</a:t>
+            </a:r>
+            <a:endParaRPr lang="en-US" sz="800" dirty="0"/>
+          </a:p>
+        </p:txBody>
+      </p:sp>
+      <p:sp>
+        <p:nvSpPr>
+          <p:cNvPr id="40" name="Text 38"/>
+          <p:cNvSpPr txBox="1"/>
+          <p:nvPr/>
+        </p:nvSpPr>
+        <p:spPr>
+          <a:xfrm>
+            <a:off x="6007608" y="3977640"/>
+            <a:ext cx="1856232" cy="256032"/>
+          </a:xfrm>
+          <a:prstGeom prst="rect">
+            <a:avLst/>
+          </a:prstGeom>
+          <a:solidFill>
+            <a:srgbClr val="FFFFFF"/>
+          </a:solidFill>
+          <a:ln/>
+        </p:spPr>
+        <p:txBody>
+          <a:bodyPr wrap="square" lIns="254" tIns="254" rIns="254" bIns="254" rtlCol="0" anchor="ctr"/>
+          <a:lstStyle/>
+          <a:p>
+            <a:pPr indent="0" marL="0">
+              <a:buNone/>
+            </a:pPr>
+            <a:r>
+              <a:rPr lang="en-US" sz="750" dirty="0">
+                <a:solidFill>
+                  <a:srgbClr val="1F2A1F"/>
+                </a:solidFill>
+                <a:latin typeface="Calibri" pitchFamily="34" charset="0"/>
+                <a:ea typeface="Calibri" pitchFamily="34" charset="-122"/>
+                <a:cs typeface="Calibri" pitchFamily="34" charset="-120"/>
+              </a:rPr>
+              <a:t>unterschrieben, per E-Mail ans Dekanat</a:t>
+            </a:r>
+            <a:endParaRPr lang="en-US" sz="750" dirty="0"/>
+          </a:p>
+        </p:txBody>
+      </p:sp>
+      <p:sp>
+        <p:nvSpPr>
+          <p:cNvPr id="41" name="Shape 39"/>
+          <p:cNvSpPr/>
+          <p:nvPr/>
+        </p:nvSpPr>
+        <p:spPr>
+          <a:xfrm>
+            <a:off x="6492240" y="1623060"/>
+            <a:ext cx="914" cy="1303020"/>
+          </a:xfrm>
+          <a:prstGeom prst="line">
+            <a:avLst/>
+          </a:prstGeom>
+          <a:noFill/>
+          <a:ln w="19050">
+            <a:solidFill>
+              <a:srgbClr val="2C5F2D"/>
+            </a:solidFill>
+            <a:prstDash val="solid"/>
+          </a:ln>
+        </p:spPr>
+      </p:sp>
+      <p:sp>
+        <p:nvSpPr>
+          <p:cNvPr id="42" name="Shape 40"/>
+          <p:cNvSpPr/>
+          <p:nvPr/>
+        </p:nvSpPr>
+        <p:spPr>
+          <a:xfrm>
+            <a:off x="6492240" y="1623060"/>
+            <a:ext cx="1463040" cy="914"/>
+          </a:xfrm>
+          <a:prstGeom prst="line">
+            <a:avLst/>
+          </a:prstGeom>
+          <a:noFill/>
+          <a:ln w="19050">
+            <a:solidFill>
+              <a:srgbClr val="2C5F2D"/>
+            </a:solidFill>
+            <a:prstDash val="solid"/>
+            <a:tailEnd type="triangle"/>
+          </a:ln>
+        </p:spPr>
+      </p:sp>
+      <p:sp>
+        <p:nvSpPr>
+          <p:cNvPr id="43" name="Shape 41"/>
+          <p:cNvSpPr/>
+          <p:nvPr/>
+        </p:nvSpPr>
+        <p:spPr>
+          <a:xfrm>
+            <a:off x="6583680" y="2130552"/>
+            <a:ext cx="201168" cy="201168"/>
+          </a:xfrm>
+          <a:prstGeom prst="ellipse">
+            <a:avLst/>
+          </a:prstGeom>
+          <a:solidFill>
+            <a:srgbClr val="2C5F2D"/>
+          </a:solidFill>
+          <a:ln w="12700">
+            <a:solidFill>
+              <a:srgbClr val="2C5F2D"/>
+            </a:solidFill>
+            <a:prstDash val="solid"/>
+          </a:ln>
+        </p:spPr>
+      </p:sp>
+      <p:sp>
+        <p:nvSpPr>
+          <p:cNvPr id="44" name="Text 42"/>
+          <p:cNvSpPr txBox="1"/>
+          <p:nvPr/>
+        </p:nvSpPr>
+        <p:spPr>
+          <a:xfrm>
+            <a:off x="6583680" y="2130552"/>
+            <a:ext cx="201168" cy="201168"/>
+          </a:xfrm>
+          <a:prstGeom prst="rect">
+            <a:avLst/>
+          </a:prstGeom>
+          <a:noFill/>
+          <a:ln/>
+        </p:spPr>
+        <p:txBody>
+          <a:bodyPr wrap="square" lIns="0" tIns="0" rIns="0" bIns="0" rtlCol="0" anchor="ctr"/>
+          <a:lstStyle/>
+          <a:p>
+            <a:pPr algn="ctr" indent="0" marL="0">
+              <a:buNone/>
+            </a:pPr>
+            <a:r>
+              <a:rPr lang="en-US" sz="800" b="1" dirty="0">
+                <a:solidFill>
+                  <a:srgbClr val="FFFFFF"/>
+                </a:solidFill>
+                <a:latin typeface="Calibri" pitchFamily="34" charset="0"/>
+                <a:ea typeface="Calibri" pitchFamily="34" charset="-122"/>
+                <a:cs typeface="Calibri" pitchFamily="34" charset="-120"/>
+              </a:rPr>
+              <a:t>4</a:t>
+            </a:r>
+            <a:endParaRPr lang="en-US" sz="800" dirty="0"/>
+          </a:p>
+        </p:txBody>
+      </p:sp>
+      <p:sp>
+        <p:nvSpPr>
+          <p:cNvPr id="45" name="Text 43"/>
+          <p:cNvSpPr txBox="1"/>
+          <p:nvPr/>
+        </p:nvSpPr>
+        <p:spPr>
+          <a:xfrm>
+            <a:off x="6830568" y="2103120"/>
+            <a:ext cx="1170432" cy="256032"/>
+          </a:xfrm>
+          <a:prstGeom prst="rect">
+            <a:avLst/>
+          </a:prstGeom>
+          <a:solidFill>
+            <a:srgbClr val="FFFFFF"/>
+          </a:solidFill>
+          <a:ln/>
+        </p:spPr>
+        <p:txBody>
+          <a:bodyPr wrap="square" lIns="254" tIns="254" rIns="254" bIns="254" rtlCol="0" anchor="ctr"/>
+          <a:lstStyle/>
+          <a:p>
+            <a:pPr indent="0" marL="0">
+              <a:buNone/>
+            </a:pPr>
+            <a:r>
+              <a:rPr lang="en-US" sz="750" dirty="0">
+                <a:solidFill>
+                  <a:srgbClr val="1F2A1F"/>
+                </a:solidFill>
+                <a:latin typeface="Calibri" pitchFamily="34" charset="0"/>
+                <a:ea typeface="Calibri" pitchFamily="34" charset="-122"/>
+                <a:cs typeface="Calibri" pitchFamily="34" charset="-120"/>
+              </a:rPr>
+              <a:t>geprüft: Zulassung, Qualifikation</a:t>
+            </a:r>
+            <a:endParaRPr lang="en-US" sz="750" dirty="0"/>
+          </a:p>
+        </p:txBody>
+      </p:sp>
+      <p:sp>
+        <p:nvSpPr>
+          <p:cNvPr id="46" name="Shape 44"/>
+          <p:cNvSpPr/>
+          <p:nvPr/>
+        </p:nvSpPr>
+        <p:spPr>
+          <a:xfrm>
+            <a:off x="8823960" y="1188720"/>
+            <a:ext cx="914" cy="182880"/>
+          </a:xfrm>
+          <a:prstGeom prst="line">
+            <a:avLst/>
+          </a:prstGeom>
+          <a:noFill/>
+          <a:ln w="19050">
+            <a:solidFill>
+              <a:srgbClr val="2C5F2D"/>
+            </a:solidFill>
+            <a:prstDash val="solid"/>
+          </a:ln>
+        </p:spPr>
+      </p:sp>
+      <p:sp>
+        <p:nvSpPr>
+          <p:cNvPr id="47" name="Shape 45"/>
+          <p:cNvSpPr/>
+          <p:nvPr/>
+        </p:nvSpPr>
+        <p:spPr>
+          <a:xfrm>
+            <a:off x="1783080" y="1188720"/>
+            <a:ext cx="7040880" cy="914"/>
+          </a:xfrm>
+          <a:prstGeom prst="line">
+            <a:avLst/>
+          </a:prstGeom>
+          <a:noFill/>
+          <a:ln w="19050">
+            <a:solidFill>
+              <a:srgbClr val="2C5F2D"/>
+            </a:solidFill>
+            <a:prstDash val="solid"/>
+          </a:ln>
+        </p:spPr>
+      </p:sp>
+      <p:sp>
+        <p:nvSpPr>
+          <p:cNvPr id="48" name="Shape 46"/>
+          <p:cNvSpPr/>
+          <p:nvPr/>
+        </p:nvSpPr>
+        <p:spPr>
+          <a:xfrm>
+            <a:off x="1783080" y="1188720"/>
+            <a:ext cx="914" cy="182880"/>
+          </a:xfrm>
+          <a:prstGeom prst="line">
+            <a:avLst/>
+          </a:prstGeom>
+          <a:noFill/>
+          <a:ln w="19050">
+            <a:solidFill>
+              <a:srgbClr val="2C5F2D"/>
+            </a:solidFill>
+            <a:prstDash val="solid"/>
+            <a:tailEnd type="triangle"/>
+          </a:ln>
+        </p:spPr>
+      </p:sp>
+      <p:sp>
+        <p:nvSpPr>
+          <p:cNvPr id="49" name="Shape 47"/>
+          <p:cNvSpPr/>
+          <p:nvPr/>
+        </p:nvSpPr>
+        <p:spPr>
+          <a:xfrm>
+            <a:off x="4023360" y="1234440"/>
+            <a:ext cx="201168" cy="201168"/>
+          </a:xfrm>
+          <a:prstGeom prst="ellipse">
+            <a:avLst/>
+          </a:prstGeom>
+          <a:solidFill>
+            <a:srgbClr val="2C5F2D"/>
+          </a:solidFill>
+          <a:ln w="12700">
+            <a:solidFill>
+              <a:srgbClr val="2C5F2D"/>
+            </a:solidFill>
+            <a:prstDash val="solid"/>
+          </a:ln>
+        </p:spPr>
+      </p:sp>
+      <p:sp>
+        <p:nvSpPr>
+          <p:cNvPr id="50" name="Text 48"/>
+          <p:cNvSpPr txBox="1"/>
+          <p:nvPr/>
+        </p:nvSpPr>
+        <p:spPr>
+          <a:xfrm>
+            <a:off x="4023360" y="1234440"/>
+            <a:ext cx="201168" cy="201168"/>
+          </a:xfrm>
+          <a:prstGeom prst="rect">
+            <a:avLst/>
+          </a:prstGeom>
+          <a:noFill/>
+          <a:ln/>
+        </p:spPr>
+        <p:txBody>
+          <a:bodyPr wrap="square" lIns="0" tIns="0" rIns="0" bIns="0" rtlCol="0" anchor="ctr"/>
+          <a:lstStyle/>
+          <a:p>
+            <a:pPr algn="ctr" indent="0" marL="0">
+              <a:buNone/>
+            </a:pPr>
+            <a:r>
+              <a:rPr lang="en-US" sz="800" b="1" dirty="0">
+                <a:solidFill>
+                  <a:srgbClr val="FFFFFF"/>
+                </a:solidFill>
+                <a:latin typeface="Calibri" pitchFamily="34" charset="0"/>
+                <a:ea typeface="Calibri" pitchFamily="34" charset="-122"/>
+                <a:cs typeface="Calibri" pitchFamily="34" charset="-120"/>
+              </a:rPr>
+              <a:t>5</a:t>
+            </a:r>
+            <a:endParaRPr lang="en-US" sz="800" dirty="0"/>
+          </a:p>
+        </p:txBody>
+      </p:sp>
+      <p:sp>
+        <p:nvSpPr>
+          <p:cNvPr id="51" name="Text 49"/>
+          <p:cNvSpPr txBox="1"/>
+          <p:nvPr/>
+        </p:nvSpPr>
+        <p:spPr>
+          <a:xfrm>
+            <a:off x="4270248" y="1207008"/>
+            <a:ext cx="2679192" cy="256032"/>
+          </a:xfrm>
+          <a:prstGeom prst="rect">
+            <a:avLst/>
+          </a:prstGeom>
+          <a:solidFill>
+            <a:srgbClr val="FFFFFF"/>
+          </a:solidFill>
+          <a:ln/>
+        </p:spPr>
+        <p:txBody>
+          <a:bodyPr wrap="square" lIns="254" tIns="254" rIns="254" bIns="254" rtlCol="0" anchor="ctr"/>
+          <a:lstStyle/>
+          <a:p>
+            <a:pPr indent="0" marL="0">
+              <a:buNone/>
+            </a:pPr>
+            <a:r>
+              <a:rPr lang="en-US" sz="750" dirty="0">
+                <a:solidFill>
+                  <a:srgbClr val="1F2A1F"/>
+                </a:solidFill>
+                <a:latin typeface="Calibri" pitchFamily="34" charset="0"/>
+                <a:ea typeface="Calibri" pitchFamily="34" charset="-122"/>
+                <a:cs typeface="Calibri" pitchFamily="34" charset="-120"/>
+              </a:rPr>
+              <a:t>Entscheidung PA; 1. Prüfer trägt Ausgabe ein (Beginn, Abgabe)</a:t>
+            </a:r>
+            <a:endParaRPr lang="en-US" sz="750" dirty="0"/>
+          </a:p>
+        </p:txBody>
+      </p:sp>
+      <p:sp>
+        <p:nvSpPr>
+          <p:cNvPr id="52" name="Shape 50"/>
+          <p:cNvSpPr/>
+          <p:nvPr/>
+        </p:nvSpPr>
+        <p:spPr>
+          <a:xfrm>
+            <a:off x="2651760" y="1737360"/>
+            <a:ext cx="2240280" cy="914"/>
+          </a:xfrm>
+          <a:prstGeom prst="line">
+            <a:avLst/>
+          </a:prstGeom>
+          <a:noFill/>
+          <a:ln w="19050">
+            <a:solidFill>
+              <a:srgbClr val="2C5F2D"/>
+            </a:solidFill>
+            <a:prstDash val="solid"/>
+          </a:ln>
+        </p:spPr>
+      </p:sp>
+      <p:sp>
+        <p:nvSpPr>
+          <p:cNvPr id="53" name="Shape 51"/>
+          <p:cNvSpPr/>
+          <p:nvPr/>
+        </p:nvSpPr>
+        <p:spPr>
+          <a:xfrm>
+            <a:off x="4892040" y="1737360"/>
+            <a:ext cx="914" cy="1325880"/>
+          </a:xfrm>
+          <a:prstGeom prst="line">
+            <a:avLst/>
+          </a:prstGeom>
+          <a:noFill/>
+          <a:ln w="19050">
+            <a:solidFill>
+              <a:srgbClr val="2C5F2D"/>
+            </a:solidFill>
+            <a:prstDash val="solid"/>
+          </a:ln>
+        </p:spPr>
+      </p:sp>
+      <p:sp>
+        <p:nvSpPr>
+          <p:cNvPr id="54" name="Shape 52"/>
+          <p:cNvSpPr/>
+          <p:nvPr/>
+        </p:nvSpPr>
+        <p:spPr>
+          <a:xfrm>
+            <a:off x="4892040" y="3063240"/>
+            <a:ext cx="228600" cy="914"/>
+          </a:xfrm>
+          <a:prstGeom prst="line">
+            <a:avLst/>
+          </a:prstGeom>
+          <a:noFill/>
+          <a:ln w="19050">
+            <a:solidFill>
+              <a:srgbClr val="2C5F2D"/>
+            </a:solidFill>
+            <a:prstDash val="solid"/>
+            <a:tailEnd type="triangle"/>
+          </a:ln>
+        </p:spPr>
+      </p:sp>
+      <p:sp>
+        <p:nvSpPr>
+          <p:cNvPr id="55" name="Shape 53"/>
+          <p:cNvSpPr/>
+          <p:nvPr/>
+        </p:nvSpPr>
+        <p:spPr>
+          <a:xfrm>
+            <a:off x="2743200" y="1856232"/>
+            <a:ext cx="201168" cy="201168"/>
+          </a:xfrm>
+          <a:prstGeom prst="ellipse">
+            <a:avLst/>
+          </a:prstGeom>
+          <a:solidFill>
+            <a:srgbClr val="2C5F2D"/>
+          </a:solidFill>
+          <a:ln w="12700">
+            <a:solidFill>
+              <a:srgbClr val="2C5F2D"/>
+            </a:solidFill>
+            <a:prstDash val="solid"/>
+          </a:ln>
+        </p:spPr>
+      </p:sp>
+      <p:sp>
+        <p:nvSpPr>
+          <p:cNvPr id="56" name="Text 54"/>
+          <p:cNvSpPr txBox="1"/>
+          <p:nvPr/>
+        </p:nvSpPr>
+        <p:spPr>
+          <a:xfrm>
+            <a:off x="2743200" y="1856232"/>
+            <a:ext cx="201168" cy="201168"/>
+          </a:xfrm>
+          <a:prstGeom prst="rect">
+            <a:avLst/>
+          </a:prstGeom>
+          <a:noFill/>
+          <a:ln/>
+        </p:spPr>
+        <p:txBody>
+          <a:bodyPr wrap="square" lIns="0" tIns="0" rIns="0" bIns="0" rtlCol="0" anchor="ctr"/>
+          <a:lstStyle/>
+          <a:p>
+            <a:pPr algn="ctr" indent="0" marL="0">
+              <a:buNone/>
+            </a:pPr>
+            <a:r>
+              <a:rPr lang="en-US" sz="800" b="1" dirty="0">
+                <a:solidFill>
+                  <a:srgbClr val="FFFFFF"/>
+                </a:solidFill>
+                <a:latin typeface="Calibri" pitchFamily="34" charset="0"/>
+                <a:ea typeface="Calibri" pitchFamily="34" charset="-122"/>
+                <a:cs typeface="Calibri" pitchFamily="34" charset="-120"/>
+              </a:rPr>
+              <a:t>6</a:t>
+            </a:r>
+            <a:endParaRPr lang="en-US" sz="800" dirty="0"/>
+          </a:p>
+        </p:txBody>
+      </p:sp>
+      <p:sp>
+        <p:nvSpPr>
+          <p:cNvPr id="57" name="Text 55"/>
+          <p:cNvSpPr txBox="1"/>
+          <p:nvPr/>
+        </p:nvSpPr>
+        <p:spPr>
+          <a:xfrm>
+            <a:off x="2990088" y="1828800"/>
+            <a:ext cx="1399032" cy="256032"/>
+          </a:xfrm>
+          <a:prstGeom prst="rect">
+            <a:avLst/>
+          </a:prstGeom>
+          <a:solidFill>
+            <a:srgbClr val="FFFFFF"/>
+          </a:solidFill>
+          <a:ln/>
+        </p:spPr>
+        <p:txBody>
+          <a:bodyPr wrap="square" lIns="254" tIns="254" rIns="254" bIns="254" rtlCol="0" anchor="ctr"/>
+          <a:lstStyle/>
+          <a:p>
+            <a:pPr indent="0" marL="0">
+              <a:buNone/>
+            </a:pPr>
+            <a:r>
+              <a:rPr lang="en-US" sz="750" dirty="0">
+                <a:solidFill>
+                  <a:srgbClr val="1F2A1F"/>
+                </a:solidFill>
+                <a:latin typeface="Calibri" pitchFamily="34" charset="0"/>
+                <a:ea typeface="Calibri" pitchFamily="34" charset="-122"/>
+                <a:cs typeface="Calibri" pitchFamily="34" charset="-120"/>
+              </a:rPr>
+              <a:t>Formular mit Fristen zurück</a:t>
+            </a:r>
+            <a:endParaRPr lang="en-US" sz="750" dirty="0"/>
+          </a:p>
+        </p:txBody>
+      </p:sp>
+      <p:sp>
+        <p:nvSpPr>
+          <p:cNvPr id="58" name="Shape 56"/>
+          <p:cNvSpPr/>
+          <p:nvPr/>
+        </p:nvSpPr>
+        <p:spPr>
+          <a:xfrm>
+            <a:off x="2651760" y="3200400"/>
+            <a:ext cx="2468880" cy="914"/>
+          </a:xfrm>
+          <a:prstGeom prst="line">
+            <a:avLst/>
+          </a:prstGeom>
+          <a:noFill/>
+          <a:ln w="19050">
+            <a:solidFill>
+              <a:srgbClr val="2C5F2D"/>
+            </a:solidFill>
+            <a:prstDash val="solid"/>
+            <a:headEnd type="triangle"/>
+          </a:ln>
+        </p:spPr>
+      </p:sp>
+      <p:sp>
+        <p:nvSpPr>
+          <p:cNvPr id="59" name="Shape 57"/>
+          <p:cNvSpPr/>
+          <p:nvPr/>
+        </p:nvSpPr>
+        <p:spPr>
+          <a:xfrm>
+            <a:off x="2743200" y="2816352"/>
+            <a:ext cx="201168" cy="201168"/>
+          </a:xfrm>
+          <a:prstGeom prst="ellipse">
+            <a:avLst/>
+          </a:prstGeom>
+          <a:solidFill>
+            <a:srgbClr val="2C5F2D"/>
+          </a:solidFill>
+          <a:ln w="12700">
+            <a:solidFill>
+              <a:srgbClr val="2C5F2D"/>
+            </a:solidFill>
+            <a:prstDash val="solid"/>
+          </a:ln>
+        </p:spPr>
+      </p:sp>
+      <p:sp>
+        <p:nvSpPr>
+          <p:cNvPr id="60" name="Text 58"/>
+          <p:cNvSpPr txBox="1"/>
+          <p:nvPr/>
+        </p:nvSpPr>
+        <p:spPr>
+          <a:xfrm>
+            <a:off x="2743200" y="2816352"/>
+            <a:ext cx="201168" cy="201168"/>
+          </a:xfrm>
+          <a:prstGeom prst="rect">
+            <a:avLst/>
+          </a:prstGeom>
+          <a:noFill/>
+          <a:ln/>
+        </p:spPr>
+        <p:txBody>
+          <a:bodyPr wrap="square" lIns="0" tIns="0" rIns="0" bIns="0" rtlCol="0" anchor="ctr"/>
+          <a:lstStyle/>
+          <a:p>
+            <a:pPr algn="ctr" indent="0" marL="0">
+              <a:buNone/>
+            </a:pPr>
+            <a:r>
+              <a:rPr lang="en-US" sz="800" b="1" dirty="0">
+                <a:solidFill>
+                  <a:srgbClr val="FFFFFF"/>
+                </a:solidFill>
+                <a:latin typeface="Calibri" pitchFamily="34" charset="0"/>
+                <a:ea typeface="Calibri" pitchFamily="34" charset="-122"/>
+                <a:cs typeface="Calibri" pitchFamily="34" charset="-120"/>
+              </a:rPr>
+              <a:t>7</a:t>
+            </a:r>
+            <a:endParaRPr lang="en-US" sz="800" dirty="0"/>
+          </a:p>
+        </p:txBody>
+      </p:sp>
+      <p:sp>
+        <p:nvSpPr>
+          <p:cNvPr id="61" name="Text 59"/>
+          <p:cNvSpPr txBox="1"/>
+          <p:nvPr/>
+        </p:nvSpPr>
+        <p:spPr>
+          <a:xfrm>
+            <a:off x="2990088" y="2788920"/>
+            <a:ext cx="1856232" cy="256032"/>
+          </a:xfrm>
+          <a:prstGeom prst="rect">
+            <a:avLst/>
+          </a:prstGeom>
+          <a:solidFill>
+            <a:srgbClr val="FFFFFF"/>
+          </a:solidFill>
+          <a:ln/>
+        </p:spPr>
+        <p:txBody>
+          <a:bodyPr wrap="square" lIns="254" tIns="254" rIns="254" bIns="254" rtlCol="0" anchor="ctr"/>
+          <a:lstStyle/>
+          <a:p>
+            <a:pPr indent="0" marL="0">
+              <a:buNone/>
+            </a:pPr>
+            <a:r>
+              <a:rPr lang="en-US" sz="750" dirty="0">
+                <a:solidFill>
+                  <a:srgbClr val="1F2A1F"/>
+                </a:solidFill>
+                <a:latin typeface="Calibri" pitchFamily="34" charset="0"/>
+                <a:ea typeface="Calibri" pitchFamily="34" charset="-122"/>
+                <a:cs typeface="Calibri" pitchFamily="34" charset="-120"/>
+              </a:rPr>
+              <a:t>Info Thema + Frist; Formular bleibt in der Akte</a:t>
+            </a:r>
+            <a:endParaRPr lang="en-US" sz="750" dirty="0"/>
+          </a:p>
+        </p:txBody>
+      </p:sp>
+      <p:sp>
+        <p:nvSpPr>
+          <p:cNvPr id="62" name="Shape 60"/>
+          <p:cNvSpPr/>
+          <p:nvPr/>
+        </p:nvSpPr>
+        <p:spPr>
+          <a:xfrm>
+            <a:off x="6858000" y="3200400"/>
+            <a:ext cx="1097280" cy="914"/>
+          </a:xfrm>
+          <a:prstGeom prst="line">
+            <a:avLst/>
+          </a:prstGeom>
+          <a:noFill/>
+          <a:ln w="19050">
+            <a:solidFill>
+              <a:srgbClr val="C9A227"/>
+            </a:solidFill>
+            <a:prstDash val="dash"/>
+            <a:tailEnd type="triangle"/>
+          </a:ln>
+        </p:spPr>
+      </p:sp>
+      <p:sp>
+        <p:nvSpPr>
+          <p:cNvPr id="63" name="Shape 61"/>
+          <p:cNvSpPr/>
+          <p:nvPr/>
+        </p:nvSpPr>
+        <p:spPr>
+          <a:xfrm>
+            <a:off x="6903720" y="3456432"/>
+            <a:ext cx="201168" cy="201168"/>
+          </a:xfrm>
+          <a:prstGeom prst="ellipse">
+            <a:avLst/>
+          </a:prstGeom>
+          <a:solidFill>
+            <a:srgbClr val="C9A227"/>
+          </a:solidFill>
+          <a:ln w="12700">
+            <a:solidFill>
+              <a:srgbClr val="C9A227"/>
+            </a:solidFill>
+            <a:prstDash val="solid"/>
+          </a:ln>
+        </p:spPr>
+      </p:sp>
+      <p:sp>
+        <p:nvSpPr>
+          <p:cNvPr id="64" name="Text 62"/>
+          <p:cNvSpPr txBox="1"/>
+          <p:nvPr/>
+        </p:nvSpPr>
+        <p:spPr>
+          <a:xfrm>
+            <a:off x="6903720" y="3456432"/>
+            <a:ext cx="201168" cy="201168"/>
+          </a:xfrm>
+          <a:prstGeom prst="rect">
+            <a:avLst/>
+          </a:prstGeom>
+          <a:noFill/>
+          <a:ln/>
+        </p:spPr>
+        <p:txBody>
+          <a:bodyPr wrap="square" lIns="0" tIns="0" rIns="0" bIns="0" rtlCol="0" anchor="ctr"/>
+          <a:lstStyle/>
+          <a:p>
+            <a:pPr algn="ctr" indent="0" marL="0">
+              <a:buNone/>
+            </a:pPr>
+            <a:r>
+              <a:rPr lang="en-US" sz="800" b="1" dirty="0">
+                <a:solidFill>
+                  <a:srgbClr val="FFFFFF"/>
+                </a:solidFill>
+                <a:latin typeface="Calibri" pitchFamily="34" charset="0"/>
+                <a:ea typeface="Calibri" pitchFamily="34" charset="-122"/>
+                <a:cs typeface="Calibri" pitchFamily="34" charset="-120"/>
+              </a:rPr>
+              <a:t>V</a:t>
+            </a:r>
+            <a:endParaRPr lang="en-US" sz="800" dirty="0"/>
+          </a:p>
+        </p:txBody>
+      </p:sp>
+      <p:sp>
+        <p:nvSpPr>
+          <p:cNvPr id="65" name="Text 63"/>
+          <p:cNvSpPr txBox="1"/>
+          <p:nvPr/>
+        </p:nvSpPr>
+        <p:spPr>
+          <a:xfrm>
+            <a:off x="7150608" y="3429000"/>
+            <a:ext cx="850392" cy="256032"/>
+          </a:xfrm>
+          <a:prstGeom prst="rect">
+            <a:avLst/>
+          </a:prstGeom>
+          <a:solidFill>
+            <a:srgbClr val="FFFFFF"/>
+          </a:solidFill>
+          <a:ln/>
+        </p:spPr>
+        <p:txBody>
+          <a:bodyPr wrap="square" lIns="254" tIns="254" rIns="254" bIns="254" rtlCol="0" anchor="ctr"/>
+          <a:lstStyle/>
+          <a:p>
+            <a:pPr indent="0" marL="0">
+              <a:buNone/>
+            </a:pPr>
+            <a:r>
+              <a:rPr lang="en-US" sz="750" dirty="0">
+                <a:solidFill>
+                  <a:srgbClr val="1F2A1F"/>
+                </a:solidFill>
+                <a:latin typeface="Calibri" pitchFamily="34" charset="0"/>
+                <a:ea typeface="Calibri" pitchFamily="34" charset="-122"/>
+                <a:cs typeface="Calibri" pitchFamily="34" charset="-120"/>
+              </a:rPr>
+              <a:t>Verlängerung</a:t>
+            </a:r>
+            <a:endParaRPr lang="en-US" sz="750" dirty="0"/>
+          </a:p>
+        </p:txBody>
+      </p:sp>
+      <p:sp>
+        <p:nvSpPr>
+          <p:cNvPr id="66" name="Text 64"/>
+          <p:cNvSpPr txBox="1"/>
+          <p:nvPr/>
+        </p:nvSpPr>
+        <p:spPr>
+          <a:xfrm>
+            <a:off x="457200" y="5486400"/>
+            <a:ext cx="2743200" cy="182880"/>
+          </a:xfrm>
+          <a:prstGeom prst="rect">
+            <a:avLst/>
+          </a:prstGeom>
+          <a:noFill/>
+          <a:ln/>
+        </p:spPr>
+        <p:txBody>
+          <a:bodyPr wrap="square" lIns="0" tIns="0" rIns="0" bIns="0" rtlCol="0" anchor="ctr"/>
+          <a:lstStyle/>
+          <a:p>
+            <a:pPr indent="0" marL="0">
+              <a:buNone/>
+            </a:pPr>
+            <a:r>
+              <a:rPr lang="en-US" sz="800" b="1" i="1" dirty="0">
+                <a:solidFill>
+                  <a:srgbClr val="97BC62"/>
+                </a:solidFill>
+                <a:latin typeface="Calibri" pitchFamily="34" charset="0"/>
+                <a:ea typeface="Calibri" pitchFamily="34" charset="-122"/>
+                <a:cs typeface="Calibri" pitchFamily="34" charset="-120"/>
+              </a:rPr>
+              <a:t>Rahmenbedingungen im Kontext</a:t>
+            </a:r>
+            <a:endParaRPr lang="en-US" sz="800" dirty="0"/>
+          </a:p>
+        </p:txBody>
+      </p:sp>
+      <p:sp>
+        <p:nvSpPr>
+          <p:cNvPr id="67" name="Shape 65"/>
+          <p:cNvSpPr/>
+          <p:nvPr/>
+        </p:nvSpPr>
+        <p:spPr>
+          <a:xfrm>
+            <a:off x="457200" y="5687568"/>
+            <a:ext cx="2286000" cy="457200"/>
+          </a:xfrm>
+          <a:prstGeom prst="roundRect">
+            <a:avLst>
+              <a:gd name="adj" fmla="val 12000"/>
+            </a:avLst>
+          </a:prstGeom>
+          <a:solidFill>
+            <a:srgbClr val="FFFFFF"/>
+          </a:solidFill>
+          <a:ln w="12700">
+            <a:solidFill>
+              <a:srgbClr val="8A968A"/>
+            </a:solidFill>
+            <a:prstDash val="dash"/>
+          </a:ln>
+        </p:spPr>
+      </p:sp>
+      <p:sp>
+        <p:nvSpPr>
+          <p:cNvPr id="68" name="Text 66"/>
+          <p:cNvSpPr txBox="1"/>
+          <p:nvPr/>
+        </p:nvSpPr>
+        <p:spPr>
+          <a:xfrm>
+            <a:off x="457200" y="5687568"/>
+            <a:ext cx="2286000" cy="457200"/>
+          </a:xfrm>
+          <a:prstGeom prst="rect">
+            <a:avLst/>
+          </a:prstGeom>
+          <a:noFill/>
+          <a:ln/>
+        </p:spPr>
+        <p:txBody>
+          <a:bodyPr wrap="square" lIns="635" tIns="635" rIns="635" bIns="635" rtlCol="0" anchor="ctr"/>
+          <a:lstStyle/>
+          <a:p>
+            <a:pPr indent="0" marL="0">
+              <a:buNone/>
+            </a:pPr>
+            <a:r>
+              <a:rPr lang="en-US" sz="850" b="1" dirty="0">
+                <a:solidFill>
+                  <a:srgbClr val="5C6B5C"/>
+                </a:solidFill>
+                <a:latin typeface="Calibri" pitchFamily="34" charset="0"/>
+                <a:ea typeface="Calibri" pitchFamily="34" charset="-122"/>
+                <a:cs typeface="Calibri" pitchFamily="34" charset="-120"/>
+              </a:rPr>
+              <a:t>E-Mail (Outlook)</a:t>
+            </a:r>
+            <a:endParaRPr lang="en-US" sz="850" dirty="0"/>
+          </a:p>
+          <a:p>
+            <a:pPr indent="0" marL="0">
+              <a:buNone/>
+            </a:pPr>
+            <a:r>
+              <a:rPr lang="en-US" sz="700" dirty="0">
+                <a:solidFill>
+                  <a:srgbClr val="5C6B5C"/>
+                </a:solidFill>
+                <a:latin typeface="Calibri" pitchFamily="34" charset="0"/>
+                <a:ea typeface="Calibri" pitchFamily="34" charset="-122"/>
+                <a:cs typeface="Calibri" pitchFamily="34" charset="-120"/>
+              </a:rPr>
+              <a:t>Transport aller Übergaben, keine Nachverfolgung</a:t>
+            </a:r>
+            <a:endParaRPr lang="en-US" sz="850" dirty="0"/>
+          </a:p>
+        </p:txBody>
+      </p:sp>
+      <p:sp>
+        <p:nvSpPr>
+          <p:cNvPr id="69" name="Shape 67"/>
+          <p:cNvSpPr/>
+          <p:nvPr/>
+        </p:nvSpPr>
+        <p:spPr>
+          <a:xfrm>
+            <a:off x="2852928" y="5687568"/>
+            <a:ext cx="2286000" cy="457200"/>
+          </a:xfrm>
+          <a:prstGeom prst="roundRect">
+            <a:avLst>
+              <a:gd name="adj" fmla="val 12000"/>
+            </a:avLst>
+          </a:prstGeom>
+          <a:solidFill>
+            <a:srgbClr val="FFFFFF"/>
+          </a:solidFill>
+          <a:ln w="12700">
+            <a:solidFill>
+              <a:srgbClr val="8A968A"/>
+            </a:solidFill>
+            <a:prstDash val="dash"/>
+          </a:ln>
+        </p:spPr>
+      </p:sp>
+      <p:sp>
+        <p:nvSpPr>
+          <p:cNvPr id="70" name="Text 68"/>
+          <p:cNvSpPr txBox="1"/>
+          <p:nvPr/>
+        </p:nvSpPr>
+        <p:spPr>
+          <a:xfrm>
+            <a:off x="2852928" y="5687568"/>
+            <a:ext cx="2286000" cy="457200"/>
+          </a:xfrm>
+          <a:prstGeom prst="rect">
+            <a:avLst/>
+          </a:prstGeom>
+          <a:noFill/>
+          <a:ln/>
+        </p:spPr>
+        <p:txBody>
+          <a:bodyPr wrap="square" lIns="635" tIns="635" rIns="635" bIns="635" rtlCol="0" anchor="ctr"/>
+          <a:lstStyle/>
+          <a:p>
+            <a:pPr indent="0" marL="0">
+              <a:buNone/>
+            </a:pPr>
+            <a:r>
+              <a:rPr lang="en-US" sz="850" b="1" dirty="0">
+                <a:solidFill>
+                  <a:srgbClr val="5C6B5C"/>
+                </a:solidFill>
+                <a:latin typeface="Calibri" pitchFamily="34" charset="0"/>
+                <a:ea typeface="Calibri" pitchFamily="34" charset="-122"/>
+                <a:cs typeface="Calibri" pitchFamily="34" charset="-120"/>
+              </a:rPr>
+              <a:t>THM-Intranet</a:t>
+            </a:r>
+            <a:endParaRPr lang="en-US" sz="850" dirty="0"/>
+          </a:p>
+          <a:p>
+            <a:pPr indent="0" marL="0">
+              <a:buNone/>
+            </a:pPr>
+            <a:r>
+              <a:rPr lang="en-US" sz="700" dirty="0">
+                <a:solidFill>
+                  <a:srgbClr val="5C6B5C"/>
+                </a:solidFill>
+                <a:latin typeface="Calibri" pitchFamily="34" charset="0"/>
+                <a:ea typeface="Calibri" pitchFamily="34" charset="-122"/>
+                <a:cs typeface="Calibri" pitchFamily="34" charset="-120"/>
+              </a:rPr>
+              <a:t>PDF-Formulare nur nach Login</a:t>
+            </a:r>
+            <a:endParaRPr lang="en-US" sz="850" dirty="0"/>
+          </a:p>
+        </p:txBody>
+      </p:sp>
+      <p:sp>
+        <p:nvSpPr>
+          <p:cNvPr id="71" name="Shape 69"/>
+          <p:cNvSpPr/>
+          <p:nvPr/>
+        </p:nvSpPr>
+        <p:spPr>
+          <a:xfrm>
+            <a:off x="5248656" y="5687568"/>
+            <a:ext cx="2286000" cy="457200"/>
+          </a:xfrm>
+          <a:prstGeom prst="roundRect">
+            <a:avLst>
+              <a:gd name="adj" fmla="val 12000"/>
+            </a:avLst>
+          </a:prstGeom>
+          <a:solidFill>
+            <a:srgbClr val="FFF7E0"/>
+          </a:solidFill>
+          <a:ln w="12700">
+            <a:solidFill>
+              <a:srgbClr val="C9A227"/>
+            </a:solidFill>
+            <a:prstDash val="solid"/>
+          </a:ln>
+        </p:spPr>
+      </p:sp>
+      <p:sp>
+        <p:nvSpPr>
+          <p:cNvPr id="72" name="Text 70"/>
+          <p:cNvSpPr txBox="1"/>
+          <p:nvPr/>
+        </p:nvSpPr>
+        <p:spPr>
+          <a:xfrm>
+            <a:off x="5248656" y="5687568"/>
+            <a:ext cx="2286000" cy="457200"/>
+          </a:xfrm>
+          <a:prstGeom prst="rect">
+            <a:avLst/>
+          </a:prstGeom>
+          <a:noFill/>
+          <a:ln/>
+        </p:spPr>
+        <p:txBody>
+          <a:bodyPr wrap="square" lIns="635" tIns="635" rIns="635" bIns="635" rtlCol="0" anchor="ctr"/>
+          <a:lstStyle/>
+          <a:p>
+            <a:pPr indent="0" marL="0">
+              <a:buNone/>
+            </a:pPr>
+            <a:r>
+              <a:rPr lang="en-US" sz="850" b="1" dirty="0">
+                <a:solidFill>
+                  <a:srgbClr val="7A5C00"/>
+                </a:solidFill>
+                <a:latin typeface="Calibri" pitchFamily="34" charset="0"/>
+                <a:ea typeface="Calibri" pitchFamily="34" charset="-122"/>
+                <a:cs typeface="Calibri" pitchFamily="34" charset="-120"/>
+              </a:rPr>
+              <a:t>Sprechzeiten Sekretariat</a:t>
+            </a:r>
+            <a:endParaRPr lang="en-US" sz="850" dirty="0"/>
+          </a:p>
+          <a:p>
+            <a:pPr indent="0" marL="0">
+              <a:buNone/>
+            </a:pPr>
+            <a:r>
+              <a:rPr lang="en-US" sz="700" dirty="0">
+                <a:solidFill>
+                  <a:srgbClr val="5C6B5C"/>
+                </a:solidFill>
+                <a:latin typeface="Calibri" pitchFamily="34" charset="0"/>
+                <a:ea typeface="Calibri" pitchFamily="34" charset="-122"/>
+                <a:cs typeface="Calibri" pitchFamily="34" charset="-120"/>
+              </a:rPr>
+              <a:t>Rückfragen Mo bis Fr 9.30 bis 11.30 Uhr</a:t>
+            </a:r>
+            <a:endParaRPr lang="en-US" sz="850" dirty="0"/>
+          </a:p>
+        </p:txBody>
+      </p:sp>
+      <p:sp>
+        <p:nvSpPr>
+          <p:cNvPr id="73" name="Shape 71"/>
+          <p:cNvSpPr/>
+          <p:nvPr/>
+        </p:nvSpPr>
+        <p:spPr>
+          <a:xfrm>
+            <a:off x="7644384" y="5687568"/>
+            <a:ext cx="2286000" cy="457200"/>
+          </a:xfrm>
+          <a:prstGeom prst="roundRect">
+            <a:avLst>
+              <a:gd name="adj" fmla="val 12000"/>
+            </a:avLst>
+          </a:prstGeom>
+          <a:solidFill>
+            <a:srgbClr val="FFFFFF"/>
+          </a:solidFill>
+          <a:ln w="12700">
+            <a:solidFill>
+              <a:srgbClr val="2C5F2D"/>
+            </a:solidFill>
+            <a:prstDash val="sysDot"/>
+          </a:ln>
+        </p:spPr>
+      </p:sp>
+      <p:sp>
+        <p:nvSpPr>
+          <p:cNvPr id="74" name="Text 72"/>
+          <p:cNvSpPr txBox="1"/>
+          <p:nvPr/>
+        </p:nvSpPr>
+        <p:spPr>
+          <a:xfrm>
+            <a:off x="7644384" y="5687568"/>
+            <a:ext cx="2286000" cy="457200"/>
+          </a:xfrm>
+          <a:prstGeom prst="rect">
+            <a:avLst/>
+          </a:prstGeom>
+          <a:noFill/>
+          <a:ln/>
+        </p:spPr>
+        <p:txBody>
+          <a:bodyPr wrap="square" lIns="635" tIns="635" rIns="635" bIns="635" rtlCol="0" anchor="ctr"/>
+          <a:lstStyle/>
+          <a:p>
+            <a:pPr indent="0" marL="0">
+              <a:buNone/>
+            </a:pPr>
+            <a:r>
+              <a:rPr lang="en-US" sz="850" b="1" dirty="0">
+                <a:solidFill>
+                  <a:srgbClr val="2C5F2D"/>
+                </a:solidFill>
+                <a:latin typeface="Calibri" pitchFamily="34" charset="0"/>
+                <a:ea typeface="Calibri" pitchFamily="34" charset="-122"/>
+                <a:cs typeface="Calibri" pitchFamily="34" charset="-120"/>
+              </a:rPr>
+              <a:t>Papierakte</a:t>
+            </a:r>
+            <a:endParaRPr lang="en-US" sz="850" dirty="0"/>
+          </a:p>
+          <a:p>
+            <a:pPr indent="0" marL="0">
+              <a:buNone/>
+            </a:pPr>
+            <a:r>
+              <a:rPr lang="en-US" sz="700" dirty="0">
+                <a:solidFill>
+                  <a:srgbClr val="5C6B5C"/>
+                </a:solidFill>
+                <a:latin typeface="Calibri" pitchFamily="34" charset="0"/>
+                <a:ea typeface="Calibri" pitchFamily="34" charset="-122"/>
+                <a:cs typeface="Calibri" pitchFamily="34" charset="-120"/>
+              </a:rPr>
+              <a:t>Formular wird abgeheftet, nicht an Studierende</a:t>
+            </a:r>
+            <a:endParaRPr lang="en-US" sz="850" dirty="0"/>
+          </a:p>
+        </p:txBody>
+      </p:sp>
+      <p:sp>
+        <p:nvSpPr>
+          <p:cNvPr id="75" name="Shape 73"/>
+          <p:cNvSpPr/>
+          <p:nvPr/>
+        </p:nvSpPr>
+        <p:spPr>
+          <a:xfrm>
+            <a:off x="10241280" y="896112"/>
+            <a:ext cx="1508760" cy="5248656"/>
+          </a:xfrm>
+          <a:prstGeom prst="roundRect">
+            <a:avLst>
+              <a:gd name="adj" fmla="val 12121"/>
+            </a:avLst>
+          </a:prstGeom>
+          <a:solidFill>
+            <a:srgbClr val="FFFFFF"/>
+          </a:solidFill>
+          <a:ln w="12700">
+            <a:solidFill>
+              <a:srgbClr val="9B3B2E"/>
+            </a:solidFill>
+            <a:prstDash val="sysDot"/>
+          </a:ln>
+        </p:spPr>
+      </p:sp>
+      <p:sp>
+        <p:nvSpPr>
+          <p:cNvPr id="76" name="Text 74"/>
+          <p:cNvSpPr txBox="1"/>
+          <p:nvPr/>
+        </p:nvSpPr>
+        <p:spPr>
+          <a:xfrm>
+            <a:off x="10332720" y="987552"/>
+            <a:ext cx="1325880" cy="548640"/>
+          </a:xfrm>
+          <a:prstGeom prst="rect">
+            <a:avLst/>
+          </a:prstGeom>
+          <a:noFill/>
+          <a:ln/>
+        </p:spPr>
+        <p:txBody>
+          <a:bodyPr wrap="square" lIns="0" tIns="0" rIns="0" bIns="0" rtlCol="0" anchor="t"/>
+          <a:lstStyle/>
+          <a:p>
+            <a:pPr indent="0" marL="0">
+              <a:buNone/>
+            </a:pPr>
+            <a:r>
+              <a:rPr lang="en-US" sz="950" b="1" dirty="0">
+                <a:solidFill>
+                  <a:srgbClr val="9B3B2E"/>
+                </a:solidFill>
+                <a:latin typeface="Calibri" pitchFamily="34" charset="0"/>
+                <a:ea typeface="Calibri" pitchFamily="34" charset="-122"/>
+                <a:cs typeface="Calibri" pitchFamily="34" charset="-120"/>
+              </a:rPr>
+              <a:t>Schwachstellen (Ist)</a:t>
+            </a:r>
+            <a:endParaRPr lang="en-US" sz="950" dirty="0"/>
+          </a:p>
+          <a:p>
+            <a:pPr indent="0" marL="0">
+              <a:buNone/>
+            </a:pPr>
+            <a:r>
+              <a:rPr lang="en-US" sz="700" dirty="0">
+                <a:solidFill>
+                  <a:srgbClr val="8A968A"/>
+                </a:solidFill>
+                <a:latin typeface="Calibri" pitchFamily="34" charset="0"/>
+                <a:ea typeface="Calibri" pitchFamily="34" charset="-122"/>
+                <a:cs typeface="Calibri" pitchFamily="34" charset="-120"/>
+              </a:rPr>
+              <a:t>Beobachtet aus Formular und THM-Seite</a:t>
+            </a:r>
+            <a:endParaRPr lang="en-US" sz="950" dirty="0"/>
+          </a:p>
+        </p:txBody>
+      </p:sp>
+      <p:sp>
+        <p:nvSpPr>
+          <p:cNvPr id="77" name="Shape 75"/>
+          <p:cNvSpPr/>
+          <p:nvPr/>
+        </p:nvSpPr>
+        <p:spPr>
+          <a:xfrm>
+            <a:off x="10332720" y="1627632"/>
+            <a:ext cx="1325880" cy="987552"/>
+          </a:xfrm>
+          <a:prstGeom prst="roundRect">
+            <a:avLst>
+              <a:gd name="adj" fmla="val 5556"/>
+            </a:avLst>
+          </a:prstGeom>
+          <a:solidFill>
+            <a:srgbClr val="FBF1EF"/>
+          </a:solidFill>
+          <a:ln w="9525">
+            <a:solidFill>
+              <a:srgbClr val="9B3B2E"/>
+            </a:solidFill>
+            <a:prstDash val="dash"/>
+          </a:ln>
+        </p:spPr>
+      </p:sp>
+      <p:sp>
+        <p:nvSpPr>
+          <p:cNvPr id="78" name="Text 76"/>
+          <p:cNvSpPr txBox="1"/>
+          <p:nvPr/>
+        </p:nvSpPr>
+        <p:spPr>
+          <a:xfrm>
+            <a:off x="10387584" y="1673352"/>
+            <a:ext cx="1216152" cy="914400"/>
+          </a:xfrm>
+          <a:prstGeom prst="rect">
+            <a:avLst/>
+          </a:prstGeom>
+          <a:noFill/>
+          <a:ln/>
+        </p:spPr>
+        <p:txBody>
+          <a:bodyPr wrap="square" lIns="0" tIns="0" rIns="0" bIns="0" rtlCol="0" anchor="t"/>
+          <a:lstStyle/>
+          <a:p>
+            <a:pPr indent="0" marL="0">
+              <a:lnSpc>
+                <a:spcPct val="105000"/>
+              </a:lnSpc>
+              <a:buNone/>
+            </a:pPr>
+            <a:r>
+              <a:rPr lang="en-US" sz="800" b="1" dirty="0">
+                <a:solidFill>
+                  <a:srgbClr val="9B3B2E"/>
+                </a:solidFill>
+                <a:latin typeface="Calibri" pitchFamily="34" charset="0"/>
+                <a:ea typeface="Calibri" pitchFamily="34" charset="-122"/>
+                <a:cs typeface="Calibri" pitchFamily="34" charset="-120"/>
+              </a:rPr>
+              <a:t>Medienbrüche</a:t>
+            </a:r>
+            <a:endParaRPr lang="en-US" sz="800" dirty="0"/>
+          </a:p>
+          <a:p>
+            <a:pPr indent="0" marL="0">
+              <a:lnSpc>
+                <a:spcPct val="105000"/>
+              </a:lnSpc>
+              <a:buNone/>
+            </a:pPr>
+            <a:r>
+              <a:rPr lang="en-US" sz="700" dirty="0">
+                <a:solidFill>
+                  <a:srgbClr val="5C6B5C"/>
+                </a:solidFill>
+                <a:latin typeface="Calibri" pitchFamily="34" charset="0"/>
+                <a:ea typeface="Calibri" pitchFamily="34" charset="-122"/>
+                <a:cs typeface="Calibri" pitchFamily="34" charset="-120"/>
+              </a:rPr>
+              <a:t>PDF ausfüllen, drucken, unterschreiben, scannen, mailen: sieben Übergaben pro Antrag.</a:t>
+            </a:r>
+            <a:endParaRPr lang="en-US" sz="800" dirty="0"/>
+          </a:p>
+        </p:txBody>
+      </p:sp>
+      <p:sp>
+        <p:nvSpPr>
+          <p:cNvPr id="79" name="Shape 77"/>
+          <p:cNvSpPr/>
+          <p:nvPr/>
+        </p:nvSpPr>
+        <p:spPr>
+          <a:xfrm>
+            <a:off x="10332720" y="2724912"/>
+            <a:ext cx="1325880" cy="987552"/>
+          </a:xfrm>
+          <a:prstGeom prst="roundRect">
+            <a:avLst>
+              <a:gd name="adj" fmla="val 5556"/>
+            </a:avLst>
+          </a:prstGeom>
+          <a:solidFill>
+            <a:srgbClr val="FBF1EF"/>
+          </a:solidFill>
+          <a:ln w="9525">
+            <a:solidFill>
+              <a:srgbClr val="9B3B2E"/>
+            </a:solidFill>
+            <a:prstDash val="dash"/>
+          </a:ln>
+        </p:spPr>
+      </p:sp>
+      <p:sp>
+        <p:nvSpPr>
+          <p:cNvPr id="80" name="Text 78"/>
+          <p:cNvSpPr txBox="1"/>
+          <p:nvPr/>
+        </p:nvSpPr>
+        <p:spPr>
+          <a:xfrm>
+            <a:off x="10387584" y="2770632"/>
+            <a:ext cx="1216152" cy="914400"/>
+          </a:xfrm>
+          <a:prstGeom prst="rect">
+            <a:avLst/>
+          </a:prstGeom>
+          <a:noFill/>
+          <a:ln/>
+        </p:spPr>
+        <p:txBody>
+          <a:bodyPr wrap="square" lIns="0" tIns="0" rIns="0" bIns="0" rtlCol="0" anchor="t"/>
+          <a:lstStyle/>
+          <a:p>
+            <a:pPr indent="0" marL="0">
+              <a:lnSpc>
+                <a:spcPct val="105000"/>
+              </a:lnSpc>
+              <a:buNone/>
+            </a:pPr>
+            <a:r>
+              <a:rPr lang="en-US" sz="800" b="1" dirty="0">
+                <a:solidFill>
+                  <a:srgbClr val="9B3B2E"/>
+                </a:solidFill>
+                <a:latin typeface="Calibri" pitchFamily="34" charset="0"/>
+                <a:ea typeface="Calibri" pitchFamily="34" charset="-122"/>
+                <a:cs typeface="Calibri" pitchFamily="34" charset="-120"/>
+              </a:rPr>
+              <a:t>Kein Status</a:t>
+            </a:r>
+            <a:endParaRPr lang="en-US" sz="800" dirty="0"/>
+          </a:p>
+          <a:p>
+            <a:pPr indent="0" marL="0">
+              <a:lnSpc>
+                <a:spcPct val="105000"/>
+              </a:lnSpc>
+              <a:buNone/>
+            </a:pPr>
+            <a:r>
+              <a:rPr lang="en-US" sz="700" dirty="0">
+                <a:solidFill>
+                  <a:srgbClr val="5C6B5C"/>
+                </a:solidFill>
+                <a:latin typeface="Calibri" pitchFamily="34" charset="0"/>
+                <a:ea typeface="Calibri" pitchFamily="34" charset="-122"/>
+                <a:cs typeface="Calibri" pitchFamily="34" charset="-120"/>
+              </a:rPr>
+              <a:t>Studierende erfahren erst in Schritt 7 vom Ergebnis; Nachfragen nur telefonisch.</a:t>
+            </a:r>
+            <a:endParaRPr lang="en-US" sz="800" dirty="0"/>
+          </a:p>
+        </p:txBody>
+      </p:sp>
+      <p:sp>
+        <p:nvSpPr>
+          <p:cNvPr id="81" name="Shape 79"/>
+          <p:cNvSpPr/>
+          <p:nvPr/>
+        </p:nvSpPr>
+        <p:spPr>
+          <a:xfrm>
+            <a:off x="10332720" y="3822192"/>
+            <a:ext cx="1325880" cy="987552"/>
+          </a:xfrm>
+          <a:prstGeom prst="roundRect">
+            <a:avLst>
+              <a:gd name="adj" fmla="val 5556"/>
+            </a:avLst>
+          </a:prstGeom>
+          <a:solidFill>
+            <a:srgbClr val="FBF1EF"/>
+          </a:solidFill>
+          <a:ln w="9525">
+            <a:solidFill>
+              <a:srgbClr val="9B3B2E"/>
+            </a:solidFill>
+            <a:prstDash val="dash"/>
+          </a:ln>
+        </p:spPr>
+      </p:sp>
+      <p:sp>
+        <p:nvSpPr>
+          <p:cNvPr id="82" name="Text 80"/>
+          <p:cNvSpPr txBox="1"/>
+          <p:nvPr/>
+        </p:nvSpPr>
+        <p:spPr>
+          <a:xfrm>
+            <a:off x="10387584" y="3867912"/>
+            <a:ext cx="1216152" cy="914400"/>
+          </a:xfrm>
+          <a:prstGeom prst="rect">
+            <a:avLst/>
+          </a:prstGeom>
+          <a:noFill/>
+          <a:ln/>
+        </p:spPr>
+        <p:txBody>
+          <a:bodyPr wrap="square" lIns="0" tIns="0" rIns="0" bIns="0" rtlCol="0" anchor="t"/>
+          <a:lstStyle/>
+          <a:p>
+            <a:pPr indent="0" marL="0">
+              <a:lnSpc>
+                <a:spcPct val="105000"/>
+              </a:lnSpc>
+              <a:buNone/>
+            </a:pPr>
+            <a:r>
+              <a:rPr lang="en-US" sz="800" b="1" dirty="0">
+                <a:solidFill>
+                  <a:srgbClr val="9B3B2E"/>
+                </a:solidFill>
+                <a:latin typeface="Calibri" pitchFamily="34" charset="0"/>
+                <a:ea typeface="Calibri" pitchFamily="34" charset="-122"/>
+                <a:cs typeface="Calibri" pitchFamily="34" charset="-120"/>
+              </a:rPr>
+              <a:t>Manuelle Prüfung</a:t>
+            </a:r>
+            <a:endParaRPr lang="en-US" sz="800" dirty="0"/>
+          </a:p>
+          <a:p>
+            <a:pPr indent="0" marL="0">
+              <a:lnSpc>
+                <a:spcPct val="105000"/>
+              </a:lnSpc>
+              <a:buNone/>
+            </a:pPr>
+            <a:r>
+              <a:rPr lang="en-US" sz="700" dirty="0">
+                <a:solidFill>
+                  <a:srgbClr val="5C6B5C"/>
+                </a:solidFill>
+                <a:latin typeface="Calibri" pitchFamily="34" charset="0"/>
+                <a:ea typeface="Calibri" pitchFamily="34" charset="-122"/>
+                <a:cs typeface="Calibri" pitchFamily="34" charset="-120"/>
+              </a:rPr>
+              <a:t>Zulassung, Qualifikation und Fristen prüft das Sekretariat von Hand (Schritte 3 und 6).</a:t>
+            </a:r>
+            <a:endParaRPr lang="en-US" sz="800" dirty="0"/>
+          </a:p>
+        </p:txBody>
+      </p:sp>
+      <p:sp>
+        <p:nvSpPr>
+          <p:cNvPr id="83" name="Shape 81"/>
+          <p:cNvSpPr/>
+          <p:nvPr/>
+        </p:nvSpPr>
+        <p:spPr>
+          <a:xfrm>
+            <a:off x="10332720" y="4919472"/>
+            <a:ext cx="1325880" cy="987552"/>
+          </a:xfrm>
+          <a:prstGeom prst="roundRect">
+            <a:avLst>
+              <a:gd name="adj" fmla="val 5556"/>
+            </a:avLst>
+          </a:prstGeom>
+          <a:solidFill>
+            <a:srgbClr val="FBF1EF"/>
+          </a:solidFill>
+          <a:ln w="9525">
+            <a:solidFill>
+              <a:srgbClr val="9B3B2E"/>
+            </a:solidFill>
+            <a:prstDash val="dash"/>
+          </a:ln>
+        </p:spPr>
+      </p:sp>
+      <p:sp>
+        <p:nvSpPr>
+          <p:cNvPr id="84" name="Text 82"/>
+          <p:cNvSpPr txBox="1"/>
+          <p:nvPr/>
+        </p:nvSpPr>
+        <p:spPr>
+          <a:xfrm>
+            <a:off x="10387584" y="4965192"/>
+            <a:ext cx="1216152" cy="914400"/>
+          </a:xfrm>
+          <a:prstGeom prst="rect">
+            <a:avLst/>
+          </a:prstGeom>
+          <a:noFill/>
+          <a:ln/>
+        </p:spPr>
+        <p:txBody>
+          <a:bodyPr wrap="square" lIns="0" tIns="0" rIns="0" bIns="0" rtlCol="0" anchor="t"/>
+          <a:lstStyle/>
+          <a:p>
+            <a:pPr indent="0" marL="0">
+              <a:lnSpc>
+                <a:spcPct val="105000"/>
+              </a:lnSpc>
+              <a:buNone/>
+            </a:pPr>
+            <a:r>
+              <a:rPr lang="en-US" sz="800" b="1" dirty="0">
+                <a:solidFill>
+                  <a:srgbClr val="9B3B2E"/>
+                </a:solidFill>
+                <a:latin typeface="Calibri" pitchFamily="34" charset="0"/>
+                <a:ea typeface="Calibri" pitchFamily="34" charset="-122"/>
+                <a:cs typeface="Calibri" pitchFamily="34" charset="-120"/>
+              </a:rPr>
+              <a:t>Externe ohne Zugang</a:t>
+            </a:r>
+            <a:endParaRPr lang="en-US" sz="800" dirty="0"/>
+          </a:p>
+          <a:p>
+            <a:pPr indent="0" marL="0">
+              <a:lnSpc>
+                <a:spcPct val="105000"/>
+              </a:lnSpc>
+              <a:buNone/>
+            </a:pPr>
+            <a:r>
+              <a:rPr lang="en-US" sz="700" dirty="0">
+                <a:solidFill>
+                  <a:srgbClr val="5C6B5C"/>
+                </a:solidFill>
+                <a:latin typeface="Calibri" pitchFamily="34" charset="0"/>
+                <a:ea typeface="Calibri" pitchFamily="34" charset="-122"/>
+                <a:cs typeface="Calibri" pitchFamily="34" charset="-120"/>
+              </a:rPr>
+              <a:t>Externe Korreferenten brauchen Zusatzformular, Post oder Scan (Schritt 2).</a:t>
+            </a:r>
+            <a:endParaRPr lang="en-US" sz="800" dirty="0"/>
+          </a:p>
+        </p:txBody>
+      </p:sp>
+      <p:sp>
+        <p:nvSpPr>
+          <p:cNvPr id="85" name="Shape 83"/>
+          <p:cNvSpPr/>
+          <p:nvPr/>
+        </p:nvSpPr>
+        <p:spPr>
+          <a:xfrm>
+            <a:off x="457200" y="6355080"/>
+            <a:ext cx="292608" cy="182880"/>
+          </a:xfrm>
+          <a:prstGeom prst="roundRect">
+            <a:avLst>
+              <a:gd name="adj" fmla="val 20000"/>
+            </a:avLst>
+          </a:prstGeom>
+          <a:solidFill>
+            <a:srgbClr val="EEF4E8"/>
+          </a:solidFill>
+          <a:ln w="12700">
+            <a:solidFill>
+              <a:srgbClr val="2C5F2D"/>
+            </a:solidFill>
+            <a:prstDash val="solid"/>
+          </a:ln>
+        </p:spPr>
+      </p:sp>
+      <p:sp>
+        <p:nvSpPr>
+          <p:cNvPr id="86" name="Text 84"/>
+          <p:cNvSpPr txBox="1"/>
+          <p:nvPr/>
+        </p:nvSpPr>
+        <p:spPr>
+          <a:xfrm>
+            <a:off x="804672" y="6309360"/>
+            <a:ext cx="1280160" cy="274320"/>
+          </a:xfrm>
+          <a:prstGeom prst="rect">
+            <a:avLst/>
+          </a:prstGeom>
+          <a:noFill/>
+          <a:ln/>
+        </p:spPr>
+        <p:txBody>
+          <a:bodyPr wrap="square" lIns="0" tIns="0" rIns="0" bIns="0" rtlCol="0" anchor="ctr"/>
+          <a:lstStyle/>
+          <a:p>
+            <a:pPr indent="0" marL="0">
+              <a:buNone/>
+            </a:pPr>
+            <a:r>
+              <a:rPr lang="en-US" sz="750" dirty="0">
+                <a:solidFill>
+                  <a:srgbClr val="5C6B5C"/>
+                </a:solidFill>
+                <a:latin typeface="Calibri" pitchFamily="34" charset="0"/>
+                <a:ea typeface="Calibri" pitchFamily="34" charset="-122"/>
+                <a:cs typeface="Calibri" pitchFamily="34" charset="-120"/>
+              </a:rPr>
+              <a:t>Person / Rolle</a:t>
+            </a:r>
+            <a:endParaRPr lang="en-US" sz="750" dirty="0"/>
+          </a:p>
+        </p:txBody>
+      </p:sp>
+      <p:sp>
+        <p:nvSpPr>
+          <p:cNvPr id="87" name="Shape 85"/>
+          <p:cNvSpPr/>
+          <p:nvPr/>
+        </p:nvSpPr>
+        <p:spPr>
+          <a:xfrm>
+            <a:off x="1737360" y="6355080"/>
+            <a:ext cx="292608" cy="182880"/>
+          </a:xfrm>
+          <a:prstGeom prst="roundRect">
+            <a:avLst>
+              <a:gd name="adj" fmla="val 20000"/>
+            </a:avLst>
+          </a:prstGeom>
+          <a:solidFill>
+            <a:srgbClr val="FFFFFF"/>
+          </a:solidFill>
+          <a:ln w="12700">
+            <a:solidFill>
+              <a:srgbClr val="8A968A"/>
+            </a:solidFill>
+            <a:prstDash val="dash"/>
+          </a:ln>
+        </p:spPr>
+      </p:sp>
+      <p:sp>
+        <p:nvSpPr>
+          <p:cNvPr id="88" name="Text 86"/>
+          <p:cNvSpPr txBox="1"/>
+          <p:nvPr/>
+        </p:nvSpPr>
+        <p:spPr>
+          <a:xfrm>
+            <a:off x="2084832" y="6309360"/>
+            <a:ext cx="1280160" cy="274320"/>
+          </a:xfrm>
+          <a:prstGeom prst="rect">
+            <a:avLst/>
+          </a:prstGeom>
+          <a:noFill/>
+          <a:ln/>
+        </p:spPr>
+        <p:txBody>
+          <a:bodyPr wrap="square" lIns="0" tIns="0" rIns="0" bIns="0" rtlCol="0" anchor="ctr"/>
+          <a:lstStyle/>
+          <a:p>
+            <a:pPr indent="0" marL="0">
+              <a:buNone/>
+            </a:pPr>
+            <a:r>
+              <a:rPr lang="en-US" sz="750" dirty="0">
+                <a:solidFill>
+                  <a:srgbClr val="5C6B5C"/>
+                </a:solidFill>
+                <a:latin typeface="Calibri" pitchFamily="34" charset="0"/>
+                <a:ea typeface="Calibri" pitchFamily="34" charset="-122"/>
+                <a:cs typeface="Calibri" pitchFamily="34" charset="-120"/>
+              </a:rPr>
+              <a:t>System im Betrieb</a:t>
+            </a:r>
+            <a:endParaRPr lang="en-US" sz="750" dirty="0"/>
+          </a:p>
+        </p:txBody>
+      </p:sp>
+      <p:sp>
+        <p:nvSpPr>
+          <p:cNvPr id="89" name="Shape 87"/>
+          <p:cNvSpPr/>
+          <p:nvPr/>
+        </p:nvSpPr>
+        <p:spPr>
+          <a:xfrm>
+            <a:off x="3108960" y="6355080"/>
+            <a:ext cx="292608" cy="182880"/>
+          </a:xfrm>
+          <a:prstGeom prst="roundRect">
+            <a:avLst>
+              <a:gd name="adj" fmla="val 20000"/>
+            </a:avLst>
+          </a:prstGeom>
+          <a:solidFill>
+            <a:srgbClr val="FFFFFF"/>
+          </a:solidFill>
+          <a:ln w="12700">
+            <a:solidFill>
+              <a:srgbClr val="2C5F2D"/>
+            </a:solidFill>
+            <a:prstDash val="sysDot"/>
+          </a:ln>
+        </p:spPr>
+      </p:sp>
+      <p:sp>
+        <p:nvSpPr>
+          <p:cNvPr id="90" name="Text 88"/>
+          <p:cNvSpPr txBox="1"/>
+          <p:nvPr/>
+        </p:nvSpPr>
+        <p:spPr>
+          <a:xfrm>
+            <a:off x="3456432" y="6309360"/>
+            <a:ext cx="1280160" cy="274320"/>
+          </a:xfrm>
+          <a:prstGeom prst="rect">
+            <a:avLst/>
+          </a:prstGeom>
+          <a:noFill/>
+          <a:ln/>
+        </p:spPr>
+        <p:txBody>
+          <a:bodyPr wrap="square" lIns="0" tIns="0" rIns="0" bIns="0" rtlCol="0" anchor="ctr"/>
+          <a:lstStyle/>
+          <a:p>
+            <a:pPr indent="0" marL="0">
+              <a:buNone/>
+            </a:pPr>
+            <a:r>
+              <a:rPr lang="en-US" sz="750" dirty="0">
+                <a:solidFill>
+                  <a:srgbClr val="5C6B5C"/>
+                </a:solidFill>
+                <a:latin typeface="Calibri" pitchFamily="34" charset="0"/>
+                <a:ea typeface="Calibri" pitchFamily="34" charset="-122"/>
+                <a:cs typeface="Calibri" pitchFamily="34" charset="-120"/>
+              </a:rPr>
+              <a:t>Dokument</a:t>
+            </a:r>
+            <a:endParaRPr lang="en-US" sz="750" dirty="0"/>
+          </a:p>
+        </p:txBody>
+      </p:sp>
+      <p:sp>
+        <p:nvSpPr>
+          <p:cNvPr id="91" name="Shape 89"/>
+          <p:cNvSpPr/>
+          <p:nvPr/>
+        </p:nvSpPr>
+        <p:spPr>
+          <a:xfrm>
+            <a:off x="4114800" y="6355080"/>
+            <a:ext cx="292608" cy="182880"/>
+          </a:xfrm>
+          <a:prstGeom prst="roundRect">
+            <a:avLst>
+              <a:gd name="adj" fmla="val 20000"/>
+            </a:avLst>
+          </a:prstGeom>
+          <a:solidFill>
+            <a:srgbClr val="FFF7E0"/>
+          </a:solidFill>
+          <a:ln w="12700">
+            <a:solidFill>
+              <a:srgbClr val="C9A227"/>
+            </a:solidFill>
+            <a:prstDash val="solid"/>
+          </a:ln>
+        </p:spPr>
+      </p:sp>
+      <p:sp>
+        <p:nvSpPr>
+          <p:cNvPr id="92" name="Text 90"/>
+          <p:cNvSpPr txBox="1"/>
+          <p:nvPr/>
+        </p:nvSpPr>
+        <p:spPr>
+          <a:xfrm>
+            <a:off x="4462272" y="6309360"/>
+            <a:ext cx="1280160" cy="274320"/>
+          </a:xfrm>
+          <a:prstGeom prst="rect">
+            <a:avLst/>
+          </a:prstGeom>
+          <a:noFill/>
+          <a:ln/>
+        </p:spPr>
+        <p:txBody>
+          <a:bodyPr wrap="square" lIns="0" tIns="0" rIns="0" bIns="0" rtlCol="0" anchor="ctr"/>
+          <a:lstStyle/>
+          <a:p>
+            <a:pPr indent="0" marL="0">
+              <a:buNone/>
+            </a:pPr>
+            <a:r>
+              <a:rPr lang="en-US" sz="750" dirty="0">
+                <a:solidFill>
+                  <a:srgbClr val="5C6B5C"/>
+                </a:solidFill>
+                <a:latin typeface="Calibri" pitchFamily="34" charset="0"/>
+                <a:ea typeface="Calibri" pitchFamily="34" charset="-122"/>
+                <a:cs typeface="Calibri" pitchFamily="34" charset="-120"/>
+              </a:rPr>
+              <a:t>Ereignis / Einschränkung</a:t>
+            </a:r>
+            <a:endParaRPr lang="en-US" sz="750" dirty="0"/>
+          </a:p>
+        </p:txBody>
+      </p:sp>
+      <p:sp>
+        <p:nvSpPr>
+          <p:cNvPr id="93" name="Shape 91"/>
+          <p:cNvSpPr/>
+          <p:nvPr/>
+        </p:nvSpPr>
+        <p:spPr>
+          <a:xfrm>
+            <a:off x="5669280" y="6446520"/>
+            <a:ext cx="365760" cy="914"/>
+          </a:xfrm>
+          <a:prstGeom prst="line">
+            <a:avLst/>
+          </a:prstGeom>
+          <a:noFill/>
+          <a:ln w="19050">
+            <a:solidFill>
+              <a:srgbClr val="2C5F2D"/>
+            </a:solidFill>
+            <a:prstDash val="solid"/>
+            <a:tailEnd type="triangle"/>
+          </a:ln>
+        </p:spPr>
+      </p:sp>
+      <p:sp>
+        <p:nvSpPr>
+          <p:cNvPr id="94" name="Text 92"/>
+          <p:cNvSpPr txBox="1"/>
+          <p:nvPr/>
+        </p:nvSpPr>
+        <p:spPr>
+          <a:xfrm>
+            <a:off x="6080760" y="6309360"/>
+            <a:ext cx="2011680" cy="274320"/>
+          </a:xfrm>
+          <a:prstGeom prst="rect">
+            <a:avLst/>
+          </a:prstGeom>
+          <a:noFill/>
+          <a:ln/>
+        </p:spPr>
+        <p:txBody>
+          <a:bodyPr wrap="square" lIns="0" tIns="0" rIns="0" bIns="0" rtlCol="0" anchor="ctr"/>
+          <a:lstStyle/>
+          <a:p>
+            <a:pPr indent="0" marL="0">
+              <a:buNone/>
+            </a:pPr>
+            <a:r>
+              <a:rPr lang="en-US" sz="750" dirty="0">
+                <a:solidFill>
+                  <a:srgbClr val="5C6B5C"/>
+                </a:solidFill>
+                <a:latin typeface="Calibri" pitchFamily="34" charset="0"/>
+                <a:ea typeface="Calibri" pitchFamily="34" charset="-122"/>
+                <a:cs typeface="Calibri" pitchFamily="34" charset="-120"/>
+              </a:rPr>
+              <a:t>Übergabe des Formulars, Schritte 1 bis 7</a:t>
+            </a:r>
+            <a:endParaRPr lang="en-US" sz="750" dirty="0"/>
+          </a:p>
+        </p:txBody>
+      </p:sp>
+      <p:sp>
+        <p:nvSpPr>
+          <p:cNvPr id="95" name="Shape 93"/>
+          <p:cNvSpPr/>
+          <p:nvPr/>
+        </p:nvSpPr>
+        <p:spPr>
+          <a:xfrm>
+            <a:off x="8138160" y="6446520"/>
+            <a:ext cx="365760" cy="914"/>
+          </a:xfrm>
+          <a:prstGeom prst="line">
+            <a:avLst/>
+          </a:prstGeom>
+          <a:noFill/>
+          <a:ln w="19050">
+            <a:solidFill>
+              <a:srgbClr val="C9A227"/>
+            </a:solidFill>
+            <a:prstDash val="dash"/>
+            <a:tailEnd type="triangle"/>
+          </a:ln>
+        </p:spPr>
+      </p:sp>
+      <p:sp>
+        <p:nvSpPr>
+          <p:cNvPr id="96" name="Text 94"/>
+          <p:cNvSpPr txBox="1"/>
+          <p:nvPr/>
+        </p:nvSpPr>
+        <p:spPr>
+          <a:xfrm>
+            <a:off x="8549640" y="6309360"/>
+            <a:ext cx="1188720" cy="274320"/>
+          </a:xfrm>
+          <a:prstGeom prst="rect">
+            <a:avLst/>
+          </a:prstGeom>
+          <a:noFill/>
+          <a:ln/>
+        </p:spPr>
+        <p:txBody>
+          <a:bodyPr wrap="square" lIns="0" tIns="0" rIns="0" bIns="0" rtlCol="0" anchor="ctr"/>
+          <a:lstStyle/>
+          <a:p>
+            <a:pPr indent="0" marL="0">
+              <a:buNone/>
+            </a:pPr>
+            <a:r>
+              <a:rPr lang="en-US" sz="750" dirty="0">
+                <a:solidFill>
+                  <a:srgbClr val="5C6B5C"/>
+                </a:solidFill>
+                <a:latin typeface="Calibri" pitchFamily="34" charset="0"/>
+                <a:ea typeface="Calibri" pitchFamily="34" charset="-122"/>
+                <a:cs typeface="Calibri" pitchFamily="34" charset="-120"/>
+              </a:rPr>
+              <a:t>Verlängerungsantrag</a:t>
+            </a:r>
+            <a:endParaRPr lang="en-US" sz="750" dirty="0"/>
+          </a:p>
+        </p:txBody>
+      </p:sp>
+      <p:sp>
+        <p:nvSpPr>
+          <p:cNvPr id="97" name="Text 95"/>
+          <p:cNvSpPr txBox="1"/>
+          <p:nvPr/>
+        </p:nvSpPr>
+        <p:spPr>
+          <a:xfrm>
+            <a:off x="9784080" y="6309360"/>
+            <a:ext cx="1965960" cy="274320"/>
+          </a:xfrm>
+          <a:prstGeom prst="rect">
+            <a:avLst/>
+          </a:prstGeom>
+          <a:noFill/>
+          <a:ln/>
+        </p:spPr>
+        <p:txBody>
+          <a:bodyPr wrap="square" lIns="0" tIns="0" rIns="0" bIns="0" rtlCol="0" anchor="ctr"/>
+          <a:lstStyle/>
+          <a:p>
+            <a:pPr algn="r" indent="0" marL="0">
+              <a:buNone/>
+            </a:pPr>
+            <a:r>
+              <a:rPr lang="en-US" sz="650" dirty="0">
+                <a:solidFill>
+                  <a:srgbClr val="8A968A"/>
+                </a:solidFill>
+                <a:latin typeface="Calibri" pitchFamily="34" charset="0"/>
+                <a:ea typeface="Calibri" pitchFamily="34" charset="-122"/>
+                <a:cs typeface="Calibri" pitchFamily="34" charset="-120"/>
+              </a:rPr>
+              <a:t>Quelle: Zulassungsantrag WS23/24, Hinweise zur Bearbeitung</a:t>
             </a:r>
             <a:endParaRPr lang="en-US" sz="650" dirty="0"/>
           </a:p>

</xml_diff>